<commit_message>
Update deck with actual experiment progress (18 slides)
Slide 8 now shows a real generated pack excerpt (v4 R3 recipe); slide 9
reflects the five concrete prompt strategies with measured token sizes;
slide 10 becomes the 4-stage validation status table; new slide 11
presents early findings (the two-construction-sites trap and working
ranking); rollout marks the spike in progress and the ask is narrowed
to finishing Duo validation. Speaker notes renumbered and updated.

Co-Authored-By: Claude Fable 5 <noreply@anthropic.com>
Claude-Session: https://claude.ai/code/session_01BzhS5vhV791L3z5LF6C3UY
</commit_message>
<xml_diff>
--- a/deck/claude2duo-context-packs.pptx
+++ b/deck/claude2duo-context-packs.pptx
@@ -22,6 +22,7 @@
     <p:sldId id="270" r:id="rId21"/>
     <p:sldId id="271" r:id="rId22"/>
     <p:sldId id="272" r:id="rId23"/>
+    <p:sldId id="273" r:id="rId24"/>
   </p:sldIdLst>
   <p:sldSz cx="12191695" cy="6858000" type="screen4x3"/>
   <p:notesSz cx="6858000" cy="9144000"/>
@@ -3428,7 +3429,7 @@
         </p:nvGraphicFramePr>
         <p:xfrm>
           <a:off x="548640" y="1691640"/>
-          <a:ext cx="11201399" cy="3108960"/>
+          <a:ext cx="11201398" cy="3291840"/>
         </p:xfrm>
         <a:graphic>
           <a:graphicData uri="http://schemas.openxmlformats.org/drawingml/2006/table">
@@ -3437,11 +3438,11 @@
                 <a:tableStyleId>{5C22544A-7EE6-4342-B048-85BDC9FD1C3A}</a:tableStyleId>
               </a:tblPr>
               <a:tblGrid>
-                <a:gridCol w="3121701"/>
-                <a:gridCol w="4039849"/>
-                <a:gridCol w="4039849"/>
+                <a:gridCol w="2387183"/>
+                <a:gridCol w="6059773"/>
+                <a:gridCol w="2754442"/>
               </a:tblGrid>
-              <a:tr h="518160">
+              <a:tr h="658368">
                 <a:tc>
                   <a:txBody>
                     <a:bodyPr/>
@@ -3454,7 +3455,7 @@
                           </a:solidFill>
                           <a:latin typeface="Calibri"/>
                         </a:rPr>
-                        <a:t>Test</a:t>
+                        <a:t>Stage</a:t>
                       </a:r>
                     </a:p>
                   </a:txBody>
@@ -3476,7 +3477,7 @@
                           </a:solidFill>
                           <a:latin typeface="Calibri"/>
                         </a:rPr>
-                        <a:t>GitLab Duo (IntelliJ / VS Code)</a:t>
+                        <a:t>What is tested</a:t>
                       </a:r>
                     </a:p>
                   </a:txBody>
@@ -3498,7 +3499,7 @@
                           </a:solidFill>
                           <a:latin typeface="Calibri"/>
                         </a:rPr>
-                        <a:t>Microsoft Copilot</a:t>
+                        <a:t>Status</a:t>
                       </a:r>
                     </a:p>
                   </a:txBody>
@@ -3509,7 +3510,7 @@
                   </a:tcPr>
                 </a:tc>
               </a:tr>
-              <a:tr h="518160">
+              <a:tr h="658368">
                 <a:tc>
                   <a:txBody>
                     <a:bodyPr/>
@@ -3522,7 +3523,7 @@
                           </a:solidFill>
                           <a:latin typeface="Calibri"/>
                         </a:rPr>
-                        <a:t>Pack loads in a fresh session</a:t>
+                        <a:t>1 · Objective checks</a:t>
                       </a:r>
                     </a:p>
                   </a:txBody>
@@ -3544,7 +3545,7 @@
                           </a:solidFill>
                           <a:latin typeface="Calibri"/>
                         </a:rPr>
-                        <a:t>Attach files, verify no truncation</a:t>
+                        <a:t>Size vs caps, secret/hostname hygiene, 30-symbol accuracy vs code, coverage, workflow file complete</a:t>
                       </a:r>
                     </a:p>
                   </a:txBody>
@@ -3566,7 +3567,7 @@
                           </a:solidFill>
                           <a:latin typeface="Calibri"/>
                         </a:rPr>
-                        <a:t>Attach files, verify no truncation</a:t>
+                        <a:t>DONE — all 5 variants pass</a:t>
                       </a:r>
                     </a:p>
                   </a:txBody>
@@ -3577,7 +3578,7 @@
                   </a:tcPr>
                 </a:tc>
               </a:tr>
-              <a:tr h="518160">
+              <a:tr h="658368">
                 <a:tc>
                   <a:txBody>
                     <a:bodyPr/>
@@ -3590,7 +3591,7 @@
                           </a:solidFill>
                           <a:latin typeface="Calibri"/>
                         </a:rPr>
-                        <a:t>Q&amp;A: service-specific questions</a:t>
+                        <a:t>2 · Duo Q&amp;A</a:t>
                       </a:r>
                     </a:p>
                   </a:txBody>
@@ -3612,7 +3613,7 @@
                           </a:solidFill>
                           <a:latin typeface="Calibri"/>
                         </a:rPr>
-                        <a:t>Answers cite real endpoints / entities</a:t>
+                        <a:t>Fixed 8-question set per pack in fresh Duo sessions; answers must cite real classes (0–2 each)</a:t>
                       </a:r>
                     </a:p>
                   </a:txBody>
@@ -3634,7 +3635,7 @@
                           </a:solidFill>
                           <a:latin typeface="Calibri"/>
                         </a:rPr>
-                        <a:t>Answers cite real endpoints / entities</a:t>
+                        <a:t>Next — protocol ready</a:t>
                       </a:r>
                     </a:p>
                   </a:txBody>
@@ -3645,7 +3646,7 @@
                   </a:tcPr>
                 </a:tc>
               </a:tr>
-              <a:tr h="518160">
+              <a:tr h="658368">
                 <a:tc>
                   <a:txBody>
                     <a:bodyPr/>
@@ -3658,7 +3659,7 @@
                           </a:solidFill>
                           <a:latin typeface="Calibri"/>
                         </a:rPr>
-                        <a:t>Plan template: small change</a:t>
+                        <a:t>3 · Duo agentic workflow</a:t>
                       </a:r>
                     </a:p>
                   </a:txBody>
@@ -3680,7 +3681,7 @@
                           </a:solidFill>
                           <a:latin typeface="Calibri"/>
                         </a:rPr>
-                        <a:t>Produces correct filled-in plan</a:t>
+                        <a:t>Same feature request per pack: plan-only first, refusal before APPROVED, step-wise code, error handling (9 gates)</a:t>
                       </a:r>
                     </a:p>
                   </a:txBody>
@@ -3702,7 +3703,7 @@
                           </a:solidFill>
                           <a:latin typeface="Calibri"/>
                         </a:rPr>
-                        <a:t>Produces correct filled-in plan</a:t>
+                        <a:t>Next — protocol ready</a:t>
                       </a:r>
                     </a:p>
                   </a:txBody>
@@ -3713,7 +3714,7 @@
                   </a:tcPr>
                 </a:tc>
               </a:tr>
-              <a:tr h="518160">
+              <a:tr h="658368">
                 <a:tc>
                   <a:txBody>
                     <a:bodyPr/>
@@ -3726,7 +3727,7 @@
                           </a:solidFill>
                           <a:latin typeface="Calibri"/>
                         </a:rPr>
-                        <a:t>Plan template: new feature</a:t>
+                        <a:t>4 · Decision</a:t>
                       </a:r>
                     </a:p>
                   </a:txBody>
@@ -3748,7 +3749,7 @@
                           </a:solidFill>
                           <a:latin typeface="Calibri"/>
                         </a:rPr>
-                        <a:t>Plan judged usable by service dev</a:t>
+                        <a:t>Weighted score (workflow 40%, Q&amp;A 30%, objective 20%, practicality 10%) picks the winner; hybrid prompt built from best parts</a:t>
                       </a:r>
                     </a:p>
                   </a:txBody>
@@ -3770,75 +3771,7 @@
                           </a:solidFill>
                           <a:latin typeface="Calibri"/>
                         </a:rPr>
-                        <a:t>Plan judged usable by service dev</a:t>
-                      </a:r>
-                    </a:p>
-                  </a:txBody>
-                  <a:tcPr marL="73152" marR="73152" marT="36576" marB="36576">
-                    <a:solidFill>
-                      <a:srgbClr val="FFFFFF"/>
-                    </a:solidFill>
-                  </a:tcPr>
-                </a:tc>
-              </a:tr>
-              <a:tr h="518160">
-                <a:tc>
-                  <a:txBody>
-                    <a:bodyPr/>
-                    <a:lstStyle/>
-                    <a:p>
-                      <a:r>
-                        <a:rPr b="1" sz="1200">
-                          <a:solidFill>
-                            <a:srgbClr val="1F2933"/>
-                          </a:solidFill>
-                          <a:latin typeface="Calibri"/>
-                        </a:rPr>
-                        <a:t>Context headroom</a:t>
-                      </a:r>
-                    </a:p>
-                  </a:txBody>
-                  <a:tcPr marL="73152" marR="73152" marT="36576" marB="36576">
-                    <a:solidFill>
-                      <a:srgbClr val="FFFFFF"/>
-                    </a:solidFill>
-                  </a:tcPr>
-                </a:tc>
-                <a:tc>
-                  <a:txBody>
-                    <a:bodyPr/>
-                    <a:lstStyle/>
-                    <a:p>
-                      <a:r>
-                        <a:rPr sz="1200">
-                          <a:solidFill>
-                            <a:srgbClr val="1F2933"/>
-                          </a:solidFill>
-                          <a:latin typeface="Calibri"/>
-                        </a:rPr>
-                        <a:t>Meaningful conversation still possible after attach</a:t>
-                      </a:r>
-                    </a:p>
-                  </a:txBody>
-                  <a:tcPr marL="73152" marR="73152" marT="36576" marB="36576">
-                    <a:solidFill>
-                      <a:srgbClr val="FFFFFF"/>
-                    </a:solidFill>
-                  </a:tcPr>
-                </a:tc>
-                <a:tc>
-                  <a:txBody>
-                    <a:bodyPr/>
-                    <a:lstStyle/>
-                    <a:p>
-                      <a:r>
-                        <a:rPr sz="1200">
-                          <a:solidFill>
-                            <a:srgbClr val="1F2933"/>
-                          </a:solidFill>
-                          <a:latin typeface="Calibri"/>
-                        </a:rPr>
-                        <a:t>Meaningful conversation still possible after attach</a:t>
+                        <a:t>After Duo runs</a:t>
                       </a:r>
                     </a:p>
                   </a:txBody>
@@ -3861,8 +3794,8 @@
         </p:nvSpPr>
         <p:spPr>
           <a:xfrm>
-            <a:off x="548640" y="5074920"/>
-            <a:ext cx="11201400" cy="1234440"/>
+            <a:off x="548640" y="5257800"/>
+            <a:ext cx="11201400" cy="1051560"/>
           </a:xfrm>
           <a:prstGeom prst="roundRect">
             <a:avLst>
@@ -3903,7 +3836,7 @@
                 </a:solidFill>
                 <a:latin typeface="Calibri"/>
               </a:rPr>
-              <a:t>Acceptance bar: </a:t>
+              <a:t>Everything is scripted and repeatable: </a:t>
             </a:r>
             <a:r>
               <a:rPr sz="1400" b="0">
@@ -3912,7 +3845,7 @@
                 </a:solidFill>
                 <a:latin typeface="Calibri"/>
               </a:rPr>
-              <a:t>every cell green on the pilot service before we scale out. Failures feed back into the prompt-refinement loop (e.g. split files that are too large, add missing sections).</a:t>
+              <a:t>scoring rubric + scoresheet are in the repo, and Duo Q&amp;A runs can optionally be automated via GitLab's aiAction API from inside our network.</a:t>
             </a:r>
           </a:p>
         </p:txBody>
@@ -4043,7 +3976,7 @@
                 </a:solidFill>
                 <a:latin typeface="Calibri"/>
               </a:rPr>
-              <a:t>MAKING IT WORK</a:t>
+              <a:t>VALIDATION TESTING</a:t>
             </a:r>
           </a:p>
           <a:p>
@@ -4055,7 +3988,7 @@
                 </a:solidFill>
                 <a:latin typeface="Calibri"/>
               </a:rPr>
-              <a:t>Keeping packs fresh (and cheap to keep fresh)</a:t>
+              <a:t>Early findings from the experiment</a:t>
             </a:r>
           </a:p>
         </p:txBody>
@@ -4068,8 +4001,8 @@
         </p:nvSpPr>
         <p:spPr>
           <a:xfrm>
-            <a:off x="548640" y="1691640"/>
-            <a:ext cx="11201400" cy="1005840"/>
+            <a:off x="548640" y="1645920"/>
+            <a:ext cx="11201400" cy="2286000"/>
           </a:xfrm>
           <a:prstGeom prst="roundRect">
             <a:avLst>
@@ -4077,11 +4010,11 @@
             </a:avLst>
           </a:prstGeom>
           <a:solidFill>
-            <a:srgbClr val="F4F7FA"/>
+            <a:srgbClr val="FFFFFF"/>
           </a:solidFill>
           <a:ln w="15875">
             <a:solidFill>
-              <a:srgbClr val="0E63B0"/>
+              <a:srgbClr val="1E7A45"/>
             </a:solidFill>
           </a:ln>
           <a:effectLst/>
@@ -4101,8 +4034,44 @@
           </a:fontRef>
         </p:style>
         <p:txBody>
-          <a:bodyPr rtlCol="0" anchor="ctr" lIns="164592" rIns="164592" tIns="109728" bIns="109728" wrap="square"/>
-          <a:lstStyle/>
+          <a:bodyPr rtlCol="0" anchor="t" lIns="164592" rIns="164592" tIns="109728" bIns="109728" wrap="square"/>
+          <a:lstStyle/>
+          <a:p>
+            <a:pPr algn="l"/>
+            <a:r>
+              <a:rPr sz="1600" b="1">
+                <a:solidFill>
+                  <a:srgbClr val="1E7A45"/>
+                </a:solidFill>
+                <a:latin typeface="Calibri"/>
+              </a:rPr>
+              <a:t>The planted trap worked — and separated the strategies</a:t>
+            </a:r>
+          </a:p>
+          <a:p>
+            <a:pPr algn="l"/>
+            <a:r>
+              <a:rPr sz="1350" b="0">
+                <a:solidFill>
+                  <a:srgbClr val="1F2933"/>
+                </a:solidFill>
+                <a:latin typeface="Calibri"/>
+              </a:rPr>
+              <a:t>The sample service constructs its Transfer entity in TWO code paths; a change plan that misses one silently loses data. Only the task-cookbook pack surfaced this on its own, and the self-critique prompt caught it by testing its own output (4 real defects found and patched). Reference-style packs documented what exists — but not what a change touches.</a:t>
+            </a:r>
+          </a:p>
+          <a:p>
+            <a:pPr algn="l"/>
+            <a:r>
+              <a:rPr sz="400" b="0">
+                <a:solidFill>
+                  <a:srgbClr val="1F2933"/>
+                </a:solidFill>
+                <a:latin typeface="Calibri"/>
+              </a:rPr>
+              <a:t/>
+            </a:r>
+          </a:p>
           <a:p>
             <a:pPr algn="l"/>
             <a:r>
@@ -4112,16 +4081,7 @@
                 </a:solidFill>
                 <a:latin typeface="Calibri"/>
               </a:rPr>
-              <a:t>Regeneration is one command — </a:t>
-            </a:r>
-            <a:r>
-              <a:rPr sz="1350" b="0">
-                <a:solidFill>
-                  <a:srgbClr val="1F2933"/>
-                </a:solidFill>
-                <a:latin typeface="Calibri"/>
-              </a:rPr>
-              <a:t>Packs are generated, not hand-written. Refreshing a service is re-running the winning prompt — minutes, not days.</a:t>
+              <a:t>Lesson: packs must encode change recipes and be self-tested, not just describe the code.</a:t>
             </a:r>
           </a:p>
         </p:txBody>
@@ -4134,8 +4094,8 @@
         </p:nvSpPr>
         <p:spPr>
           <a:xfrm>
-            <a:off x="548640" y="2862072"/>
-            <a:ext cx="11201400" cy="1005840"/>
+            <a:off x="548640" y="4160520"/>
+            <a:ext cx="5486400" cy="2148840"/>
           </a:xfrm>
           <a:prstGeom prst="roundRect">
             <a:avLst>
@@ -4145,10 +4105,8 @@
           <a:solidFill>
             <a:srgbClr val="F4F7FA"/>
           </a:solidFill>
-          <a:ln w="15875">
-            <a:solidFill>
-              <a:srgbClr val="0E63B0"/>
-            </a:solidFill>
+          <a:ln>
+            <a:noFill/>
           </a:ln>
           <a:effectLst/>
         </p:spPr>
@@ -4167,7 +4125,7 @@
           </a:fontRef>
         </p:style>
         <p:txBody>
-          <a:bodyPr rtlCol="0" anchor="ctr" lIns="164592" rIns="164592" tIns="109728" bIns="109728" wrap="square"/>
+          <a:bodyPr rtlCol="0" anchor="t" lIns="164592" rIns="164592" tIns="109728" bIns="109728" wrap="square"/>
           <a:lstStyle/>
           <a:p>
             <a:pPr algn="l"/>
@@ -4178,16 +4136,67 @@
                 </a:solidFill>
                 <a:latin typeface="Calibri"/>
               </a:rPr>
-              <a:t>Cadence — </a:t>
-            </a:r>
-            <a:r>
-              <a:rPr sz="1350" b="0">
+              <a:t>Working ranking (pre-Duo)</a:t>
+            </a:r>
+          </a:p>
+          <a:p>
+            <a:pPr algn="l"/>
+            <a:r>
+              <a:rPr sz="1250" b="0">
                 <a:solidFill>
                   <a:srgbClr val="1F2933"/>
                 </a:solidFill>
                 <a:latin typeface="Calibri"/>
               </a:rPr>
-              <a:t>Regenerate once per PI as a routine enabler task, plus ad-hoc after significant merges to a service.</a:t>
+              <a:t>1. Task cookbook — best change support per token</a:t>
+            </a:r>
+          </a:p>
+          <a:p>
+            <a:pPr algn="l"/>
+            <a:r>
+              <a:rPr sz="1250" b="0">
+                <a:solidFill>
+                  <a:srgbClr val="1F2933"/>
+                </a:solidFill>
+                <a:latin typeface="Calibri"/>
+              </a:rPr>
+              <a:t>2. Self-critique — most complete, biggest pack</a:t>
+            </a:r>
+          </a:p>
+          <a:p>
+            <a:pPr algn="l"/>
+            <a:r>
+              <a:rPr sz="1250" b="0">
+                <a:solidFill>
+                  <a:srgbClr val="1F2933"/>
+                </a:solidFill>
+                <a:latin typeface="Calibri"/>
+              </a:rPr>
+              <a:t>3. Compact — full facts at 1/4 the tokens</a:t>
+            </a:r>
+          </a:p>
+          <a:p>
+            <a:pPr algn="l"/>
+            <a:r>
+              <a:rPr sz="1250" b="0">
+                <a:solidFill>
+                  <a:srgbClr val="1F2933"/>
+                </a:solidFill>
+                <a:latin typeface="Calibri"/>
+              </a:rPr>
+              <a:t>4. Persona  5. Structured spec</a:t>
+            </a:r>
+          </a:p>
+          <a:p>
+            <a:pPr algn="l"/>
+            <a:r>
+              <a:rPr sz="1250" b="1">
+                <a:solidFill>
+                  <a:srgbClr val="5A6B7A"/>
+                </a:solidFill>
+                <a:latin typeface="Calibri"/>
+              </a:rPr>
+              <a:t>Duo sessions confirm or refute this.</a:t>
             </a:r>
           </a:p>
         </p:txBody>
@@ -4200,8 +4209,8 @@
         </p:nvSpPr>
         <p:spPr>
           <a:xfrm>
-            <a:off x="548640" y="4032504"/>
-            <a:ext cx="11201400" cy="1005840"/>
+            <a:off x="6263640" y="4160520"/>
+            <a:ext cx="5486400" cy="2148840"/>
           </a:xfrm>
           <a:prstGeom prst="roundRect">
             <a:avLst>
@@ -4211,10 +4220,8 @@
           <a:solidFill>
             <a:srgbClr val="F4F7FA"/>
           </a:solidFill>
-          <a:ln w="15875">
-            <a:solidFill>
-              <a:srgbClr val="0E63B0"/>
-            </a:solidFill>
+          <a:ln>
+            <a:noFill/>
           </a:ln>
           <a:effectLst/>
         </p:spPr>
@@ -4233,7 +4240,7 @@
           </a:fontRef>
         </p:style>
         <p:txBody>
-          <a:bodyPr rtlCol="0" anchor="ctr" lIns="164592" rIns="164592" tIns="109728" bIns="109728" wrap="square"/>
+          <a:bodyPr rtlCol="0" anchor="t" lIns="164592" rIns="164592" tIns="109728" bIns="109728" wrap="square"/>
           <a:lstStyle/>
           <a:p>
             <a:pPr algn="l"/>
@@ -4244,89 +4251,62 @@
                 </a:solidFill>
                 <a:latin typeface="Calibri"/>
               </a:rPr>
-              <a:t>Ownership — </a:t>
-            </a:r>
-            <a:r>
-              <a:rPr sz="1350" b="0">
+              <a:t>Also proven along the way</a:t>
+            </a:r>
+          </a:p>
+          <a:p>
+            <a:pPr algn="l"/>
+            <a:r>
+              <a:rPr sz="1250" b="0">
                 <a:solidFill>
                   <a:srgbClr val="1F2933"/>
                 </a:solidFill>
                 <a:latin typeface="Calibri"/>
               </a:rPr>
-              <a:t>The licensed Claude Code developers own generation; each service team spot-checks its own pack.</a:t>
-            </a:r>
-          </a:p>
-        </p:txBody>
-      </p:sp>
-      <p:sp>
-        <p:nvSpPr>
-          <p:cNvPr id="7" name="Rounded Rectangle 6"/>
-          <p:cNvSpPr/>
-          <p:nvPr/>
-        </p:nvSpPr>
-        <p:spPr>
-          <a:xfrm>
-            <a:off x="548640" y="5202936"/>
-            <a:ext cx="11201400" cy="1005840"/>
-          </a:xfrm>
-          <a:prstGeom prst="roundRect">
-            <a:avLst>
-              <a:gd name="adj" fmla="val 6000"/>
-            </a:avLst>
-          </a:prstGeom>
-          <a:solidFill>
-            <a:srgbClr val="F4F7FA"/>
-          </a:solidFill>
-          <a:ln w="15875">
-            <a:solidFill>
-              <a:srgbClr val="B45E12"/>
-            </a:solidFill>
-          </a:ln>
-          <a:effectLst/>
-        </p:spPr>
-        <p:style>
-          <a:lnRef idx="1">
-            <a:schemeClr val="accent1"/>
-          </a:lnRef>
-          <a:fillRef idx="3">
-            <a:schemeClr val="accent1"/>
-          </a:fillRef>
-          <a:effectRef idx="2">
-            <a:schemeClr val="accent1"/>
-          </a:effectRef>
-          <a:fontRef idx="minor">
-            <a:schemeClr val="lt1"/>
-          </a:fontRef>
-        </p:style>
-        <p:txBody>
-          <a:bodyPr rtlCol="0" anchor="ctr" lIns="164592" rIns="164592" tIns="109728" bIns="109728" wrap="square"/>
-          <a:lstStyle/>
-          <a:p>
-            <a:pPr algn="l"/>
-            <a:r>
-              <a:rPr sz="1400" b="1">
-                <a:solidFill>
-                  <a:srgbClr val="0A467E"/>
-                </a:solidFill>
-                <a:latin typeface="Calibri"/>
-              </a:rPr>
-              <a:t>Drift guardrails — </a:t>
-            </a:r>
-            <a:r>
-              <a:rPr sz="1350" b="0">
+              <a:t>• Packs honestly mark gaps (“UNKNOWN — verify with team”)</a:t>
+            </a:r>
+          </a:p>
+          <a:p>
+            <a:pPr algn="l"/>
+            <a:r>
+              <a:rPr sz="1250" b="0">
                 <a:solidFill>
                   <a:srgbClr val="1F2933"/>
                 </a:solidFill>
                 <a:latin typeface="Calibri"/>
               </a:rPr>
-              <a:t>Every pack carries a generated-on date + commit hash. Optional CI reminder when a service changes heavily since last generation.</a:t>
-            </a:r>
-          </a:p>
-        </p:txBody>
-      </p:sp>
-      <p:sp>
-        <p:nvSpPr>
-          <p:cNvPr id="8" name="TextBox 7"/>
+              <a:t>• Zero hallucinated classes across 30-symbol spot checks</a:t>
+            </a:r>
+          </a:p>
+          <a:p>
+            <a:pPr algn="l"/>
+            <a:r>
+              <a:rPr sz="1250" b="0">
+                <a:solidFill>
+                  <a:srgbClr val="1F2933"/>
+                </a:solidFill>
+                <a:latin typeface="Calibri"/>
+              </a:rPr>
+              <a:t>• Hygiene scans clean — no secrets/hostnames leak</a:t>
+            </a:r>
+          </a:p>
+          <a:p>
+            <a:pPr algn="l"/>
+            <a:r>
+              <a:rPr sz="1250" b="0">
+                <a:solidFill>
+                  <a:srgbClr val="1F2933"/>
+                </a:solidFill>
+                <a:latin typeface="Calibri"/>
+              </a:rPr>
+              <a:t>• Jira ticket template ready for licensed devs to reuse</a:t>
+            </a:r>
+          </a:p>
+        </p:txBody>
+      </p:sp>
+      <p:sp>
+        <p:nvSpPr>
+          <p:cNvPr id="7" name="TextBox 6"/>
           <p:cNvSpPr txBox="1"/>
           <p:nvPr/>
         </p:nvSpPr>
@@ -4462,7 +4442,7 @@
                 </a:solidFill>
                 <a:latin typeface="Calibri"/>
               </a:rPr>
-              <a:t>Security &amp; compliance posture</a:t>
+              <a:t>Keeping packs fresh (and cheap to keep fresh)</a:t>
             </a:r>
           </a:p>
         </p:txBody>
@@ -4488,7 +4468,7 @@
           </a:solidFill>
           <a:ln w="15875">
             <a:solidFill>
-              <a:srgbClr val="1E7A45"/>
+              <a:srgbClr val="0E63B0"/>
             </a:solidFill>
           </a:ln>
           <a:effectLst/>
@@ -4519,7 +4499,7 @@
                 </a:solidFill>
                 <a:latin typeface="Calibri"/>
               </a:rPr>
-              <a:t>No new data exposure — </a:t>
+              <a:t>Regeneration is one command — </a:t>
             </a:r>
             <a:r>
               <a:rPr sz="1350" b="0">
@@ -4528,7 +4508,7 @@
                 </a:solidFill>
                 <a:latin typeface="Calibri"/>
               </a:rPr>
-              <a:t>Packs describe code that Duo and Copilot can already access through their approved integrations. We change the form of the context, not its scope.</a:t>
+              <a:t>Packs are generated, not hand-written. Refreshing a service is re-running the winning prompt — minutes, not days.</a:t>
             </a:r>
           </a:p>
         </p:txBody>
@@ -4554,7 +4534,7 @@
           </a:solidFill>
           <a:ln w="15875">
             <a:solidFill>
-              <a:srgbClr val="1E7A45"/>
+              <a:srgbClr val="0E63B0"/>
             </a:solidFill>
           </a:ln>
           <a:effectLst/>
@@ -4585,7 +4565,7 @@
                 </a:solidFill>
                 <a:latin typeface="Calibri"/>
               </a:rPr>
-              <a:t>No new tools, no new licences — </a:t>
+              <a:t>Cadence — </a:t>
             </a:r>
             <a:r>
               <a:rPr sz="1350" b="0">
@@ -4594,7 +4574,7 @@
                 </a:solidFill>
                 <a:latin typeface="Calibri"/>
               </a:rPr>
-              <a:t>Everything runs on tooling that is already procured and security-approved: Claude Code for the few, Duo / Copilot for the many.</a:t>
+              <a:t>Regenerate once per PI as a routine enabler task, plus ad-hoc after significant merges to a service.</a:t>
             </a:r>
           </a:p>
         </p:txBody>
@@ -4620,7 +4600,7 @@
           </a:solidFill>
           <a:ln w="15875">
             <a:solidFill>
-              <a:srgbClr val="1E7A45"/>
+              <a:srgbClr val="0E63B0"/>
             </a:solidFill>
           </a:ln>
           <a:effectLst/>
@@ -4651,7 +4631,7 @@
                 </a:solidFill>
                 <a:latin typeface="Calibri"/>
               </a:rPr>
-              <a:t>Human in the loop by design — </a:t>
+              <a:t>Ownership — </a:t>
             </a:r>
             <a:r>
               <a:rPr sz="1350" b="0">
@@ -4660,7 +4640,7 @@
                 </a:solidFill>
                 <a:latin typeface="Calibri"/>
               </a:rPr>
-              <a:t>Chat AIs only produce plans and snippets; a developer applies every change manually and it goes through normal MR review.</a:t>
+              <a:t>The licensed Claude Code developers own generation; each service team spot-checks its own pack.</a:t>
             </a:r>
           </a:p>
         </p:txBody>
@@ -4717,7 +4697,7 @@
                 </a:solidFill>
                 <a:latin typeface="Calibri"/>
               </a:rPr>
-              <a:t>Content hygiene — </a:t>
+              <a:t>Drift guardrails — </a:t>
             </a:r>
             <a:r>
               <a:rPr sz="1350" b="0">
@@ -4726,7 +4706,7 @@
                 </a:solidFill>
                 <a:latin typeface="Calibri"/>
               </a:rPr>
-              <a:t>Generation prompts explicitly exclude secrets, credentials, internal hostnames and personal data; packs are reviewed before first commit.</a:t>
+              <a:t>Every pack carries a generated-on date + commit hash. Optional CI reminder when a service changes heavily since last generation.</a:t>
             </a:r>
           </a:p>
         </p:txBody>
@@ -4857,7 +4837,7 @@
                 </a:solidFill>
                 <a:latin typeface="Calibri"/>
               </a:rPr>
-              <a:t>BENEFITS</a:t>
+              <a:t>MAKING IT WORK</a:t>
             </a:r>
           </a:p>
           <a:p>
@@ -4869,7 +4849,7 @@
                 </a:solidFill>
                 <a:latin typeface="Calibri"/>
               </a:rPr>
-              <a:t>What we get</a:t>
+              <a:t>Security &amp; compliance posture</a:t>
             </a:r>
           </a:p>
         </p:txBody>
@@ -4882,8 +4862,8 @@
         </p:nvSpPr>
         <p:spPr>
           <a:xfrm>
-            <a:off x="548640" y="1783080"/>
-            <a:ext cx="3611880" cy="1874519"/>
+            <a:off x="548640" y="1691640"/>
+            <a:ext cx="11201400" cy="1005840"/>
           </a:xfrm>
           <a:prstGeom prst="roundRect">
             <a:avLst>
@@ -4893,8 +4873,10 @@
           <a:solidFill>
             <a:srgbClr val="F4F7FA"/>
           </a:solidFill>
-          <a:ln>
-            <a:noFill/>
+          <a:ln w="15875">
+            <a:solidFill>
+              <a:srgbClr val="1E7A45"/>
+            </a:solidFill>
           </a:ln>
           <a:effectLst/>
         </p:spPr>
@@ -4913,30 +4895,27 @@
           </a:fontRef>
         </p:style>
         <p:txBody>
-          <a:bodyPr rtlCol="0" anchor="t" lIns="164592" rIns="164592" tIns="109728" bIns="109728" wrap="square"/>
-          <a:lstStyle/>
-          <a:p>
-            <a:pPr algn="l"/>
-            <a:r>
-              <a:rPr sz="1500" b="1">
+          <a:bodyPr rtlCol="0" anchor="ctr" lIns="164592" rIns="164592" tIns="109728" bIns="109728" wrap="square"/>
+          <a:lstStyle/>
+          <a:p>
+            <a:pPr algn="l"/>
+            <a:r>
+              <a:rPr sz="1400" b="1">
                 <a:solidFill>
                   <a:srgbClr val="0A467E"/>
                 </a:solidFill>
                 <a:latin typeface="Calibri"/>
               </a:rPr>
-              <a:t>Whole-team uplift</a:t>
-            </a:r>
-          </a:p>
-          <a:p>
-            <a:pPr algn="l"/>
-            <a:r>
-              <a:rPr sz="1300" b="0">
+              <a:t>No new data exposure — </a:t>
+            </a:r>
+            <a:r>
+              <a:rPr sz="1350" b="0">
                 <a:solidFill>
                   <a:srgbClr val="1F2933"/>
                 </a:solidFill>
                 <a:latin typeface="Calibri"/>
               </a:rPr>
-              <a:t>Every developer gets near-agentic AI help from the licences we already pay for — no new seats needed.</a:t>
+              <a:t>Packs describe code that Duo and Copilot can already access through their approved integrations. We change the form of the context, not its scope.</a:t>
             </a:r>
           </a:p>
         </p:txBody>
@@ -4949,8 +4928,8 @@
         </p:nvSpPr>
         <p:spPr>
           <a:xfrm>
-            <a:off x="4343400" y="1783080"/>
-            <a:ext cx="3611880" cy="1874519"/>
+            <a:off x="548640" y="2862072"/>
+            <a:ext cx="11201400" cy="1005840"/>
           </a:xfrm>
           <a:prstGeom prst="roundRect">
             <a:avLst>
@@ -4960,8 +4939,10 @@
           <a:solidFill>
             <a:srgbClr val="F4F7FA"/>
           </a:solidFill>
-          <a:ln>
-            <a:noFill/>
+          <a:ln w="15875">
+            <a:solidFill>
+              <a:srgbClr val="1E7A45"/>
+            </a:solidFill>
           </a:ln>
           <a:effectLst/>
         </p:spPr>
@@ -4980,30 +4961,27 @@
           </a:fontRef>
         </p:style>
         <p:txBody>
-          <a:bodyPr rtlCol="0" anchor="t" lIns="164592" rIns="164592" tIns="109728" bIns="109728" wrap="square"/>
-          <a:lstStyle/>
-          <a:p>
-            <a:pPr algn="l"/>
-            <a:r>
-              <a:rPr sz="1500" b="1">
+          <a:bodyPr rtlCol="0" anchor="ctr" lIns="164592" rIns="164592" tIns="109728" bIns="109728" wrap="square"/>
+          <a:lstStyle/>
+          <a:p>
+            <a:pPr algn="l"/>
+            <a:r>
+              <a:rPr sz="1400" b="1">
                 <a:solidFill>
                   <a:srgbClr val="0A467E"/>
                 </a:solidFill>
                 <a:latin typeface="Calibri"/>
               </a:rPr>
-              <a:t>Faster onboarding</a:t>
-            </a:r>
-          </a:p>
-          <a:p>
-            <a:pPr algn="l"/>
-            <a:r>
-              <a:rPr sz="1300" b="0">
+              <a:t>No new tools, no new licences — </a:t>
+            </a:r>
+            <a:r>
+              <a:rPr sz="1350" b="0">
                 <a:solidFill>
                   <a:srgbClr val="1F2933"/>
                 </a:solidFill>
                 <a:latin typeface="Calibri"/>
               </a:rPr>
-              <a:t>New joiners read the pack (or chat with it) instead of spelunking for weeks.</a:t>
+              <a:t>Everything runs on tooling that is already procured and security-approved: Claude Code for the few, Duo / Copilot for the many.</a:t>
             </a:r>
           </a:p>
         </p:txBody>
@@ -5016,8 +4994,8 @@
         </p:nvSpPr>
         <p:spPr>
           <a:xfrm>
-            <a:off x="8138160" y="1783080"/>
-            <a:ext cx="3611880" cy="1874519"/>
+            <a:off x="548640" y="4032504"/>
+            <a:ext cx="11201400" cy="1005840"/>
           </a:xfrm>
           <a:prstGeom prst="roundRect">
             <a:avLst>
@@ -5027,8 +5005,10 @@
           <a:solidFill>
             <a:srgbClr val="F4F7FA"/>
           </a:solidFill>
-          <a:ln>
-            <a:noFill/>
+          <a:ln w="15875">
+            <a:solidFill>
+              <a:srgbClr val="1E7A45"/>
+            </a:solidFill>
           </a:ln>
           <a:effectLst/>
         </p:spPr>
@@ -5047,30 +5027,27 @@
           </a:fontRef>
         </p:style>
         <p:txBody>
-          <a:bodyPr rtlCol="0" anchor="t" lIns="164592" rIns="164592" tIns="109728" bIns="109728" wrap="square"/>
-          <a:lstStyle/>
-          <a:p>
-            <a:pPr algn="l"/>
-            <a:r>
-              <a:rPr sz="1500" b="1">
+          <a:bodyPr rtlCol="0" anchor="ctr" lIns="164592" rIns="164592" tIns="109728" bIns="109728" wrap="square"/>
+          <a:lstStyle/>
+          <a:p>
+            <a:pPr algn="l"/>
+            <a:r>
+              <a:rPr sz="1400" b="1">
                 <a:solidFill>
                   <a:srgbClr val="0A467E"/>
                 </a:solidFill>
                 <a:latin typeface="Calibri"/>
               </a:rPr>
-              <a:t>Living documentation</a:t>
-            </a:r>
-          </a:p>
-          <a:p>
-            <a:pPr algn="l"/>
-            <a:r>
-              <a:rPr sz="1300" b="0">
+              <a:t>Human in the loop by design — </a:t>
+            </a:r>
+            <a:r>
+              <a:rPr sz="1350" b="0">
                 <a:solidFill>
                   <a:srgbClr val="1F2933"/>
                 </a:solidFill>
                 <a:latin typeface="Calibri"/>
               </a:rPr>
-              <a:t>Regenerable, always-current service docs as a permanent side effect.</a:t>
+              <a:t>Chat AIs only produce plans and snippets; a developer applies every change manually and it goes through normal MR review.</a:t>
             </a:r>
           </a:p>
         </p:txBody>
@@ -5083,8 +5060,8 @@
         </p:nvSpPr>
         <p:spPr>
           <a:xfrm>
-            <a:off x="548640" y="3886200"/>
-            <a:ext cx="3611880" cy="1874519"/>
+            <a:off x="548640" y="5202936"/>
+            <a:ext cx="11201400" cy="1005840"/>
           </a:xfrm>
           <a:prstGeom prst="roundRect">
             <a:avLst>
@@ -5094,8 +5071,10 @@
           <a:solidFill>
             <a:srgbClr val="F4F7FA"/>
           </a:solidFill>
-          <a:ln>
-            <a:noFill/>
+          <a:ln w="15875">
+            <a:solidFill>
+              <a:srgbClr val="B45E12"/>
+            </a:solidFill>
           </a:ln>
           <a:effectLst/>
         </p:spPr>
@@ -5114,171 +5093,34 @@
           </a:fontRef>
         </p:style>
         <p:txBody>
-          <a:bodyPr rtlCol="0" anchor="t" lIns="164592" rIns="164592" tIns="109728" bIns="109728" wrap="square"/>
-          <a:lstStyle/>
-          <a:p>
-            <a:pPr algn="l"/>
-            <a:r>
-              <a:rPr sz="1500" b="1">
+          <a:bodyPr rtlCol="0" anchor="ctr" lIns="164592" rIns="164592" tIns="109728" bIns="109728" wrap="square"/>
+          <a:lstStyle/>
+          <a:p>
+            <a:pPr algn="l"/>
+            <a:r>
+              <a:rPr sz="1400" b="1">
                 <a:solidFill>
                   <a:srgbClr val="0A467E"/>
                 </a:solidFill>
                 <a:latin typeface="Calibri"/>
               </a:rPr>
-              <a:t>Better reviews</a:t>
-            </a:r>
-          </a:p>
-          <a:p>
-            <a:pPr algn="l"/>
-            <a:r>
-              <a:rPr sz="1300" b="0">
+              <a:t>Content hygiene — </a:t>
+            </a:r>
+            <a:r>
+              <a:rPr sz="1350" b="0">
                 <a:solidFill>
                   <a:srgbClr val="1F2933"/>
                 </a:solidFill>
                 <a:latin typeface="Calibri"/>
               </a:rPr>
-              <a:t>Standardised plans make AI-assisted changes predictable and easy to review.</a:t>
-            </a:r>
-          </a:p>
-        </p:txBody>
-      </p:sp>
-      <p:sp>
-        <p:nvSpPr>
-          <p:cNvPr id="8" name="Rounded Rectangle 7"/>
-          <p:cNvSpPr/>
-          <p:nvPr/>
-        </p:nvSpPr>
-        <p:spPr>
-          <a:xfrm>
-            <a:off x="4343400" y="3886200"/>
-            <a:ext cx="3611880" cy="1874519"/>
-          </a:xfrm>
-          <a:prstGeom prst="roundRect">
-            <a:avLst>
-              <a:gd name="adj" fmla="val 6000"/>
-            </a:avLst>
-          </a:prstGeom>
-          <a:solidFill>
-            <a:srgbClr val="F4F7FA"/>
-          </a:solidFill>
-          <a:ln>
-            <a:noFill/>
-          </a:ln>
-          <a:effectLst/>
-        </p:spPr>
-        <p:style>
-          <a:lnRef idx="1">
-            <a:schemeClr val="accent1"/>
-          </a:lnRef>
-          <a:fillRef idx="3">
-            <a:schemeClr val="accent1"/>
-          </a:fillRef>
-          <a:effectRef idx="2">
-            <a:schemeClr val="accent1"/>
-          </a:effectRef>
-          <a:fontRef idx="minor">
-            <a:schemeClr val="lt1"/>
-          </a:fontRef>
-        </p:style>
-        <p:txBody>
-          <a:bodyPr rtlCol="0" anchor="t" lIns="164592" rIns="164592" tIns="109728" bIns="109728" wrap="square"/>
-          <a:lstStyle/>
-          <a:p>
-            <a:pPr algn="l"/>
-            <a:r>
-              <a:rPr sz="1500" b="1">
-                <a:solidFill>
-                  <a:srgbClr val="0A467E"/>
-                </a:solidFill>
-                <a:latin typeface="Calibri"/>
-              </a:rPr>
-              <a:t>Compounding asset</a:t>
-            </a:r>
-          </a:p>
-          <a:p>
-            <a:pPr algn="l"/>
-            <a:r>
-              <a:rPr sz="1300" b="0">
-                <a:solidFill>
-                  <a:srgbClr val="1F2933"/>
-                </a:solidFill>
-                <a:latin typeface="Calibri"/>
-              </a:rPr>
-              <a:t>Prompts and templates improve every iteration and apply to every new service.</a:t>
-            </a:r>
-          </a:p>
-        </p:txBody>
-      </p:sp>
-      <p:sp>
-        <p:nvSpPr>
-          <p:cNvPr id="9" name="Rounded Rectangle 8"/>
-          <p:cNvSpPr/>
-          <p:nvPr/>
-        </p:nvSpPr>
-        <p:spPr>
-          <a:xfrm>
-            <a:off x="8138160" y="3886200"/>
-            <a:ext cx="3611880" cy="1874519"/>
-          </a:xfrm>
-          <a:prstGeom prst="roundRect">
-            <a:avLst>
-              <a:gd name="adj" fmla="val 6000"/>
-            </a:avLst>
-          </a:prstGeom>
-          <a:solidFill>
-            <a:srgbClr val="F4F7FA"/>
-          </a:solidFill>
-          <a:ln>
-            <a:noFill/>
-          </a:ln>
-          <a:effectLst/>
-        </p:spPr>
-        <p:style>
-          <a:lnRef idx="1">
-            <a:schemeClr val="accent1"/>
-          </a:lnRef>
-          <a:fillRef idx="3">
-            <a:schemeClr val="accent1"/>
-          </a:fillRef>
-          <a:effectRef idx="2">
-            <a:schemeClr val="accent1"/>
-          </a:effectRef>
-          <a:fontRef idx="minor">
-            <a:schemeClr val="lt1"/>
-          </a:fontRef>
-        </p:style>
-        <p:txBody>
-          <a:bodyPr rtlCol="0" anchor="t" lIns="164592" rIns="164592" tIns="109728" bIns="109728" wrap="square"/>
-          <a:lstStyle/>
-          <a:p>
-            <a:pPr algn="l"/>
-            <a:r>
-              <a:rPr sz="1500" b="1">
-                <a:solidFill>
-                  <a:srgbClr val="0A467E"/>
-                </a:solidFill>
-                <a:latin typeface="Calibri"/>
-              </a:rPr>
-              <a:t>Low cost to try</a:t>
-            </a:r>
-          </a:p>
-          <a:p>
-            <a:pPr algn="l"/>
-            <a:r>
-              <a:rPr sz="1300" b="0">
-                <a:solidFill>
-                  <a:srgbClr val="1F2933"/>
-                </a:solidFill>
-                <a:latin typeface="Calibri"/>
-              </a:rPr>
-              <a:t>A time-boxed spike by the licensed devs; no procurement, no platform work.</a:t>
-            </a:r>
-          </a:p>
-        </p:txBody>
-      </p:sp>
-      <p:sp>
-        <p:nvSpPr>
-          <p:cNvPr id="10" name="TextBox 9"/>
+              <a:t>Generation prompts explicitly exclude secrets, credentials, internal hostnames and personal data; packs are reviewed before first commit.</a:t>
+            </a:r>
+          </a:p>
+        </p:txBody>
+      </p:sp>
+      <p:sp>
+        <p:nvSpPr>
+          <p:cNvPr id="8" name="TextBox 7"/>
           <p:cNvSpPr txBox="1"/>
           <p:nvPr/>
         </p:nvSpPr>
@@ -5320,6 +5162,551 @@
 </file>
 
 <file path=ppt/slides/slide14.xml><?xml version="1.0" encoding="utf-8"?>
+<p:sld xmlns:a="http://schemas.openxmlformats.org/drawingml/2006/main" xmlns:p="http://schemas.openxmlformats.org/presentationml/2006/main" xmlns:r="http://schemas.openxmlformats.org/officeDocument/2006/relationships">
+  <p:cSld>
+    <p:spTree>
+      <p:nvGrpSpPr>
+        <p:cNvPr id="1" name=""/>
+        <p:cNvGrpSpPr/>
+        <p:nvPr/>
+      </p:nvGrpSpPr>
+      <p:grpSpPr/>
+      <p:sp>
+        <p:nvSpPr>
+          <p:cNvPr id="2" name="Rectangle 1"/>
+          <p:cNvSpPr/>
+          <p:nvPr/>
+        </p:nvSpPr>
+        <p:spPr>
+          <a:xfrm>
+            <a:off x="548640" y="502920"/>
+            <a:ext cx="502920" cy="82296"/>
+          </a:xfrm>
+          <a:prstGeom prst="rect">
+            <a:avLst/>
+          </a:prstGeom>
+          <a:solidFill>
+            <a:srgbClr val="0E63B0"/>
+          </a:solidFill>
+          <a:ln>
+            <a:noFill/>
+          </a:ln>
+        </p:spPr>
+        <p:style>
+          <a:lnRef idx="1">
+            <a:schemeClr val="accent1"/>
+          </a:lnRef>
+          <a:fillRef idx="3">
+            <a:schemeClr val="accent1"/>
+          </a:fillRef>
+          <a:effectRef idx="2">
+            <a:schemeClr val="accent1"/>
+          </a:effectRef>
+          <a:fontRef idx="minor">
+            <a:schemeClr val="lt1"/>
+          </a:fontRef>
+        </p:style>
+        <p:txBody>
+          <a:bodyPr rtlCol="0" anchor="ctr"/>
+          <a:lstStyle/>
+          <a:p>
+            <a:pPr algn="ctr"/>
+          </a:p>
+        </p:txBody>
+      </p:sp>
+      <p:sp>
+        <p:nvSpPr>
+          <p:cNvPr id="3" name="TextBox 2"/>
+          <p:cNvSpPr txBox="1"/>
+          <p:nvPr/>
+        </p:nvSpPr>
+        <p:spPr>
+          <a:xfrm>
+            <a:off x="548640" y="621792"/>
+            <a:ext cx="11064240" cy="914400"/>
+          </a:xfrm>
+          <a:prstGeom prst="rect">
+            <a:avLst/>
+          </a:prstGeom>
+          <a:noFill/>
+        </p:spPr>
+        <p:txBody>
+          <a:bodyPr wrap="square">
+            <a:spAutoFit/>
+          </a:bodyPr>
+          <a:lstStyle/>
+          <a:p>
+            <a:pPr algn="l"/>
+            <a:r>
+              <a:rPr sz="1200" b="1">
+                <a:solidFill>
+                  <a:srgbClr val="0E63B0"/>
+                </a:solidFill>
+                <a:latin typeface="Calibri"/>
+              </a:rPr>
+              <a:t>BENEFITS</a:t>
+            </a:r>
+          </a:p>
+          <a:p>
+            <a:pPr algn="l"/>
+            <a:r>
+              <a:rPr sz="3000" b="1">
+                <a:solidFill>
+                  <a:srgbClr val="1F2933"/>
+                </a:solidFill>
+                <a:latin typeface="Calibri"/>
+              </a:rPr>
+              <a:t>What we get</a:t>
+            </a:r>
+          </a:p>
+        </p:txBody>
+      </p:sp>
+      <p:sp>
+        <p:nvSpPr>
+          <p:cNvPr id="4" name="Rounded Rectangle 3"/>
+          <p:cNvSpPr/>
+          <p:nvPr/>
+        </p:nvSpPr>
+        <p:spPr>
+          <a:xfrm>
+            <a:off x="548640" y="1783080"/>
+            <a:ext cx="3611880" cy="1874519"/>
+          </a:xfrm>
+          <a:prstGeom prst="roundRect">
+            <a:avLst>
+              <a:gd name="adj" fmla="val 6000"/>
+            </a:avLst>
+          </a:prstGeom>
+          <a:solidFill>
+            <a:srgbClr val="F4F7FA"/>
+          </a:solidFill>
+          <a:ln>
+            <a:noFill/>
+          </a:ln>
+          <a:effectLst/>
+        </p:spPr>
+        <p:style>
+          <a:lnRef idx="1">
+            <a:schemeClr val="accent1"/>
+          </a:lnRef>
+          <a:fillRef idx="3">
+            <a:schemeClr val="accent1"/>
+          </a:fillRef>
+          <a:effectRef idx="2">
+            <a:schemeClr val="accent1"/>
+          </a:effectRef>
+          <a:fontRef idx="minor">
+            <a:schemeClr val="lt1"/>
+          </a:fontRef>
+        </p:style>
+        <p:txBody>
+          <a:bodyPr rtlCol="0" anchor="t" lIns="164592" rIns="164592" tIns="109728" bIns="109728" wrap="square"/>
+          <a:lstStyle/>
+          <a:p>
+            <a:pPr algn="l"/>
+            <a:r>
+              <a:rPr sz="1500" b="1">
+                <a:solidFill>
+                  <a:srgbClr val="0A467E"/>
+                </a:solidFill>
+                <a:latin typeface="Calibri"/>
+              </a:rPr>
+              <a:t>Whole-team uplift</a:t>
+            </a:r>
+          </a:p>
+          <a:p>
+            <a:pPr algn="l"/>
+            <a:r>
+              <a:rPr sz="1300" b="0">
+                <a:solidFill>
+                  <a:srgbClr val="1F2933"/>
+                </a:solidFill>
+                <a:latin typeface="Calibri"/>
+              </a:rPr>
+              <a:t>Every developer gets near-agentic AI help from the licences we already pay for — no new seats needed.</a:t>
+            </a:r>
+          </a:p>
+        </p:txBody>
+      </p:sp>
+      <p:sp>
+        <p:nvSpPr>
+          <p:cNvPr id="5" name="Rounded Rectangle 4"/>
+          <p:cNvSpPr/>
+          <p:nvPr/>
+        </p:nvSpPr>
+        <p:spPr>
+          <a:xfrm>
+            <a:off x="4343400" y="1783080"/>
+            <a:ext cx="3611880" cy="1874519"/>
+          </a:xfrm>
+          <a:prstGeom prst="roundRect">
+            <a:avLst>
+              <a:gd name="adj" fmla="val 6000"/>
+            </a:avLst>
+          </a:prstGeom>
+          <a:solidFill>
+            <a:srgbClr val="F4F7FA"/>
+          </a:solidFill>
+          <a:ln>
+            <a:noFill/>
+          </a:ln>
+          <a:effectLst/>
+        </p:spPr>
+        <p:style>
+          <a:lnRef idx="1">
+            <a:schemeClr val="accent1"/>
+          </a:lnRef>
+          <a:fillRef idx="3">
+            <a:schemeClr val="accent1"/>
+          </a:fillRef>
+          <a:effectRef idx="2">
+            <a:schemeClr val="accent1"/>
+          </a:effectRef>
+          <a:fontRef idx="minor">
+            <a:schemeClr val="lt1"/>
+          </a:fontRef>
+        </p:style>
+        <p:txBody>
+          <a:bodyPr rtlCol="0" anchor="t" lIns="164592" rIns="164592" tIns="109728" bIns="109728" wrap="square"/>
+          <a:lstStyle/>
+          <a:p>
+            <a:pPr algn="l"/>
+            <a:r>
+              <a:rPr sz="1500" b="1">
+                <a:solidFill>
+                  <a:srgbClr val="0A467E"/>
+                </a:solidFill>
+                <a:latin typeface="Calibri"/>
+              </a:rPr>
+              <a:t>Faster onboarding</a:t>
+            </a:r>
+          </a:p>
+          <a:p>
+            <a:pPr algn="l"/>
+            <a:r>
+              <a:rPr sz="1300" b="0">
+                <a:solidFill>
+                  <a:srgbClr val="1F2933"/>
+                </a:solidFill>
+                <a:latin typeface="Calibri"/>
+              </a:rPr>
+              <a:t>New joiners read the pack (or chat with it) instead of spelunking for weeks.</a:t>
+            </a:r>
+          </a:p>
+        </p:txBody>
+      </p:sp>
+      <p:sp>
+        <p:nvSpPr>
+          <p:cNvPr id="6" name="Rounded Rectangle 5"/>
+          <p:cNvSpPr/>
+          <p:nvPr/>
+        </p:nvSpPr>
+        <p:spPr>
+          <a:xfrm>
+            <a:off x="8138160" y="1783080"/>
+            <a:ext cx="3611880" cy="1874519"/>
+          </a:xfrm>
+          <a:prstGeom prst="roundRect">
+            <a:avLst>
+              <a:gd name="adj" fmla="val 6000"/>
+            </a:avLst>
+          </a:prstGeom>
+          <a:solidFill>
+            <a:srgbClr val="F4F7FA"/>
+          </a:solidFill>
+          <a:ln>
+            <a:noFill/>
+          </a:ln>
+          <a:effectLst/>
+        </p:spPr>
+        <p:style>
+          <a:lnRef idx="1">
+            <a:schemeClr val="accent1"/>
+          </a:lnRef>
+          <a:fillRef idx="3">
+            <a:schemeClr val="accent1"/>
+          </a:fillRef>
+          <a:effectRef idx="2">
+            <a:schemeClr val="accent1"/>
+          </a:effectRef>
+          <a:fontRef idx="minor">
+            <a:schemeClr val="lt1"/>
+          </a:fontRef>
+        </p:style>
+        <p:txBody>
+          <a:bodyPr rtlCol="0" anchor="t" lIns="164592" rIns="164592" tIns="109728" bIns="109728" wrap="square"/>
+          <a:lstStyle/>
+          <a:p>
+            <a:pPr algn="l"/>
+            <a:r>
+              <a:rPr sz="1500" b="1">
+                <a:solidFill>
+                  <a:srgbClr val="0A467E"/>
+                </a:solidFill>
+                <a:latin typeface="Calibri"/>
+              </a:rPr>
+              <a:t>Living documentation</a:t>
+            </a:r>
+          </a:p>
+          <a:p>
+            <a:pPr algn="l"/>
+            <a:r>
+              <a:rPr sz="1300" b="0">
+                <a:solidFill>
+                  <a:srgbClr val="1F2933"/>
+                </a:solidFill>
+                <a:latin typeface="Calibri"/>
+              </a:rPr>
+              <a:t>Regenerable, always-current service docs as a permanent side effect.</a:t>
+            </a:r>
+          </a:p>
+        </p:txBody>
+      </p:sp>
+      <p:sp>
+        <p:nvSpPr>
+          <p:cNvPr id="7" name="Rounded Rectangle 6"/>
+          <p:cNvSpPr/>
+          <p:nvPr/>
+        </p:nvSpPr>
+        <p:spPr>
+          <a:xfrm>
+            <a:off x="548640" y="3886200"/>
+            <a:ext cx="3611880" cy="1874519"/>
+          </a:xfrm>
+          <a:prstGeom prst="roundRect">
+            <a:avLst>
+              <a:gd name="adj" fmla="val 6000"/>
+            </a:avLst>
+          </a:prstGeom>
+          <a:solidFill>
+            <a:srgbClr val="F4F7FA"/>
+          </a:solidFill>
+          <a:ln>
+            <a:noFill/>
+          </a:ln>
+          <a:effectLst/>
+        </p:spPr>
+        <p:style>
+          <a:lnRef idx="1">
+            <a:schemeClr val="accent1"/>
+          </a:lnRef>
+          <a:fillRef idx="3">
+            <a:schemeClr val="accent1"/>
+          </a:fillRef>
+          <a:effectRef idx="2">
+            <a:schemeClr val="accent1"/>
+          </a:effectRef>
+          <a:fontRef idx="minor">
+            <a:schemeClr val="lt1"/>
+          </a:fontRef>
+        </p:style>
+        <p:txBody>
+          <a:bodyPr rtlCol="0" anchor="t" lIns="164592" rIns="164592" tIns="109728" bIns="109728" wrap="square"/>
+          <a:lstStyle/>
+          <a:p>
+            <a:pPr algn="l"/>
+            <a:r>
+              <a:rPr sz="1500" b="1">
+                <a:solidFill>
+                  <a:srgbClr val="0A467E"/>
+                </a:solidFill>
+                <a:latin typeface="Calibri"/>
+              </a:rPr>
+              <a:t>Better reviews</a:t>
+            </a:r>
+          </a:p>
+          <a:p>
+            <a:pPr algn="l"/>
+            <a:r>
+              <a:rPr sz="1300" b="0">
+                <a:solidFill>
+                  <a:srgbClr val="1F2933"/>
+                </a:solidFill>
+                <a:latin typeface="Calibri"/>
+              </a:rPr>
+              <a:t>Standardised plans make AI-assisted changes predictable and easy to review.</a:t>
+            </a:r>
+          </a:p>
+        </p:txBody>
+      </p:sp>
+      <p:sp>
+        <p:nvSpPr>
+          <p:cNvPr id="8" name="Rounded Rectangle 7"/>
+          <p:cNvSpPr/>
+          <p:nvPr/>
+        </p:nvSpPr>
+        <p:spPr>
+          <a:xfrm>
+            <a:off x="4343400" y="3886200"/>
+            <a:ext cx="3611880" cy="1874519"/>
+          </a:xfrm>
+          <a:prstGeom prst="roundRect">
+            <a:avLst>
+              <a:gd name="adj" fmla="val 6000"/>
+            </a:avLst>
+          </a:prstGeom>
+          <a:solidFill>
+            <a:srgbClr val="F4F7FA"/>
+          </a:solidFill>
+          <a:ln>
+            <a:noFill/>
+          </a:ln>
+          <a:effectLst/>
+        </p:spPr>
+        <p:style>
+          <a:lnRef idx="1">
+            <a:schemeClr val="accent1"/>
+          </a:lnRef>
+          <a:fillRef idx="3">
+            <a:schemeClr val="accent1"/>
+          </a:fillRef>
+          <a:effectRef idx="2">
+            <a:schemeClr val="accent1"/>
+          </a:effectRef>
+          <a:fontRef idx="minor">
+            <a:schemeClr val="lt1"/>
+          </a:fontRef>
+        </p:style>
+        <p:txBody>
+          <a:bodyPr rtlCol="0" anchor="t" lIns="164592" rIns="164592" tIns="109728" bIns="109728" wrap="square"/>
+          <a:lstStyle/>
+          <a:p>
+            <a:pPr algn="l"/>
+            <a:r>
+              <a:rPr sz="1500" b="1">
+                <a:solidFill>
+                  <a:srgbClr val="0A467E"/>
+                </a:solidFill>
+                <a:latin typeface="Calibri"/>
+              </a:rPr>
+              <a:t>Compounding asset</a:t>
+            </a:r>
+          </a:p>
+          <a:p>
+            <a:pPr algn="l"/>
+            <a:r>
+              <a:rPr sz="1300" b="0">
+                <a:solidFill>
+                  <a:srgbClr val="1F2933"/>
+                </a:solidFill>
+                <a:latin typeface="Calibri"/>
+              </a:rPr>
+              <a:t>Prompts and templates improve every iteration and apply to every new service.</a:t>
+            </a:r>
+          </a:p>
+        </p:txBody>
+      </p:sp>
+      <p:sp>
+        <p:nvSpPr>
+          <p:cNvPr id="9" name="Rounded Rectangle 8"/>
+          <p:cNvSpPr/>
+          <p:nvPr/>
+        </p:nvSpPr>
+        <p:spPr>
+          <a:xfrm>
+            <a:off x="8138160" y="3886200"/>
+            <a:ext cx="3611880" cy="1874519"/>
+          </a:xfrm>
+          <a:prstGeom prst="roundRect">
+            <a:avLst>
+              <a:gd name="adj" fmla="val 6000"/>
+            </a:avLst>
+          </a:prstGeom>
+          <a:solidFill>
+            <a:srgbClr val="F4F7FA"/>
+          </a:solidFill>
+          <a:ln>
+            <a:noFill/>
+          </a:ln>
+          <a:effectLst/>
+        </p:spPr>
+        <p:style>
+          <a:lnRef idx="1">
+            <a:schemeClr val="accent1"/>
+          </a:lnRef>
+          <a:fillRef idx="3">
+            <a:schemeClr val="accent1"/>
+          </a:fillRef>
+          <a:effectRef idx="2">
+            <a:schemeClr val="accent1"/>
+          </a:effectRef>
+          <a:fontRef idx="minor">
+            <a:schemeClr val="lt1"/>
+          </a:fontRef>
+        </p:style>
+        <p:txBody>
+          <a:bodyPr rtlCol="0" anchor="t" lIns="164592" rIns="164592" tIns="109728" bIns="109728" wrap="square"/>
+          <a:lstStyle/>
+          <a:p>
+            <a:pPr algn="l"/>
+            <a:r>
+              <a:rPr sz="1500" b="1">
+                <a:solidFill>
+                  <a:srgbClr val="0A467E"/>
+                </a:solidFill>
+                <a:latin typeface="Calibri"/>
+              </a:rPr>
+              <a:t>Low cost to try</a:t>
+            </a:r>
+          </a:p>
+          <a:p>
+            <a:pPr algn="l"/>
+            <a:r>
+              <a:rPr sz="1300" b="0">
+                <a:solidFill>
+                  <a:srgbClr val="1F2933"/>
+                </a:solidFill>
+                <a:latin typeface="Calibri"/>
+              </a:rPr>
+              <a:t>A time-boxed spike by the licensed devs; no procurement, no platform work.</a:t>
+            </a:r>
+          </a:p>
+        </p:txBody>
+      </p:sp>
+      <p:sp>
+        <p:nvSpPr>
+          <p:cNvPr id="10" name="TextBox 9"/>
+          <p:cNvSpPr txBox="1"/>
+          <p:nvPr/>
+        </p:nvSpPr>
+        <p:spPr>
+          <a:xfrm>
+            <a:off x="10881360" y="6446520"/>
+            <a:ext cx="1005840" cy="320040"/>
+          </a:xfrm>
+          <a:prstGeom prst="rect">
+            <a:avLst/>
+          </a:prstGeom>
+          <a:noFill/>
+        </p:spPr>
+        <p:txBody>
+          <a:bodyPr wrap="square">
+            <a:spAutoFit/>
+          </a:bodyPr>
+          <a:lstStyle/>
+          <a:p>
+            <a:pPr algn="r"/>
+            <a:r>
+              <a:rPr sz="1100" b="0">
+                <a:solidFill>
+                  <a:srgbClr val="5A6B7A"/>
+                </a:solidFill>
+                <a:latin typeface="Calibri"/>
+              </a:rPr>
+              <a:t>14</a:t>
+            </a:r>
+          </a:p>
+        </p:txBody>
+      </p:sp>
+    </p:spTree>
+  </p:cSld>
+  <p:clrMapOvr>
+    <a:masterClrMapping/>
+  </p:clrMapOvr>
+</p:sld>
+</file>
+
+<file path=ppt/slides/slide15.xml><?xml version="1.0" encoding="utf-8"?>
 <p:sld xmlns:a="http://schemas.openxmlformats.org/drawingml/2006/main" xmlns:p="http://schemas.openxmlformats.org/presentationml/2006/main" xmlns:r="http://schemas.openxmlformats.org/officeDocument/2006/relationships">
   <p:cSld>
     <p:spTree>
@@ -5751,660 +6138,6 @@
                 </a:solidFill>
                 <a:latin typeface="Calibri"/>
               </a:rPr>
-              <a:t>14</a:t>
-            </a:r>
-          </a:p>
-        </p:txBody>
-      </p:sp>
-    </p:spTree>
-  </p:cSld>
-  <p:clrMapOvr>
-    <a:masterClrMapping/>
-  </p:clrMapOvr>
-</p:sld>
-</file>
-
-<file path=ppt/slides/slide15.xml><?xml version="1.0" encoding="utf-8"?>
-<p:sld xmlns:a="http://schemas.openxmlformats.org/drawingml/2006/main" xmlns:p="http://schemas.openxmlformats.org/presentationml/2006/main" xmlns:r="http://schemas.openxmlformats.org/officeDocument/2006/relationships">
-  <p:cSld>
-    <p:spTree>
-      <p:nvGrpSpPr>
-        <p:cNvPr id="1" name=""/>
-        <p:cNvGrpSpPr/>
-        <p:nvPr/>
-      </p:nvGrpSpPr>
-      <p:grpSpPr/>
-      <p:sp>
-        <p:nvSpPr>
-          <p:cNvPr id="2" name="Rectangle 1"/>
-          <p:cNvSpPr/>
-          <p:nvPr/>
-        </p:nvSpPr>
-        <p:spPr>
-          <a:xfrm>
-            <a:off x="548640" y="502920"/>
-            <a:ext cx="502920" cy="82296"/>
-          </a:xfrm>
-          <a:prstGeom prst="rect">
-            <a:avLst/>
-          </a:prstGeom>
-          <a:solidFill>
-            <a:srgbClr val="0E63B0"/>
-          </a:solidFill>
-          <a:ln>
-            <a:noFill/>
-          </a:ln>
-        </p:spPr>
-        <p:style>
-          <a:lnRef idx="1">
-            <a:schemeClr val="accent1"/>
-          </a:lnRef>
-          <a:fillRef idx="3">
-            <a:schemeClr val="accent1"/>
-          </a:fillRef>
-          <a:effectRef idx="2">
-            <a:schemeClr val="accent1"/>
-          </a:effectRef>
-          <a:fontRef idx="minor">
-            <a:schemeClr val="lt1"/>
-          </a:fontRef>
-        </p:style>
-        <p:txBody>
-          <a:bodyPr rtlCol="0" anchor="ctr"/>
-          <a:lstStyle/>
-          <a:p>
-            <a:pPr algn="ctr"/>
-          </a:p>
-        </p:txBody>
-      </p:sp>
-      <p:sp>
-        <p:nvSpPr>
-          <p:cNvPr id="3" name="TextBox 2"/>
-          <p:cNvSpPr txBox="1"/>
-          <p:nvPr/>
-        </p:nvSpPr>
-        <p:spPr>
-          <a:xfrm>
-            <a:off x="548640" y="621792"/>
-            <a:ext cx="11064240" cy="914400"/>
-          </a:xfrm>
-          <a:prstGeom prst="rect">
-            <a:avLst/>
-          </a:prstGeom>
-          <a:noFill/>
-        </p:spPr>
-        <p:txBody>
-          <a:bodyPr wrap="square">
-            <a:spAutoFit/>
-          </a:bodyPr>
-          <a:lstStyle/>
-          <a:p>
-            <a:pPr algn="l"/>
-            <a:r>
-              <a:rPr sz="1200" b="1">
-                <a:solidFill>
-                  <a:srgbClr val="0E63B0"/>
-                </a:solidFill>
-                <a:latin typeface="Calibri"/>
-              </a:rPr>
-              <a:t>ROLLOUT PLAN</a:t>
-            </a:r>
-          </a:p>
-          <a:p>
-            <a:pPr algn="l"/>
-            <a:r>
-              <a:rPr sz="3000" b="1">
-                <a:solidFill>
-                  <a:srgbClr val="1F2933"/>
-                </a:solidFill>
-                <a:latin typeface="Calibri"/>
-              </a:rPr>
-              <a:t>Rollout, the SAFe way</a:t>
-            </a:r>
-          </a:p>
-        </p:txBody>
-      </p:sp>
-      <p:sp>
-        <p:nvSpPr>
-          <p:cNvPr id="4" name="Rounded Rectangle 3"/>
-          <p:cNvSpPr/>
-          <p:nvPr/>
-        </p:nvSpPr>
-        <p:spPr>
-          <a:xfrm>
-            <a:off x="548640" y="1783080"/>
-            <a:ext cx="2606040" cy="2377440"/>
-          </a:xfrm>
-          <a:prstGeom prst="roundRect">
-            <a:avLst>
-              <a:gd name="adj" fmla="val 6000"/>
-            </a:avLst>
-          </a:prstGeom>
-          <a:solidFill>
-            <a:srgbClr val="F4F7FA"/>
-          </a:solidFill>
-          <a:ln w="15875">
-            <a:solidFill>
-              <a:srgbClr val="0E63B0"/>
-            </a:solidFill>
-          </a:ln>
-          <a:effectLst/>
-        </p:spPr>
-        <p:style>
-          <a:lnRef idx="1">
-            <a:schemeClr val="accent1"/>
-          </a:lnRef>
-          <a:fillRef idx="3">
-            <a:schemeClr val="accent1"/>
-          </a:fillRef>
-          <a:effectRef idx="2">
-            <a:schemeClr val="accent1"/>
-          </a:effectRef>
-          <a:fontRef idx="minor">
-            <a:schemeClr val="lt1"/>
-          </a:fontRef>
-        </p:style>
-        <p:txBody>
-          <a:bodyPr rtlCol="0" anchor="t" lIns="164592" rIns="164592" tIns="109728" bIns="109728" wrap="square"/>
-          <a:lstStyle/>
-          <a:p>
-            <a:pPr algn="l"/>
-            <a:r>
-              <a:rPr sz="1400" b="1">
-                <a:solidFill>
-                  <a:srgbClr val="0E63B0"/>
-                </a:solidFill>
-                <a:latin typeface="Calibri"/>
-              </a:rPr>
-              <a:t>Spike — next iteration</a:t>
-            </a:r>
-          </a:p>
-          <a:p>
-            <a:pPr algn="l"/>
-            <a:r>
-              <a:rPr sz="1200" b="0">
-                <a:solidFill>
-                  <a:srgbClr val="1F2933"/>
-                </a:solidFill>
-                <a:latin typeface="Calibri"/>
-              </a:rPr>
-              <a:t>Prompt experiments on 1 pilot service; validate pack loads in Duo &amp; Copilot; pick winning prompts</a:t>
-            </a:r>
-          </a:p>
-        </p:txBody>
-      </p:sp>
-      <p:sp>
-        <p:nvSpPr>
-          <p:cNvPr id="5" name="Right Arrow 4"/>
-          <p:cNvSpPr/>
-          <p:nvPr/>
-        </p:nvSpPr>
-        <p:spPr>
-          <a:xfrm>
-            <a:off x="3154680" y="2834640"/>
-            <a:ext cx="320040" cy="256032"/>
-          </a:xfrm>
-          <a:prstGeom prst="rightArrow">
-            <a:avLst/>
-          </a:prstGeom>
-          <a:solidFill>
-            <a:srgbClr val="0E63B0"/>
-          </a:solidFill>
-          <a:ln>
-            <a:noFill/>
-          </a:ln>
-          <a:effectLst/>
-        </p:spPr>
-        <p:style>
-          <a:lnRef idx="1">
-            <a:schemeClr val="accent1"/>
-          </a:lnRef>
-          <a:fillRef idx="3">
-            <a:schemeClr val="accent1"/>
-          </a:fillRef>
-          <a:effectRef idx="2">
-            <a:schemeClr val="accent1"/>
-          </a:effectRef>
-          <a:fontRef idx="minor">
-            <a:schemeClr val="lt1"/>
-          </a:fontRef>
-        </p:style>
-        <p:txBody>
-          <a:bodyPr rtlCol="0" anchor="ctr"/>
-          <a:lstStyle/>
-          <a:p>
-            <a:pPr algn="ctr"/>
-          </a:p>
-        </p:txBody>
-      </p:sp>
-      <p:sp>
-        <p:nvSpPr>
-          <p:cNvPr id="6" name="Rounded Rectangle 5"/>
-          <p:cNvSpPr/>
-          <p:nvPr/>
-        </p:nvSpPr>
-        <p:spPr>
-          <a:xfrm>
-            <a:off x="3474720" y="1783080"/>
-            <a:ext cx="2606040" cy="2377440"/>
-          </a:xfrm>
-          <a:prstGeom prst="roundRect">
-            <a:avLst>
-              <a:gd name="adj" fmla="val 6000"/>
-            </a:avLst>
-          </a:prstGeom>
-          <a:solidFill>
-            <a:srgbClr val="F4F7FA"/>
-          </a:solidFill>
-          <a:ln w="15875">
-            <a:solidFill>
-              <a:srgbClr val="0E63B0"/>
-            </a:solidFill>
-          </a:ln>
-          <a:effectLst/>
-        </p:spPr>
-        <p:style>
-          <a:lnRef idx="1">
-            <a:schemeClr val="accent1"/>
-          </a:lnRef>
-          <a:fillRef idx="3">
-            <a:schemeClr val="accent1"/>
-          </a:fillRef>
-          <a:effectRef idx="2">
-            <a:schemeClr val="accent1"/>
-          </a:effectRef>
-          <a:fontRef idx="minor">
-            <a:schemeClr val="lt1"/>
-          </a:fontRef>
-        </p:style>
-        <p:txBody>
-          <a:bodyPr rtlCol="0" anchor="t" lIns="164592" rIns="164592" tIns="109728" bIns="109728" wrap="square"/>
-          <a:lstStyle/>
-          <a:p>
-            <a:pPr algn="l"/>
-            <a:r>
-              <a:rPr sz="1400" b="1">
-                <a:solidFill>
-                  <a:srgbClr val="0E63B0"/>
-                </a:solidFill>
-                <a:latin typeface="Calibri"/>
-              </a:rPr>
-              <a:t>Pilot — one PI</a:t>
-            </a:r>
-          </a:p>
-          <a:p>
-            <a:pPr algn="l"/>
-            <a:r>
-              <a:rPr sz="1200" b="0">
-                <a:solidFill>
-                  <a:srgbClr val="1F2933"/>
-                </a:solidFill>
-                <a:latin typeface="Calibri"/>
-              </a:rPr>
-              <a:t>2–3 services; real feature work by non-licensed devs using packs + plan template; collect metrics</a:t>
-            </a:r>
-          </a:p>
-        </p:txBody>
-      </p:sp>
-      <p:sp>
-        <p:nvSpPr>
-          <p:cNvPr id="7" name="Right Arrow 6"/>
-          <p:cNvSpPr/>
-          <p:nvPr/>
-        </p:nvSpPr>
-        <p:spPr>
-          <a:xfrm>
-            <a:off x="6080760" y="2834640"/>
-            <a:ext cx="320040" cy="256032"/>
-          </a:xfrm>
-          <a:prstGeom prst="rightArrow">
-            <a:avLst/>
-          </a:prstGeom>
-          <a:solidFill>
-            <a:srgbClr val="0E63B0"/>
-          </a:solidFill>
-          <a:ln>
-            <a:noFill/>
-          </a:ln>
-          <a:effectLst/>
-        </p:spPr>
-        <p:style>
-          <a:lnRef idx="1">
-            <a:schemeClr val="accent1"/>
-          </a:lnRef>
-          <a:fillRef idx="3">
-            <a:schemeClr val="accent1"/>
-          </a:fillRef>
-          <a:effectRef idx="2">
-            <a:schemeClr val="accent1"/>
-          </a:effectRef>
-          <a:fontRef idx="minor">
-            <a:schemeClr val="lt1"/>
-          </a:fontRef>
-        </p:style>
-        <p:txBody>
-          <a:bodyPr rtlCol="0" anchor="ctr"/>
-          <a:lstStyle/>
-          <a:p>
-            <a:pPr algn="ctr"/>
-          </a:p>
-        </p:txBody>
-      </p:sp>
-      <p:sp>
-        <p:nvSpPr>
-          <p:cNvPr id="8" name="Rounded Rectangle 7"/>
-          <p:cNvSpPr/>
-          <p:nvPr/>
-        </p:nvSpPr>
-        <p:spPr>
-          <a:xfrm>
-            <a:off x="6400800" y="1783080"/>
-            <a:ext cx="2606040" cy="2377440"/>
-          </a:xfrm>
-          <a:prstGeom prst="roundRect">
-            <a:avLst>
-              <a:gd name="adj" fmla="val 6000"/>
-            </a:avLst>
-          </a:prstGeom>
-          <a:solidFill>
-            <a:srgbClr val="F4F7FA"/>
-          </a:solidFill>
-          <a:ln w="15875">
-            <a:solidFill>
-              <a:srgbClr val="B45E12"/>
-            </a:solidFill>
-          </a:ln>
-          <a:effectLst/>
-        </p:spPr>
-        <p:style>
-          <a:lnRef idx="1">
-            <a:schemeClr val="accent1"/>
-          </a:lnRef>
-          <a:fillRef idx="3">
-            <a:schemeClr val="accent1"/>
-          </a:fillRef>
-          <a:effectRef idx="2">
-            <a:schemeClr val="accent1"/>
-          </a:effectRef>
-          <a:fontRef idx="minor">
-            <a:schemeClr val="lt1"/>
-          </a:fontRef>
-        </p:style>
-        <p:txBody>
-          <a:bodyPr rtlCol="0" anchor="t" lIns="164592" rIns="164592" tIns="109728" bIns="109728" wrap="square"/>
-          <a:lstStyle/>
-          <a:p>
-            <a:pPr algn="l"/>
-            <a:r>
-              <a:rPr sz="1400" b="1">
-                <a:solidFill>
-                  <a:srgbClr val="B45E12"/>
-                </a:solidFill>
-                <a:latin typeface="Calibri"/>
-              </a:rPr>
-              <a:t>Measure &amp; decide</a:t>
-            </a:r>
-          </a:p>
-          <a:p>
-            <a:pPr algn="l"/>
-            <a:r>
-              <a:rPr sz="1200" b="0">
-                <a:solidFill>
-                  <a:srgbClr val="1F2933"/>
-                </a:solidFill>
-                <a:latin typeface="Calibri"/>
-              </a:rPr>
-              <a:t>Review metrics + dev feedback at PI boundary; go / adjust / stop</a:t>
-            </a:r>
-          </a:p>
-        </p:txBody>
-      </p:sp>
-      <p:sp>
-        <p:nvSpPr>
-          <p:cNvPr id="9" name="Right Arrow 8"/>
-          <p:cNvSpPr/>
-          <p:nvPr/>
-        </p:nvSpPr>
-        <p:spPr>
-          <a:xfrm>
-            <a:off x="9006840" y="2834640"/>
-            <a:ext cx="320040" cy="256032"/>
-          </a:xfrm>
-          <a:prstGeom prst="rightArrow">
-            <a:avLst/>
-          </a:prstGeom>
-          <a:solidFill>
-            <a:srgbClr val="0E63B0"/>
-          </a:solidFill>
-          <a:ln>
-            <a:noFill/>
-          </a:ln>
-          <a:effectLst/>
-        </p:spPr>
-        <p:style>
-          <a:lnRef idx="1">
-            <a:schemeClr val="accent1"/>
-          </a:lnRef>
-          <a:fillRef idx="3">
-            <a:schemeClr val="accent1"/>
-          </a:fillRef>
-          <a:effectRef idx="2">
-            <a:schemeClr val="accent1"/>
-          </a:effectRef>
-          <a:fontRef idx="minor">
-            <a:schemeClr val="lt1"/>
-          </a:fontRef>
-        </p:style>
-        <p:txBody>
-          <a:bodyPr rtlCol="0" anchor="ctr"/>
-          <a:lstStyle/>
-          <a:p>
-            <a:pPr algn="ctr"/>
-          </a:p>
-        </p:txBody>
-      </p:sp>
-      <p:sp>
-        <p:nvSpPr>
-          <p:cNvPr id="10" name="Rounded Rectangle 9"/>
-          <p:cNvSpPr/>
-          <p:nvPr/>
-        </p:nvSpPr>
-        <p:spPr>
-          <a:xfrm>
-            <a:off x="9326880" y="1783080"/>
-            <a:ext cx="2606040" cy="2377440"/>
-          </a:xfrm>
-          <a:prstGeom prst="roundRect">
-            <a:avLst>
-              <a:gd name="adj" fmla="val 6000"/>
-            </a:avLst>
-          </a:prstGeom>
-          <a:solidFill>
-            <a:srgbClr val="F4F7FA"/>
-          </a:solidFill>
-          <a:ln w="15875">
-            <a:solidFill>
-              <a:srgbClr val="1E7A45"/>
-            </a:solidFill>
-          </a:ln>
-          <a:effectLst/>
-        </p:spPr>
-        <p:style>
-          <a:lnRef idx="1">
-            <a:schemeClr val="accent1"/>
-          </a:lnRef>
-          <a:fillRef idx="3">
-            <a:schemeClr val="accent1"/>
-          </a:fillRef>
-          <a:effectRef idx="2">
-            <a:schemeClr val="accent1"/>
-          </a:effectRef>
-          <a:fontRef idx="minor">
-            <a:schemeClr val="lt1"/>
-          </a:fontRef>
-        </p:style>
-        <p:txBody>
-          <a:bodyPr rtlCol="0" anchor="t" lIns="164592" rIns="164592" tIns="109728" bIns="109728" wrap="square"/>
-          <a:lstStyle/>
-          <a:p>
-            <a:pPr algn="l"/>
-            <a:r>
-              <a:rPr sz="1400" b="1">
-                <a:solidFill>
-                  <a:srgbClr val="1E7A45"/>
-                </a:solidFill>
-                <a:latin typeface="Calibri"/>
-              </a:rPr>
-              <a:t>Scale</a:t>
-            </a:r>
-          </a:p>
-          <a:p>
-            <a:pPr algn="l"/>
-            <a:r>
-              <a:rPr sz="1200" b="0">
-                <a:solidFill>
-                  <a:srgbClr val="1F2933"/>
-                </a:solidFill>
-                <a:latin typeface="Calibri"/>
-              </a:rPr>
-              <a:t>Roll out to all services as enabler stories; per-PI regeneration becomes routine</a:t>
-            </a:r>
-          </a:p>
-        </p:txBody>
-      </p:sp>
-      <p:sp>
-        <p:nvSpPr>
-          <p:cNvPr id="11" name="Rounded Rectangle 10"/>
-          <p:cNvSpPr/>
-          <p:nvPr/>
-        </p:nvSpPr>
-        <p:spPr>
-          <a:xfrm>
-            <a:off x="548640" y="4526280"/>
-            <a:ext cx="11201400" cy="1737360"/>
-          </a:xfrm>
-          <a:prstGeom prst="roundRect">
-            <a:avLst>
-              <a:gd name="adj" fmla="val 6000"/>
-            </a:avLst>
-          </a:prstGeom>
-          <a:solidFill>
-            <a:srgbClr val="F4F7FA"/>
-          </a:solidFill>
-          <a:ln>
-            <a:noFill/>
-          </a:ln>
-          <a:effectLst/>
-        </p:spPr>
-        <p:style>
-          <a:lnRef idx="1">
-            <a:schemeClr val="accent1"/>
-          </a:lnRef>
-          <a:fillRef idx="3">
-            <a:schemeClr val="accent1"/>
-          </a:fillRef>
-          <a:effectRef idx="2">
-            <a:schemeClr val="accent1"/>
-          </a:effectRef>
-          <a:fontRef idx="minor">
-            <a:schemeClr val="lt1"/>
-          </a:fontRef>
-        </p:style>
-        <p:txBody>
-          <a:bodyPr rtlCol="0" anchor="t" lIns="164592" rIns="164592" tIns="109728" bIns="109728" wrap="square"/>
-          <a:lstStyle/>
-          <a:p>
-            <a:pPr algn="l"/>
-            <a:r>
-              <a:rPr sz="1500" b="1">
-                <a:solidFill>
-                  <a:srgbClr val="0A467E"/>
-                </a:solidFill>
-                <a:latin typeface="Calibri"/>
-              </a:rPr>
-              <a:t>Success metrics for the pilot</a:t>
-            </a:r>
-          </a:p>
-          <a:p>
-            <a:pPr algn="l"/>
-            <a:r>
-              <a:rPr sz="1300" b="0">
-                <a:solidFill>
-                  <a:srgbClr val="1F2933"/>
-                </a:solidFill>
-                <a:latin typeface="Calibri"/>
-              </a:rPr>
-              <a:t>• Pack load success rate in Duo and Copilot sessions (target: 100% of pilot packs)</a:t>
-            </a:r>
-          </a:p>
-          <a:p>
-            <a:pPr algn="l"/>
-            <a:r>
-              <a:rPr sz="1300" b="0">
-                <a:solidFill>
-                  <a:srgbClr val="1F2933"/>
-                </a:solidFill>
-                <a:latin typeface="Calibri"/>
-              </a:rPr>
-              <a:t>• Developer survey: usefulness of answers with vs without packs</a:t>
-            </a:r>
-          </a:p>
-          <a:p>
-            <a:pPr algn="l"/>
-            <a:r>
-              <a:rPr sz="1300" b="0">
-                <a:solidFill>
-                  <a:srgbClr val="1F2933"/>
-                </a:solidFill>
-                <a:latin typeface="Calibri"/>
-              </a:rPr>
-              <a:t>• Share of changes where the filled-in plan was usable with minor edits</a:t>
-            </a:r>
-          </a:p>
-          <a:p>
-            <a:pPr algn="l"/>
-            <a:r>
-              <a:rPr sz="1300" b="0">
-                <a:solidFill>
-                  <a:srgbClr val="1F2933"/>
-                </a:solidFill>
-                <a:latin typeface="Calibri"/>
-              </a:rPr>
-              <a:t>• Time-to-first-usable-answer on service-specific questions, before vs after</a:t>
-            </a:r>
-          </a:p>
-        </p:txBody>
-      </p:sp>
-      <p:sp>
-        <p:nvSpPr>
-          <p:cNvPr id="12" name="TextBox 11"/>
-          <p:cNvSpPr txBox="1"/>
-          <p:nvPr/>
-        </p:nvSpPr>
-        <p:spPr>
-          <a:xfrm>
-            <a:off x="10881360" y="6446520"/>
-            <a:ext cx="1005840" cy="320040"/>
-          </a:xfrm>
-          <a:prstGeom prst="rect">
-            <a:avLst/>
-          </a:prstGeom>
-          <a:noFill/>
-        </p:spPr>
-        <p:txBody>
-          <a:bodyPr wrap="square">
-            <a:spAutoFit/>
-          </a:bodyPr>
-          <a:lstStyle/>
-          <a:p>
-            <a:pPr algn="r"/>
-            <a:r>
-              <a:rPr sz="1100" b="0">
-                <a:solidFill>
-                  <a:srgbClr val="5A6B7A"/>
-                </a:solidFill>
-                <a:latin typeface="Calibri"/>
-              </a:rPr>
               <a:t>15</a:t>
             </a:r>
           </a:p>
@@ -6501,7 +6234,7 @@
                 </a:solidFill>
                 <a:latin typeface="Calibri"/>
               </a:rPr>
-              <a:t>THE ASK</a:t>
+              <a:t>ROLLOUT PLAN</a:t>
             </a:r>
           </a:p>
           <a:p>
@@ -6513,7 +6246,7 @@
                 </a:solidFill>
                 <a:latin typeface="Calibri"/>
               </a:rPr>
-              <a:t>What I'm asking for today</a:t>
+              <a:t>Rollout, the SAFe way</a:t>
             </a:r>
           </a:p>
         </p:txBody>
@@ -6527,7 +6260,120 @@
         <p:spPr>
           <a:xfrm>
             <a:off x="548640" y="1783080"/>
-            <a:ext cx="5486400" cy="1463040"/>
+            <a:ext cx="2606040" cy="2377440"/>
+          </a:xfrm>
+          <a:prstGeom prst="roundRect">
+            <a:avLst>
+              <a:gd name="adj" fmla="val 6000"/>
+            </a:avLst>
+          </a:prstGeom>
+          <a:solidFill>
+            <a:srgbClr val="F4F7FA"/>
+          </a:solidFill>
+          <a:ln w="15875">
+            <a:solidFill>
+              <a:srgbClr val="1E7A45"/>
+            </a:solidFill>
+          </a:ln>
+          <a:effectLst/>
+        </p:spPr>
+        <p:style>
+          <a:lnRef idx="1">
+            <a:schemeClr val="accent1"/>
+          </a:lnRef>
+          <a:fillRef idx="3">
+            <a:schemeClr val="accent1"/>
+          </a:fillRef>
+          <a:effectRef idx="2">
+            <a:schemeClr val="accent1"/>
+          </a:effectRef>
+          <a:fontRef idx="minor">
+            <a:schemeClr val="lt1"/>
+          </a:fontRef>
+        </p:style>
+        <p:txBody>
+          <a:bodyPr rtlCol="0" anchor="t" lIns="164592" rIns="164592" tIns="109728" bIns="109728" wrap="square"/>
+          <a:lstStyle/>
+          <a:p>
+            <a:pPr algn="l"/>
+            <a:r>
+              <a:rPr sz="1400" b="1">
+                <a:solidFill>
+                  <a:srgbClr val="1E7A45"/>
+                </a:solidFill>
+                <a:latin typeface="Calibri"/>
+              </a:rPr>
+              <a:t>Spike — IN PROGRESS</a:t>
+            </a:r>
+          </a:p>
+          <a:p>
+            <a:pPr algn="l"/>
+            <a:r>
+              <a:rPr sz="1200" b="0">
+                <a:solidFill>
+                  <a:srgbClr val="1F2933"/>
+                </a:solidFill>
+                <a:latin typeface="Calibri"/>
+              </a:rPr>
+              <a:t>5 prompt strategies written; 5 packs generated on a sample service; objective checks passed; Duo runs next</a:t>
+            </a:r>
+          </a:p>
+        </p:txBody>
+      </p:sp>
+      <p:sp>
+        <p:nvSpPr>
+          <p:cNvPr id="5" name="Right Arrow 4"/>
+          <p:cNvSpPr/>
+          <p:nvPr/>
+        </p:nvSpPr>
+        <p:spPr>
+          <a:xfrm>
+            <a:off x="3154680" y="2834640"/>
+            <a:ext cx="320040" cy="256032"/>
+          </a:xfrm>
+          <a:prstGeom prst="rightArrow">
+            <a:avLst/>
+          </a:prstGeom>
+          <a:solidFill>
+            <a:srgbClr val="0E63B0"/>
+          </a:solidFill>
+          <a:ln>
+            <a:noFill/>
+          </a:ln>
+          <a:effectLst/>
+        </p:spPr>
+        <p:style>
+          <a:lnRef idx="1">
+            <a:schemeClr val="accent1"/>
+          </a:lnRef>
+          <a:fillRef idx="3">
+            <a:schemeClr val="accent1"/>
+          </a:fillRef>
+          <a:effectRef idx="2">
+            <a:schemeClr val="accent1"/>
+          </a:effectRef>
+          <a:fontRef idx="minor">
+            <a:schemeClr val="lt1"/>
+          </a:fontRef>
+        </p:style>
+        <p:txBody>
+          <a:bodyPr rtlCol="0" anchor="ctr"/>
+          <a:lstStyle/>
+          <a:p>
+            <a:pPr algn="ctr"/>
+          </a:p>
+        </p:txBody>
+      </p:sp>
+      <p:sp>
+        <p:nvSpPr>
+          <p:cNvPr id="6" name="Rounded Rectangle 5"/>
+          <p:cNvSpPr/>
+          <p:nvPr/>
+        </p:nvSpPr>
+        <p:spPr>
+          <a:xfrm>
+            <a:off x="3474720" y="1783080"/>
+            <a:ext cx="2606040" cy="2377440"/>
           </a:xfrm>
           <a:prstGeom prst="roundRect">
             <a:avLst>
@@ -6564,13 +6410,306 @@
           <a:p>
             <a:pPr algn="l"/>
             <a:r>
-              <a:rPr sz="1600" b="1">
+              <a:rPr sz="1400" b="1">
                 <a:solidFill>
                   <a:srgbClr val="0E63B0"/>
                 </a:solidFill>
                 <a:latin typeface="Calibri"/>
               </a:rPr>
-              <a:t>Approve the spike</a:t>
+              <a:t>Pilot — one PI</a:t>
+            </a:r>
+          </a:p>
+          <a:p>
+            <a:pPr algn="l"/>
+            <a:r>
+              <a:rPr sz="1200" b="0">
+                <a:solidFill>
+                  <a:srgbClr val="1F2933"/>
+                </a:solidFill>
+                <a:latin typeface="Calibri"/>
+              </a:rPr>
+              <a:t>2–3 services; real feature work by non-licensed devs using packs + plan template; collect metrics</a:t>
+            </a:r>
+          </a:p>
+        </p:txBody>
+      </p:sp>
+      <p:sp>
+        <p:nvSpPr>
+          <p:cNvPr id="7" name="Right Arrow 6"/>
+          <p:cNvSpPr/>
+          <p:nvPr/>
+        </p:nvSpPr>
+        <p:spPr>
+          <a:xfrm>
+            <a:off x="6080760" y="2834640"/>
+            <a:ext cx="320040" cy="256032"/>
+          </a:xfrm>
+          <a:prstGeom prst="rightArrow">
+            <a:avLst/>
+          </a:prstGeom>
+          <a:solidFill>
+            <a:srgbClr val="0E63B0"/>
+          </a:solidFill>
+          <a:ln>
+            <a:noFill/>
+          </a:ln>
+          <a:effectLst/>
+        </p:spPr>
+        <p:style>
+          <a:lnRef idx="1">
+            <a:schemeClr val="accent1"/>
+          </a:lnRef>
+          <a:fillRef idx="3">
+            <a:schemeClr val="accent1"/>
+          </a:fillRef>
+          <a:effectRef idx="2">
+            <a:schemeClr val="accent1"/>
+          </a:effectRef>
+          <a:fontRef idx="minor">
+            <a:schemeClr val="lt1"/>
+          </a:fontRef>
+        </p:style>
+        <p:txBody>
+          <a:bodyPr rtlCol="0" anchor="ctr"/>
+          <a:lstStyle/>
+          <a:p>
+            <a:pPr algn="ctr"/>
+          </a:p>
+        </p:txBody>
+      </p:sp>
+      <p:sp>
+        <p:nvSpPr>
+          <p:cNvPr id="8" name="Rounded Rectangle 7"/>
+          <p:cNvSpPr/>
+          <p:nvPr/>
+        </p:nvSpPr>
+        <p:spPr>
+          <a:xfrm>
+            <a:off x="6400800" y="1783080"/>
+            <a:ext cx="2606040" cy="2377440"/>
+          </a:xfrm>
+          <a:prstGeom prst="roundRect">
+            <a:avLst>
+              <a:gd name="adj" fmla="val 6000"/>
+            </a:avLst>
+          </a:prstGeom>
+          <a:solidFill>
+            <a:srgbClr val="F4F7FA"/>
+          </a:solidFill>
+          <a:ln w="15875">
+            <a:solidFill>
+              <a:srgbClr val="B45E12"/>
+            </a:solidFill>
+          </a:ln>
+          <a:effectLst/>
+        </p:spPr>
+        <p:style>
+          <a:lnRef idx="1">
+            <a:schemeClr val="accent1"/>
+          </a:lnRef>
+          <a:fillRef idx="3">
+            <a:schemeClr val="accent1"/>
+          </a:fillRef>
+          <a:effectRef idx="2">
+            <a:schemeClr val="accent1"/>
+          </a:effectRef>
+          <a:fontRef idx="minor">
+            <a:schemeClr val="lt1"/>
+          </a:fontRef>
+        </p:style>
+        <p:txBody>
+          <a:bodyPr rtlCol="0" anchor="t" lIns="164592" rIns="164592" tIns="109728" bIns="109728" wrap="square"/>
+          <a:lstStyle/>
+          <a:p>
+            <a:pPr algn="l"/>
+            <a:r>
+              <a:rPr sz="1400" b="1">
+                <a:solidFill>
+                  <a:srgbClr val="B45E12"/>
+                </a:solidFill>
+                <a:latin typeface="Calibri"/>
+              </a:rPr>
+              <a:t>Measure &amp; decide</a:t>
+            </a:r>
+          </a:p>
+          <a:p>
+            <a:pPr algn="l"/>
+            <a:r>
+              <a:rPr sz="1200" b="0">
+                <a:solidFill>
+                  <a:srgbClr val="1F2933"/>
+                </a:solidFill>
+                <a:latin typeface="Calibri"/>
+              </a:rPr>
+              <a:t>Review metrics + dev feedback at PI boundary; go / adjust / stop</a:t>
+            </a:r>
+          </a:p>
+        </p:txBody>
+      </p:sp>
+      <p:sp>
+        <p:nvSpPr>
+          <p:cNvPr id="9" name="Right Arrow 8"/>
+          <p:cNvSpPr/>
+          <p:nvPr/>
+        </p:nvSpPr>
+        <p:spPr>
+          <a:xfrm>
+            <a:off x="9006840" y="2834640"/>
+            <a:ext cx="320040" cy="256032"/>
+          </a:xfrm>
+          <a:prstGeom prst="rightArrow">
+            <a:avLst/>
+          </a:prstGeom>
+          <a:solidFill>
+            <a:srgbClr val="0E63B0"/>
+          </a:solidFill>
+          <a:ln>
+            <a:noFill/>
+          </a:ln>
+          <a:effectLst/>
+        </p:spPr>
+        <p:style>
+          <a:lnRef idx="1">
+            <a:schemeClr val="accent1"/>
+          </a:lnRef>
+          <a:fillRef idx="3">
+            <a:schemeClr val="accent1"/>
+          </a:fillRef>
+          <a:effectRef idx="2">
+            <a:schemeClr val="accent1"/>
+          </a:effectRef>
+          <a:fontRef idx="minor">
+            <a:schemeClr val="lt1"/>
+          </a:fontRef>
+        </p:style>
+        <p:txBody>
+          <a:bodyPr rtlCol="0" anchor="ctr"/>
+          <a:lstStyle/>
+          <a:p>
+            <a:pPr algn="ctr"/>
+          </a:p>
+        </p:txBody>
+      </p:sp>
+      <p:sp>
+        <p:nvSpPr>
+          <p:cNvPr id="10" name="Rounded Rectangle 9"/>
+          <p:cNvSpPr/>
+          <p:nvPr/>
+        </p:nvSpPr>
+        <p:spPr>
+          <a:xfrm>
+            <a:off x="9326880" y="1783080"/>
+            <a:ext cx="2606040" cy="2377440"/>
+          </a:xfrm>
+          <a:prstGeom prst="roundRect">
+            <a:avLst>
+              <a:gd name="adj" fmla="val 6000"/>
+            </a:avLst>
+          </a:prstGeom>
+          <a:solidFill>
+            <a:srgbClr val="F4F7FA"/>
+          </a:solidFill>
+          <a:ln w="15875">
+            <a:solidFill>
+              <a:srgbClr val="1E7A45"/>
+            </a:solidFill>
+          </a:ln>
+          <a:effectLst/>
+        </p:spPr>
+        <p:style>
+          <a:lnRef idx="1">
+            <a:schemeClr val="accent1"/>
+          </a:lnRef>
+          <a:fillRef idx="3">
+            <a:schemeClr val="accent1"/>
+          </a:fillRef>
+          <a:effectRef idx="2">
+            <a:schemeClr val="accent1"/>
+          </a:effectRef>
+          <a:fontRef idx="minor">
+            <a:schemeClr val="lt1"/>
+          </a:fontRef>
+        </p:style>
+        <p:txBody>
+          <a:bodyPr rtlCol="0" anchor="t" lIns="164592" rIns="164592" tIns="109728" bIns="109728" wrap="square"/>
+          <a:lstStyle/>
+          <a:p>
+            <a:pPr algn="l"/>
+            <a:r>
+              <a:rPr sz="1400" b="1">
+                <a:solidFill>
+                  <a:srgbClr val="1E7A45"/>
+                </a:solidFill>
+                <a:latin typeface="Calibri"/>
+              </a:rPr>
+              <a:t>Scale</a:t>
+            </a:r>
+          </a:p>
+          <a:p>
+            <a:pPr algn="l"/>
+            <a:r>
+              <a:rPr sz="1200" b="0">
+                <a:solidFill>
+                  <a:srgbClr val="1F2933"/>
+                </a:solidFill>
+                <a:latin typeface="Calibri"/>
+              </a:rPr>
+              <a:t>Roll out to all services as enabler stories; per-PI regeneration becomes routine</a:t>
+            </a:r>
+          </a:p>
+        </p:txBody>
+      </p:sp>
+      <p:sp>
+        <p:nvSpPr>
+          <p:cNvPr id="11" name="Rounded Rectangle 10"/>
+          <p:cNvSpPr/>
+          <p:nvPr/>
+        </p:nvSpPr>
+        <p:spPr>
+          <a:xfrm>
+            <a:off x="548640" y="4526280"/>
+            <a:ext cx="11201400" cy="1737360"/>
+          </a:xfrm>
+          <a:prstGeom prst="roundRect">
+            <a:avLst>
+              <a:gd name="adj" fmla="val 6000"/>
+            </a:avLst>
+          </a:prstGeom>
+          <a:solidFill>
+            <a:srgbClr val="F4F7FA"/>
+          </a:solidFill>
+          <a:ln>
+            <a:noFill/>
+          </a:ln>
+          <a:effectLst/>
+        </p:spPr>
+        <p:style>
+          <a:lnRef idx="1">
+            <a:schemeClr val="accent1"/>
+          </a:lnRef>
+          <a:fillRef idx="3">
+            <a:schemeClr val="accent1"/>
+          </a:fillRef>
+          <a:effectRef idx="2">
+            <a:schemeClr val="accent1"/>
+          </a:effectRef>
+          <a:fontRef idx="minor">
+            <a:schemeClr val="lt1"/>
+          </a:fontRef>
+        </p:style>
+        <p:txBody>
+          <a:bodyPr rtlCol="0" anchor="t" lIns="164592" rIns="164592" tIns="109728" bIns="109728" wrap="square"/>
+          <a:lstStyle/>
+          <a:p>
+            <a:pPr algn="l"/>
+            <a:r>
+              <a:rPr sz="1500" b="1">
+                <a:solidFill>
+                  <a:srgbClr val="0A467E"/>
+                </a:solidFill>
+                <a:latin typeface="Calibri"/>
+              </a:rPr>
+              <a:t>Success metrics for the pilot</a:t>
             </a:r>
           </a:p>
           <a:p>
@@ -6582,20 +6721,199 @@
                 </a:solidFill>
                 <a:latin typeface="Calibri"/>
               </a:rPr>
-              <a:t>One time-boxed spike in the next iteration for the prompt experiments and pilot pack</a:t>
-            </a:r>
-          </a:p>
-        </p:txBody>
-      </p:sp>
-      <p:sp>
-        <p:nvSpPr>
-          <p:cNvPr id="5" name="Rounded Rectangle 4"/>
+              <a:t>• Pack load success rate in Duo and Copilot sessions (target: 100% of pilot packs)</a:t>
+            </a:r>
+          </a:p>
+          <a:p>
+            <a:pPr algn="l"/>
+            <a:r>
+              <a:rPr sz="1300" b="0">
+                <a:solidFill>
+                  <a:srgbClr val="1F2933"/>
+                </a:solidFill>
+                <a:latin typeface="Calibri"/>
+              </a:rPr>
+              <a:t>• Developer survey: usefulness of answers with vs without packs</a:t>
+            </a:r>
+          </a:p>
+          <a:p>
+            <a:pPr algn="l"/>
+            <a:r>
+              <a:rPr sz="1300" b="0">
+                <a:solidFill>
+                  <a:srgbClr val="1F2933"/>
+                </a:solidFill>
+                <a:latin typeface="Calibri"/>
+              </a:rPr>
+              <a:t>• Share of changes where the filled-in plan was usable with minor edits</a:t>
+            </a:r>
+          </a:p>
+          <a:p>
+            <a:pPr algn="l"/>
+            <a:r>
+              <a:rPr sz="1300" b="0">
+                <a:solidFill>
+                  <a:srgbClr val="1F2933"/>
+                </a:solidFill>
+                <a:latin typeface="Calibri"/>
+              </a:rPr>
+              <a:t>• Time-to-first-usable-answer on service-specific questions, before vs after</a:t>
+            </a:r>
+          </a:p>
+        </p:txBody>
+      </p:sp>
+      <p:sp>
+        <p:nvSpPr>
+          <p:cNvPr id="12" name="TextBox 11"/>
+          <p:cNvSpPr txBox="1"/>
+          <p:nvPr/>
+        </p:nvSpPr>
+        <p:spPr>
+          <a:xfrm>
+            <a:off x="10881360" y="6446520"/>
+            <a:ext cx="1005840" cy="320040"/>
+          </a:xfrm>
+          <a:prstGeom prst="rect">
+            <a:avLst/>
+          </a:prstGeom>
+          <a:noFill/>
+        </p:spPr>
+        <p:txBody>
+          <a:bodyPr wrap="square">
+            <a:spAutoFit/>
+          </a:bodyPr>
+          <a:lstStyle/>
+          <a:p>
+            <a:pPr algn="r"/>
+            <a:r>
+              <a:rPr sz="1100" b="0">
+                <a:solidFill>
+                  <a:srgbClr val="5A6B7A"/>
+                </a:solidFill>
+                <a:latin typeface="Calibri"/>
+              </a:rPr>
+              <a:t>16</a:t>
+            </a:r>
+          </a:p>
+        </p:txBody>
+      </p:sp>
+    </p:spTree>
+  </p:cSld>
+  <p:clrMapOvr>
+    <a:masterClrMapping/>
+  </p:clrMapOvr>
+</p:sld>
+</file>
+
+<file path=ppt/slides/slide17.xml><?xml version="1.0" encoding="utf-8"?>
+<p:sld xmlns:a="http://schemas.openxmlformats.org/drawingml/2006/main" xmlns:p="http://schemas.openxmlformats.org/presentationml/2006/main" xmlns:r="http://schemas.openxmlformats.org/officeDocument/2006/relationships">
+  <p:cSld>
+    <p:spTree>
+      <p:nvGrpSpPr>
+        <p:cNvPr id="1" name=""/>
+        <p:cNvGrpSpPr/>
+        <p:nvPr/>
+      </p:nvGrpSpPr>
+      <p:grpSpPr/>
+      <p:sp>
+        <p:nvSpPr>
+          <p:cNvPr id="2" name="Rectangle 1"/>
           <p:cNvSpPr/>
           <p:nvPr/>
         </p:nvSpPr>
         <p:spPr>
           <a:xfrm>
-            <a:off x="6263640" y="1783080"/>
+            <a:off x="548640" y="502920"/>
+            <a:ext cx="502920" cy="82296"/>
+          </a:xfrm>
+          <a:prstGeom prst="rect">
+            <a:avLst/>
+          </a:prstGeom>
+          <a:solidFill>
+            <a:srgbClr val="0E63B0"/>
+          </a:solidFill>
+          <a:ln>
+            <a:noFill/>
+          </a:ln>
+        </p:spPr>
+        <p:style>
+          <a:lnRef idx="1">
+            <a:schemeClr val="accent1"/>
+          </a:lnRef>
+          <a:fillRef idx="3">
+            <a:schemeClr val="accent1"/>
+          </a:fillRef>
+          <a:effectRef idx="2">
+            <a:schemeClr val="accent1"/>
+          </a:effectRef>
+          <a:fontRef idx="minor">
+            <a:schemeClr val="lt1"/>
+          </a:fontRef>
+        </p:style>
+        <p:txBody>
+          <a:bodyPr rtlCol="0" anchor="ctr"/>
+          <a:lstStyle/>
+          <a:p>
+            <a:pPr algn="ctr"/>
+          </a:p>
+        </p:txBody>
+      </p:sp>
+      <p:sp>
+        <p:nvSpPr>
+          <p:cNvPr id="3" name="TextBox 2"/>
+          <p:cNvSpPr txBox="1"/>
+          <p:nvPr/>
+        </p:nvSpPr>
+        <p:spPr>
+          <a:xfrm>
+            <a:off x="548640" y="621792"/>
+            <a:ext cx="11064240" cy="914400"/>
+          </a:xfrm>
+          <a:prstGeom prst="rect">
+            <a:avLst/>
+          </a:prstGeom>
+          <a:noFill/>
+        </p:spPr>
+        <p:txBody>
+          <a:bodyPr wrap="square">
+            <a:spAutoFit/>
+          </a:bodyPr>
+          <a:lstStyle/>
+          <a:p>
+            <a:pPr algn="l"/>
+            <a:r>
+              <a:rPr sz="1200" b="1">
+                <a:solidFill>
+                  <a:srgbClr val="0E63B0"/>
+                </a:solidFill>
+                <a:latin typeface="Calibri"/>
+              </a:rPr>
+              <a:t>THE ASK</a:t>
+            </a:r>
+          </a:p>
+          <a:p>
+            <a:pPr algn="l"/>
+            <a:r>
+              <a:rPr sz="3000" b="1">
+                <a:solidFill>
+                  <a:srgbClr val="1F2933"/>
+                </a:solidFill>
+                <a:latin typeface="Calibri"/>
+              </a:rPr>
+              <a:t>What I'm asking for today</a:t>
+            </a:r>
+          </a:p>
+        </p:txBody>
+      </p:sp>
+      <p:sp>
+        <p:nvSpPr>
+          <p:cNvPr id="4" name="Rounded Rectangle 3"/>
+          <p:cNvSpPr/>
+          <p:nvPr/>
+        </p:nvSpPr>
+        <p:spPr>
+          <a:xfrm>
+            <a:off x="548640" y="1783080"/>
             <a:ext cx="5486400" cy="1463040"/>
           </a:xfrm>
           <a:prstGeom prst="roundRect">
@@ -6639,7 +6957,7 @@
                 </a:solidFill>
                 <a:latin typeface="Calibri"/>
               </a:rPr>
-              <a:t>Time-box for licensed devs</a:t>
+              <a:t>Finish the spike</a:t>
             </a:r>
           </a:p>
           <a:p>
@@ -6651,20 +6969,20 @@
                 </a:solidFill>
                 <a:latin typeface="Calibri"/>
               </a:rPr>
-              <a:t>A few hours of Claude Code time from the licensed developers during the spike</a:t>
-            </a:r>
-          </a:p>
-        </p:txBody>
-      </p:sp>
-      <p:sp>
-        <p:nvSpPr>
-          <p:cNvPr id="6" name="Rounded Rectangle 5"/>
+              <a:t>Time to run the Duo validation sessions on the 5 generated packs and pick the winning prompt</a:t>
+            </a:r>
+          </a:p>
+        </p:txBody>
+      </p:sp>
+      <p:sp>
+        <p:nvSpPr>
+          <p:cNvPr id="5" name="Rounded Rectangle 4"/>
           <p:cNvSpPr/>
           <p:nvPr/>
         </p:nvSpPr>
         <p:spPr>
           <a:xfrm>
-            <a:off x="548640" y="3474720"/>
+            <a:off x="6263640" y="1783080"/>
             <a:ext cx="5486400" cy="1463040"/>
           </a:xfrm>
           <a:prstGeom prst="roundRect">
@@ -6708,7 +7026,7 @@
                 </a:solidFill>
                 <a:latin typeface="Calibri"/>
               </a:rPr>
-              <a:t>Nominate a pilot service</a:t>
+              <a:t>Time-box for licensed devs</a:t>
             </a:r>
           </a:p>
           <a:p>
@@ -6720,20 +7038,20 @@
                 </a:solidFill>
                 <a:latin typeface="Calibri"/>
               </a:rPr>
-              <a:t>One representative Spring Boot service (and later 2–3 for the PI pilot)</a:t>
-            </a:r>
-          </a:p>
-        </p:txBody>
-      </p:sp>
-      <p:sp>
-        <p:nvSpPr>
-          <p:cNvPr id="7" name="Rounded Rectangle 6"/>
+              <a:t>A few hours of Claude Code time to re-run the winner fresh and generate the first real pack</a:t>
+            </a:r>
+          </a:p>
+        </p:txBody>
+      </p:sp>
+      <p:sp>
+        <p:nvSpPr>
+          <p:cNvPr id="6" name="Rounded Rectangle 5"/>
           <p:cNvSpPr/>
           <p:nvPr/>
         </p:nvSpPr>
         <p:spPr>
           <a:xfrm>
-            <a:off x="6263640" y="3474720"/>
+            <a:off x="548640" y="3474720"/>
             <a:ext cx="5486400" cy="1463040"/>
           </a:xfrm>
           <a:prstGeom prst="roundRect">
@@ -6777,6 +7095,75 @@
                 </a:solidFill>
                 <a:latin typeface="Calibri"/>
               </a:rPr>
+              <a:t>Nominate a pilot service</a:t>
+            </a:r>
+          </a:p>
+          <a:p>
+            <a:pPr algn="l"/>
+            <a:r>
+              <a:rPr sz="1300" b="0">
+                <a:solidFill>
+                  <a:srgbClr val="1F2933"/>
+                </a:solidFill>
+                <a:latin typeface="Calibri"/>
+              </a:rPr>
+              <a:t>One representative Spring Boot service (and later 2–3 for the PI pilot)</a:t>
+            </a:r>
+          </a:p>
+        </p:txBody>
+      </p:sp>
+      <p:sp>
+        <p:nvSpPr>
+          <p:cNvPr id="7" name="Rounded Rectangle 6"/>
+          <p:cNvSpPr/>
+          <p:nvPr/>
+        </p:nvSpPr>
+        <p:spPr>
+          <a:xfrm>
+            <a:off x="6263640" y="3474720"/>
+            <a:ext cx="5486400" cy="1463040"/>
+          </a:xfrm>
+          <a:prstGeom prst="roundRect">
+            <a:avLst>
+              <a:gd name="adj" fmla="val 6000"/>
+            </a:avLst>
+          </a:prstGeom>
+          <a:solidFill>
+            <a:srgbClr val="F4F7FA"/>
+          </a:solidFill>
+          <a:ln w="15875">
+            <a:solidFill>
+              <a:srgbClr val="0E63B0"/>
+            </a:solidFill>
+          </a:ln>
+          <a:effectLst/>
+        </p:spPr>
+        <p:style>
+          <a:lnRef idx="1">
+            <a:schemeClr val="accent1"/>
+          </a:lnRef>
+          <a:fillRef idx="3">
+            <a:schemeClr val="accent1"/>
+          </a:fillRef>
+          <a:effectRef idx="2">
+            <a:schemeClr val="accent1"/>
+          </a:effectRef>
+          <a:fontRef idx="minor">
+            <a:schemeClr val="lt1"/>
+          </a:fontRef>
+        </p:style>
+        <p:txBody>
+          <a:bodyPr rtlCol="0" anchor="t" lIns="164592" rIns="164592" tIns="109728" bIns="109728" wrap="square"/>
+          <a:lstStyle/>
+          <a:p>
+            <a:pPr algn="l"/>
+            <a:r>
+              <a:rPr sz="1600" b="1">
+                <a:solidFill>
+                  <a:srgbClr val="0E63B0"/>
+                </a:solidFill>
+                <a:latin typeface="Calibri"/>
+              </a:rPr>
               <a:t>Team commitment</a:t>
             </a:r>
           </a:p>
@@ -6879,7 +7266,7 @@
                 </a:solidFill>
                 <a:latin typeface="Calibri"/>
               </a:rPr>
-              <a:t>16</a:t>
+              <a:t>17</a:t>
             </a:r>
           </a:p>
         </p:txBody>
@@ -6892,7 +7279,7 @@
 </p:sld>
 </file>
 
-<file path=ppt/slides/slide17.xml><?xml version="1.0" encoding="utf-8"?>
+<file path=ppt/slides/slide18.xml><?xml version="1.0" encoding="utf-8"?>
 <p:sld xmlns:a="http://schemas.openxmlformats.org/drawingml/2006/main" xmlns:p="http://schemas.openxmlformats.org/presentationml/2006/main" xmlns:r="http://schemas.openxmlformats.org/officeDocument/2006/relationships">
   <p:cSld>
     <p:spTree>
@@ -11149,17 +11536,16 @@
           </a:xfrm>
           <a:prstGeom prst="roundRect">
             <a:avLst>
-              <a:gd name="adj" fmla="val 5000"/>
+              <a:gd name="adj" fmla="val 6000"/>
             </a:avLst>
           </a:prstGeom>
           <a:solidFill>
-            <a:srgbClr val="FDF3E3"/>
+            <a:srgbClr val="FFFFFF"/>
           </a:solidFill>
-          <a:ln w="19050">
+          <a:ln w="15875">
             <a:solidFill>
-              <a:srgbClr val="D9A440"/>
+              <a:srgbClr val="0E63B0"/>
             </a:solidFill>
-            <a:prstDash val="sysDash"/>
           </a:ln>
           <a:effectLst/>
         </p:spPr>
@@ -11178,42 +11564,174 @@
           </a:fontRef>
         </p:style>
         <p:txBody>
-          <a:bodyPr rtlCol="0" anchor="ctr" lIns="164592" rIns="164592" tIns="109728" bIns="109728" wrap="square"/>
-          <a:lstStyle/>
-          <a:p>
-            <a:pPr algn="ctr"/>
-            <a:r>
-              <a:rPr sz="1200" b="1">
+          <a:bodyPr rtlCol="0" anchor="t" lIns="164592" rIns="164592" tIns="109728" bIns="109728" wrap="square"/>
+          <a:lstStyle/>
+          <a:p>
+            <a:pPr algn="l"/>
+            <a:r>
+              <a:rPr sz="1100" b="1">
+                <a:solidFill>
+                  <a:srgbClr val="1E7A45"/>
+                </a:solidFill>
+                <a:latin typeface="Calibri"/>
+              </a:rPr>
+              <a:t>REAL OUTPUT — generated by Claude Code from the sample transfer-service</a:t>
+            </a:r>
+          </a:p>
+          <a:p>
+            <a:pPr algn="l"/>
+            <a:r>
+              <a:rPr sz="1300" b="1">
+                <a:solidFill>
+                  <a:srgbClr val="0A467E"/>
+                </a:solidFill>
+                <a:latin typeface="Calibri"/>
+              </a:rPr>
+              <a:t>RECIPES.md · R3 — Add a field to an existing entity</a:t>
+            </a:r>
+          </a:p>
+          <a:p>
+            <a:pPr algn="l"/>
+            <a:r>
+              <a:rPr sz="1100" b="0">
+                <a:solidFill>
+                  <a:srgbClr val="1F2933"/>
+                </a:solidFill>
+                <a:latin typeface="Calibri"/>
+              </a:rPr>
+              <a:t>WHEN: e.g. add `description` to Transfer.</a:t>
+            </a:r>
+          </a:p>
+          <a:p>
+            <a:pPr algn="l"/>
+            <a:r>
+              <a:rPr sz="1100" b="0">
+                <a:solidFill>
+                  <a:srgbClr val="1F2933"/>
+                </a:solidFill>
+                <a:latin typeface="Calibri"/>
+              </a:rPr>
+              <a:t>1  model.Transfer — private field + @Column traits + constructor param</a:t>
+            </a:r>
+          </a:p>
+          <a:p>
+            <a:pPr algn="l"/>
+            <a:r>
+              <a:rPr sz="1100" b="0">
+                <a:solidFill>
+                  <a:srgbClr val="1F2933"/>
+                </a:solidFill>
+                <a:latin typeface="Calibri"/>
+              </a:rPr>
+              <a:t>    + getter (entity is immutable — no setter)</a:t>
+            </a:r>
+          </a:p>
+          <a:p>
+            <a:pPr algn="l"/>
+            <a:r>
+              <a:rPr sz="1100" b="0">
+                <a:solidFill>
+                  <a:srgbClr val="1F2933"/>
+                </a:solidFill>
+                <a:latin typeface="Calibri"/>
+              </a:rPr>
+              <a:t>2  (no migration file: schema is ddl-auto create-drop from entities)</a:t>
+            </a:r>
+          </a:p>
+          <a:p>
+            <a:pPr algn="l"/>
+            <a:r>
+              <a:rPr sz="1100" b="0">
+                <a:solidFill>
+                  <a:srgbClr val="1F2933"/>
+                </a:solidFill>
+                <a:latin typeface="Calibri"/>
+              </a:rPr>
+              <a:t>3  dto.TransferRequest — add record component with validation</a:t>
+            </a:r>
+          </a:p>
+          <a:p>
+            <a:pPr algn="l"/>
+            <a:r>
+              <a:rPr sz="1100" b="0">
+                <a:solidFill>
+                  <a:srgbClr val="1F2933"/>
+                </a:solidFill>
+                <a:latin typeface="Calibri"/>
+              </a:rPr>
+              <a:t>    annotations (e.g. @Size(max=140); optional =&gt; no @NotBlank)</a:t>
+            </a:r>
+          </a:p>
+          <a:p>
+            <a:pPr algn="l"/>
+            <a:r>
+              <a:rPr sz="1100" b="0">
+                <a:solidFill>
+                  <a:srgbClr val="1F2933"/>
+                </a:solidFill>
+                <a:latin typeface="Calibri"/>
+              </a:rPr>
+              <a:t>4  service.TransferService — pass the value through in BOTH</a:t>
+            </a:r>
+          </a:p>
+          <a:p>
+            <a:pPr algn="l"/>
+            <a:r>
+              <a:rPr sz="1100" b="0">
+                <a:solidFill>
+                  <a:srgbClr val="1F2933"/>
+                </a:solidFill>
+                <a:latin typeface="Calibri"/>
+              </a:rPr>
+              <a:t>    new Transfer(...) call sites (REJECTED and COMPLETED branches)</a:t>
+            </a:r>
+          </a:p>
+          <a:p>
+            <a:pPr algn="l"/>
+            <a:r>
+              <a:rPr sz="1100" b="0">
+                <a:solidFill>
+                  <a:srgbClr val="1F2933"/>
+                </a:solidFill>
+                <a:latin typeface="Calibri"/>
+              </a:rPr>
+              <a:t>5  dto.TransferResponse — add component + map it in from(Transfer)</a:t>
+            </a:r>
+          </a:p>
+          <a:p>
+            <a:pPr algn="l"/>
+            <a:r>
+              <a:rPr sz="1100" b="0">
+                <a:solidFill>
+                  <a:srgbClr val="1F2933"/>
+                </a:solidFill>
+                <a:latin typeface="Calibri"/>
+              </a:rPr>
+              <a:t>6  test — extend the request(...) helper + add assertions</a:t>
+            </a:r>
+          </a:p>
+          <a:p>
+            <a:pPr algn="l"/>
+            <a:r>
+              <a:rPr sz="1100" b="1">
                 <a:solidFill>
                   <a:srgbClr val="B45E12"/>
                 </a:solidFill>
                 <a:latin typeface="Calibri"/>
               </a:rPr>
-              <a:t>[ DEMO ASSET — TO BE CAPTURED ]</a:t>
-            </a:r>
-          </a:p>
-          <a:p>
-            <a:pPr algn="ctr"/>
-            <a:r>
-              <a:rPr sz="1600" b="1">
-                <a:solidFill>
-                  <a:srgbClr val="1F2933"/>
-                </a:solidFill>
-                <a:latin typeface="Calibri"/>
-              </a:rPr>
-              <a:t>Excerpt of a generated context pack</a:t>
-            </a:r>
-          </a:p>
-          <a:p>
-            <a:pPr algn="ctr"/>
-            <a:r>
-              <a:rPr sz="1200" b="0">
-                <a:solidFill>
-                  <a:srgbClr val="5A6B7A"/>
-                </a:solidFill>
-                <a:latin typeface="Calibri"/>
-              </a:rPr>
-              <a:t>1–2 pages of the actual ARCHITECTURE.md and API-CONTRACTS.md generated by Claude Code for the pilot service, showing the level of detail and accuracy.</a:t>
+              <a:t>PITFALL: Transfer has TWO construction sites in execute() — update</a:t>
+            </a:r>
+          </a:p>
+          <a:p>
+            <a:pPr algn="l"/>
+            <a:r>
+              <a:rPr sz="1100" b="1">
+                <a:solidFill>
+                  <a:srgbClr val="B45E12"/>
+                </a:solidFill>
+                <a:latin typeface="Calibri"/>
+              </a:rPr>
+              <a:t>both or the field is silently null on one path.</a:t>
             </a:r>
           </a:p>
         </p:txBody>
@@ -11520,7 +12038,7 @@
                 </a:solidFill>
                 <a:latin typeface="Calibri"/>
               </a:rPr>
-              <a:t>Finding the best generation prompt</a:t>
+              <a:t>Finding the best generation prompt — underway</a:t>
             </a:r>
           </a:p>
         </p:txBody>
@@ -11533,7 +12051,7 @@
         </p:nvSpPr>
         <p:spPr>
           <a:xfrm>
-            <a:off x="548640" y="1463040"/>
+            <a:off x="548640" y="1417320"/>
             <a:ext cx="11155680" cy="502920"/>
           </a:xfrm>
           <a:prstGeom prst="rect">
@@ -11549,13 +12067,13 @@
           <a:p>
             <a:pPr algn="l"/>
             <a:r>
-              <a:rPr sz="1500" b="0">
+              <a:rPr sz="1400" b="0">
                 <a:solidFill>
                   <a:srgbClr val="5A6B7A"/>
                 </a:solidFill>
                 <a:latin typeface="Calibri"/>
               </a:rPr>
-              <a:t>We don't assume the first prompt is right. We run a short, structured trial-and-error loop per file type.</a:t>
+              <a:t>Not hypothetical: five prompt strategies are written, and all five packs have been generated against a sample Spring Boot payments service.</a:t>
             </a:r>
           </a:p>
         </p:txBody>
@@ -11568,8 +12086,8 @@
         </p:nvSpPr>
         <p:spPr>
           <a:xfrm>
-            <a:off x="548640" y="2148840"/>
-            <a:ext cx="2606040" cy="1371600"/>
+            <a:off x="548640" y="2057400"/>
+            <a:ext cx="2148840" cy="1691640"/>
           </a:xfrm>
           <a:prstGeom prst="roundRect">
             <a:avLst>
@@ -11606,83 +12124,51 @@
           <a:p>
             <a:pPr algn="l"/>
             <a:r>
-              <a:rPr sz="1500" b="1">
+              <a:rPr sz="1250" b="1">
                 <a:solidFill>
                   <a:srgbClr val="0E63B0"/>
                 </a:solidFill>
                 <a:latin typeface="Calibri"/>
               </a:rPr>
-              <a:t>Draft</a:t>
-            </a:r>
-          </a:p>
-          <a:p>
-            <a:pPr algn="l"/>
-            <a:r>
-              <a:rPr sz="1200" b="0">
+              <a:t>1 · Structured spec</a:t>
+            </a:r>
+          </a:p>
+          <a:p>
+            <a:pPr algn="l"/>
+            <a:r>
+              <a:rPr sz="1050" b="0">
                 <a:solidFill>
                   <a:srgbClr val="1F2933"/>
                 </a:solidFill>
                 <a:latin typeface="Calibri"/>
               </a:rPr>
-              <a:t>2–3 candidate prompts per context file type</a:t>
-            </a:r>
-          </a:p>
-        </p:txBody>
-      </p:sp>
-      <p:sp>
-        <p:nvSpPr>
-          <p:cNvPr id="6" name="Right Arrow 5"/>
+              <a:t>Fixed 11-file specification</a:t>
+            </a:r>
+          </a:p>
+          <a:p>
+            <a:pPr algn="l"/>
+            <a:r>
+              <a:rPr sz="1050" b="1">
+                <a:solidFill>
+                  <a:srgbClr val="5A6B7A"/>
+                </a:solidFill>
+                <a:latin typeface="Calibri"/>
+              </a:rPr>
+              <a:t>~5.4k tokens</a:t>
+            </a:r>
+          </a:p>
+        </p:txBody>
+      </p:sp>
+      <p:sp>
+        <p:nvSpPr>
+          <p:cNvPr id="6" name="Rounded Rectangle 5"/>
           <p:cNvSpPr/>
           <p:nvPr/>
         </p:nvSpPr>
         <p:spPr>
           <a:xfrm>
-            <a:off x="3154680" y="2697480"/>
-            <a:ext cx="320040" cy="256032"/>
-          </a:xfrm>
-          <a:prstGeom prst="rightArrow">
-            <a:avLst/>
-          </a:prstGeom>
-          <a:solidFill>
-            <a:srgbClr val="0E63B0"/>
-          </a:solidFill>
-          <a:ln>
-            <a:noFill/>
-          </a:ln>
-          <a:effectLst/>
-        </p:spPr>
-        <p:style>
-          <a:lnRef idx="1">
-            <a:schemeClr val="accent1"/>
-          </a:lnRef>
-          <a:fillRef idx="3">
-            <a:schemeClr val="accent1"/>
-          </a:fillRef>
-          <a:effectRef idx="2">
-            <a:schemeClr val="accent1"/>
-          </a:effectRef>
-          <a:fontRef idx="minor">
-            <a:schemeClr val="lt1"/>
-          </a:fontRef>
-        </p:style>
-        <p:txBody>
-          <a:bodyPr rtlCol="0" anchor="ctr"/>
-          <a:lstStyle/>
-          <a:p>
-            <a:pPr algn="ctr"/>
-          </a:p>
-        </p:txBody>
-      </p:sp>
-      <p:sp>
-        <p:nvSpPr>
-          <p:cNvPr id="7" name="Rounded Rectangle 6"/>
-          <p:cNvSpPr/>
-          <p:nvPr/>
-        </p:nvSpPr>
-        <p:spPr>
-          <a:xfrm>
-            <a:off x="3474720" y="2148840"/>
-            <a:ext cx="2606040" cy="1371600"/>
+            <a:off x="2862072" y="2057400"/>
+            <a:ext cx="2148840" cy="1691640"/>
           </a:xfrm>
           <a:prstGeom prst="roundRect">
             <a:avLst>
@@ -11719,83 +12205,51 @@
           <a:p>
             <a:pPr algn="l"/>
             <a:r>
-              <a:rPr sz="1500" b="1">
+              <a:rPr sz="1250" b="1">
                 <a:solidFill>
                   <a:srgbClr val="0E63B0"/>
                 </a:solidFill>
                 <a:latin typeface="Calibri"/>
               </a:rPr>
-              <a:t>Generate</a:t>
-            </a:r>
-          </a:p>
-          <a:p>
-            <a:pPr algn="l"/>
-            <a:r>
-              <a:rPr sz="1200" b="0">
+              <a:t>2 · Tech-lead persona</a:t>
+            </a:r>
+          </a:p>
+          <a:p>
+            <a:pPr algn="l"/>
+            <a:r>
+              <a:rPr sz="1050" b="0">
                 <a:solidFill>
                   <a:srgbClr val="1F2933"/>
                 </a:solidFill>
                 <a:latin typeface="Calibri"/>
               </a:rPr>
-              <a:t>Run each prompt with Claude Code on the pilot service</a:t>
-            </a:r>
-          </a:p>
-        </p:txBody>
-      </p:sp>
-      <p:sp>
-        <p:nvSpPr>
-          <p:cNvPr id="8" name="Right Arrow 7"/>
+              <a:t>Onboarding-brief style, AI picks structure</a:t>
+            </a:r>
+          </a:p>
+          <a:p>
+            <a:pPr algn="l"/>
+            <a:r>
+              <a:rPr sz="1050" b="1">
+                <a:solidFill>
+                  <a:srgbClr val="5A6B7A"/>
+                </a:solidFill>
+                <a:latin typeface="Calibri"/>
+              </a:rPr>
+              <a:t>~2.7k tokens</a:t>
+            </a:r>
+          </a:p>
+        </p:txBody>
+      </p:sp>
+      <p:sp>
+        <p:nvSpPr>
+          <p:cNvPr id="7" name="Rounded Rectangle 6"/>
           <p:cNvSpPr/>
           <p:nvPr/>
         </p:nvSpPr>
         <p:spPr>
           <a:xfrm>
-            <a:off x="6080760" y="2697480"/>
-            <a:ext cx="320040" cy="256032"/>
-          </a:xfrm>
-          <a:prstGeom prst="rightArrow">
-            <a:avLst/>
-          </a:prstGeom>
-          <a:solidFill>
-            <a:srgbClr val="0E63B0"/>
-          </a:solidFill>
-          <a:ln>
-            <a:noFill/>
-          </a:ln>
-          <a:effectLst/>
-        </p:spPr>
-        <p:style>
-          <a:lnRef idx="1">
-            <a:schemeClr val="accent1"/>
-          </a:lnRef>
-          <a:fillRef idx="3">
-            <a:schemeClr val="accent1"/>
-          </a:fillRef>
-          <a:effectRef idx="2">
-            <a:schemeClr val="accent1"/>
-          </a:effectRef>
-          <a:fontRef idx="minor">
-            <a:schemeClr val="lt1"/>
-          </a:fontRef>
-        </p:style>
-        <p:txBody>
-          <a:bodyPr rtlCol="0" anchor="ctr"/>
-          <a:lstStyle/>
-          <a:p>
-            <a:pPr algn="ctr"/>
-          </a:p>
-        </p:txBody>
-      </p:sp>
-      <p:sp>
-        <p:nvSpPr>
-          <p:cNvPr id="9" name="Rounded Rectangle 8"/>
-          <p:cNvSpPr/>
-          <p:nvPr/>
-        </p:nvSpPr>
-        <p:spPr>
-          <a:xfrm>
-            <a:off x="6400800" y="2148840"/>
-            <a:ext cx="2606040" cy="1371600"/>
+            <a:off x="5175504" y="2057400"/>
+            <a:ext cx="2148840" cy="1691640"/>
           </a:xfrm>
           <a:prstGeom prst="roundRect">
             <a:avLst>
@@ -11832,83 +12286,51 @@
           <a:p>
             <a:pPr algn="l"/>
             <a:r>
-              <a:rPr sz="1500" b="1">
+              <a:rPr sz="1250" b="1">
                 <a:solidFill>
                   <a:srgbClr val="0E63B0"/>
                 </a:solidFill>
                 <a:latin typeface="Calibri"/>
               </a:rPr>
-              <a:t>Score</a:t>
-            </a:r>
-          </a:p>
-          <a:p>
-            <a:pPr algn="l"/>
-            <a:r>
-              <a:rPr sz="1200" b="0">
+              <a:t>3 · Compact budget</a:t>
+            </a:r>
+          </a:p>
+          <a:p>
+            <a:pPr algn="l"/>
+            <a:r>
+              <a:rPr sz="1050" b="0">
                 <a:solidFill>
                   <a:srgbClr val="1F2933"/>
                 </a:solidFill>
                 <a:latin typeface="Calibri"/>
               </a:rPr>
-              <a:t>Grade outputs against fixed criteria</a:t>
-            </a:r>
-          </a:p>
-        </p:txBody>
-      </p:sp>
-      <p:sp>
-        <p:nvSpPr>
-          <p:cNvPr id="10" name="Right Arrow 9"/>
+              <a:t>3 dense files, hard token cap</a:t>
+            </a:r>
+          </a:p>
+          <a:p>
+            <a:pPr algn="l"/>
+            <a:r>
+              <a:rPr sz="1050" b="1">
+                <a:solidFill>
+                  <a:srgbClr val="5A6B7A"/>
+                </a:solidFill>
+                <a:latin typeface="Calibri"/>
+              </a:rPr>
+              <a:t>~1.7k tokens</a:t>
+            </a:r>
+          </a:p>
+        </p:txBody>
+      </p:sp>
+      <p:sp>
+        <p:nvSpPr>
+          <p:cNvPr id="8" name="Rounded Rectangle 7"/>
           <p:cNvSpPr/>
           <p:nvPr/>
         </p:nvSpPr>
         <p:spPr>
           <a:xfrm>
-            <a:off x="9006840" y="2697480"/>
-            <a:ext cx="320040" cy="256032"/>
-          </a:xfrm>
-          <a:prstGeom prst="rightArrow">
-            <a:avLst/>
-          </a:prstGeom>
-          <a:solidFill>
-            <a:srgbClr val="0E63B0"/>
-          </a:solidFill>
-          <a:ln>
-            <a:noFill/>
-          </a:ln>
-          <a:effectLst/>
-        </p:spPr>
-        <p:style>
-          <a:lnRef idx="1">
-            <a:schemeClr val="accent1"/>
-          </a:lnRef>
-          <a:fillRef idx="3">
-            <a:schemeClr val="accent1"/>
-          </a:fillRef>
-          <a:effectRef idx="2">
-            <a:schemeClr val="accent1"/>
-          </a:effectRef>
-          <a:fontRef idx="minor">
-            <a:schemeClr val="lt1"/>
-          </a:fontRef>
-        </p:style>
-        <p:txBody>
-          <a:bodyPr rtlCol="0" anchor="ctr"/>
-          <a:lstStyle/>
-          <a:p>
-            <a:pPr algn="ctr"/>
-          </a:p>
-        </p:txBody>
-      </p:sp>
-      <p:sp>
-        <p:nvSpPr>
-          <p:cNvPr id="11" name="Rounded Rectangle 10"/>
-          <p:cNvSpPr/>
-          <p:nvPr/>
-        </p:nvSpPr>
-        <p:spPr>
-          <a:xfrm>
-            <a:off x="9326880" y="2148840"/>
-            <a:ext cx="2606040" cy="1371600"/>
+            <a:off x="7488936" y="2057400"/>
+            <a:ext cx="2148840" cy="1691640"/>
           </a:xfrm>
           <a:prstGeom prst="roundRect">
             <a:avLst>
@@ -11945,39 +12367,132 @@
           <a:p>
             <a:pPr algn="l"/>
             <a:r>
-              <a:rPr sz="1500" b="1">
+              <a:rPr sz="1250" b="1">
                 <a:solidFill>
                   <a:srgbClr val="0E63B0"/>
                 </a:solidFill>
                 <a:latin typeface="Calibri"/>
               </a:rPr>
-              <a:t>Refine</a:t>
-            </a:r>
-          </a:p>
-          <a:p>
-            <a:pPr algn="l"/>
-            <a:r>
-              <a:rPr sz="1200" b="0">
+              <a:t>4 · Task cookbook</a:t>
+            </a:r>
+          </a:p>
+          <a:p>
+            <a:pPr algn="l"/>
+            <a:r>
+              <a:rPr sz="1050" b="0">
                 <a:solidFill>
                   <a:srgbClr val="1F2933"/>
                 </a:solidFill>
                 <a:latin typeface="Calibri"/>
               </a:rPr>
-              <a:t>Keep the winner, fix its weaknesses, re-run</a:t>
-            </a:r>
-          </a:p>
-        </p:txBody>
-      </p:sp>
-      <p:sp>
-        <p:nvSpPr>
-          <p:cNvPr id="12" name="Rounded Rectangle 11"/>
+              <a:t>Recipes for each change type + FAQ</a:t>
+            </a:r>
+          </a:p>
+          <a:p>
+            <a:pPr algn="l"/>
+            <a:r>
+              <a:rPr sz="1050" b="1">
+                <a:solidFill>
+                  <a:srgbClr val="5A6B7A"/>
+                </a:solidFill>
+                <a:latin typeface="Calibri"/>
+              </a:rPr>
+              <a:t>~3.6k tokens</a:t>
+            </a:r>
+          </a:p>
+        </p:txBody>
+      </p:sp>
+      <p:sp>
+        <p:nvSpPr>
+          <p:cNvPr id="9" name="Rounded Rectangle 8"/>
           <p:cNvSpPr/>
           <p:nvPr/>
         </p:nvSpPr>
         <p:spPr>
           <a:xfrm>
-            <a:off x="548640" y="3840480"/>
-            <a:ext cx="11201400" cy="2468880"/>
+            <a:off x="9802368" y="2057400"/>
+            <a:ext cx="2148840" cy="1691640"/>
+          </a:xfrm>
+          <a:prstGeom prst="roundRect">
+            <a:avLst>
+              <a:gd name="adj" fmla="val 6000"/>
+            </a:avLst>
+          </a:prstGeom>
+          <a:solidFill>
+            <a:srgbClr val="F4F7FA"/>
+          </a:solidFill>
+          <a:ln w="15875">
+            <a:solidFill>
+              <a:srgbClr val="0E63B0"/>
+            </a:solidFill>
+          </a:ln>
+          <a:effectLst/>
+        </p:spPr>
+        <p:style>
+          <a:lnRef idx="1">
+            <a:schemeClr val="accent1"/>
+          </a:lnRef>
+          <a:fillRef idx="3">
+            <a:schemeClr val="accent1"/>
+          </a:fillRef>
+          <a:effectRef idx="2">
+            <a:schemeClr val="accent1"/>
+          </a:effectRef>
+          <a:fontRef idx="minor">
+            <a:schemeClr val="lt1"/>
+          </a:fontRef>
+        </p:style>
+        <p:txBody>
+          <a:bodyPr rtlCol="0" anchor="t" lIns="164592" rIns="164592" tIns="109728" bIns="109728" wrap="square"/>
+          <a:lstStyle/>
+          <a:p>
+            <a:pPr algn="l"/>
+            <a:r>
+              <a:rPr sz="1250" b="1">
+                <a:solidFill>
+                  <a:srgbClr val="0E63B0"/>
+                </a:solidFill>
+                <a:latin typeface="Calibri"/>
+              </a:rPr>
+              <a:t>5 · Self-critique</a:t>
+            </a:r>
+          </a:p>
+          <a:p>
+            <a:pPr algn="l"/>
+            <a:r>
+              <a:rPr sz="1050" b="0">
+                <a:solidFill>
+                  <a:srgbClr val="1F2933"/>
+                </a:solidFill>
+                <a:latin typeface="Calibri"/>
+              </a:rPr>
+              <a:t>Generate, adversarially self-test, patch</a:t>
+            </a:r>
+          </a:p>
+          <a:p>
+            <a:pPr algn="l"/>
+            <a:r>
+              <a:rPr sz="1050" b="1">
+                <a:solidFill>
+                  <a:srgbClr val="5A6B7A"/>
+                </a:solidFill>
+                <a:latin typeface="Calibri"/>
+              </a:rPr>
+              <a:t>~6.4k tokens</a:t>
+            </a:r>
+          </a:p>
+        </p:txBody>
+      </p:sp>
+      <p:sp>
+        <p:nvSpPr>
+          <p:cNvPr id="10" name="Rounded Rectangle 9"/>
+          <p:cNvSpPr/>
+          <p:nvPr/>
+        </p:nvSpPr>
+        <p:spPr>
+          <a:xfrm>
+            <a:off x="548640" y="4069080"/>
+            <a:ext cx="11201400" cy="2194560"/>
           </a:xfrm>
           <a:prstGeom prst="roundRect">
             <a:avLst>
@@ -12012,80 +12527,80 @@
           <a:p>
             <a:pPr algn="l"/>
             <a:r>
-              <a:rPr sz="1500" b="1">
+              <a:rPr sz="1400" b="1">
                 <a:solidFill>
                   <a:srgbClr val="0A467E"/>
                 </a:solidFill>
                 <a:latin typeface="Calibri"/>
               </a:rPr>
-              <a:t>Evaluation criteria (scored per candidate)</a:t>
-            </a:r>
-          </a:p>
-          <a:p>
-            <a:pPr algn="l"/>
-            <a:r>
-              <a:rPr sz="1300" b="0">
+              <a:t>Evaluation criteria (each variant scored on)</a:t>
+            </a:r>
+          </a:p>
+          <a:p>
+            <a:pPr algn="l"/>
+            <a:r>
+              <a:rPr sz="1250" b="0">
                 <a:solidFill>
                   <a:srgbClr val="1F2933"/>
                 </a:solidFill>
                 <a:latin typeface="Calibri"/>
               </a:rPr>
-              <a:t>• Accuracy — does it match the real code? (spot-checked by the service's developers)</a:t>
-            </a:r>
-          </a:p>
-          <a:p>
-            <a:pPr algn="l"/>
-            <a:r>
-              <a:rPr sz="1300" b="0">
+              <a:t>• Accuracy — 30-symbol spot check vs the real code   • Completeness — endpoints, entities, conventions, gotchas</a:t>
+            </a:r>
+          </a:p>
+          <a:p>
+            <a:pPr algn="l"/>
+            <a:r>
+              <a:rPr sz="1250" b="0">
                 <a:solidFill>
                   <a:srgbClr val="1F2933"/>
                 </a:solidFill>
                 <a:latin typeface="Calibri"/>
               </a:rPr>
-              <a:t>• Completeness — endpoints, entities, conventions all covered</a:t>
-            </a:r>
-          </a:p>
-          <a:p>
-            <a:pPr algn="l"/>
-            <a:r>
-              <a:rPr sz="1300" b="0">
+              <a:t>• Size — fits Duo/Copilot context with headroom for conversation   • Hygiene — zero secrets/hostnames</a:t>
+            </a:r>
+          </a:p>
+          <a:p>
+            <a:pPr algn="l"/>
+            <a:r>
+              <a:rPr sz="1250" b="0">
                 <a:solidFill>
                   <a:srgbClr val="1F2933"/>
                 </a:solidFill>
                 <a:latin typeface="Calibri"/>
               </a:rPr>
-              <a:t>• Size — fits Duo and Copilot attachment / context limits with room for a conversation</a:t>
-            </a:r>
-          </a:p>
-          <a:p>
-            <a:pPr algn="l"/>
-            <a:r>
-              <a:rPr sz="1300" b="0">
+              <a:t>• Usefulness — fixed Q&amp;A set + a feature task run in real Duo sessions   • Workflow — plan/approve/execute behaviour holds</a:t>
+            </a:r>
+          </a:p>
+          <a:p>
+            <a:pPr algn="l"/>
+            <a:r>
+              <a:rPr sz="400" b="0">
                 <a:solidFill>
                   <a:srgbClr val="1F2933"/>
                 </a:solidFill>
                 <a:latin typeface="Calibri"/>
               </a:rPr>
-              <a:t>• Usefulness — does a Duo/Copilot session with this file answer service-specific questions correctly?</a:t>
-            </a:r>
-          </a:p>
-          <a:p>
-            <a:pPr algn="l"/>
-            <a:r>
-              <a:rPr sz="1300" b="0">
-                <a:solidFill>
-                  <a:srgbClr val="1F2933"/>
-                </a:solidFill>
-                <a:latin typeface="Calibri"/>
-              </a:rPr>
-              <a:t>• Regenerability — same prompt on updated code produces a cleanly updated file</a:t>
-            </a:r>
-          </a:p>
-        </p:txBody>
-      </p:sp>
-      <p:sp>
-        <p:nvSpPr>
-          <p:cNvPr id="13" name="TextBox 12"/>
+              <a:t/>
+            </a:r>
+          </a:p>
+          <a:p>
+            <a:pPr algn="l"/>
+            <a:r>
+              <a:rPr sz="1300" b="1">
+                <a:solidFill>
+                  <a:srgbClr val="1E7A45"/>
+                </a:solidFill>
+                <a:latin typeface="Calibri"/>
+              </a:rPr>
+              <a:t>Status: objective checks (accuracy, size, hygiene, coverage) complete for all five — Duo session testing is next.</a:t>
+            </a:r>
+          </a:p>
+        </p:txBody>
+      </p:sp>
+      <p:sp>
+        <p:nvSpPr>
+          <p:cNvPr id="11" name="TextBox 10"/>
           <p:cNvSpPr txBox="1"/>
           <p:nvPr/>
         </p:nvSpPr>

</xml_diff>

<commit_message>
Replace SAFe rollout framing with squad-focused slides
Removed all SAFe/PI/enabler/spike terminology. New slide 16 shows what
context packs give developers, testers and devops within a squad; new
slide 17 maps adoption across the 4 delivery squads and the release
squad with three plain next steps and pilot metrics. Ask and summary
reworded to sprints and pilot-squad language; speaker notes updated.

Co-Authored-By: Claude Fable 5 <noreply@anthropic.com>
Claude-Session: https://claude.ai/code/session_01BzhS5vhV791L3z5LF6C3UY
</commit_message>
<xml_diff>
--- a/deck/claude2duo-context-packs.pptx
+++ b/deck/claude2duo-context-packs.pptx
@@ -23,6 +23,7 @@
     <p:sldId id="271" r:id="rId22"/>
     <p:sldId id="272" r:id="rId23"/>
     <p:sldId id="273" r:id="rId24"/>
+    <p:sldId id="274" r:id="rId25"/>
   </p:sldIdLst>
   <p:sldSz cx="12191695" cy="6858000" type="screen4x3"/>
   <p:notesSz cx="6858000" cy="9144000"/>
@@ -4574,7 +4575,7 @@
                 </a:solidFill>
                 <a:latin typeface="Calibri"/>
               </a:rPr>
-              <a:t>Regenerate once per PI as a routine enabler task, plus ad-hoc after significant merges to a service.</a:t>
+              <a:t>Regenerate on a regular rhythm (e.g. each sprint or each release), plus ad-hoc after significant merges to a service.</a:t>
             </a:r>
           </a:p>
         </p:txBody>
@@ -5591,7 +5592,7 @@
                 </a:solidFill>
                 <a:latin typeface="Calibri"/>
               </a:rPr>
-              <a:t>Prompts and templates improve every iteration and apply to every new service.</a:t>
+              <a:t>Prompts and templates keep improving and apply to every new service.</a:t>
             </a:r>
           </a:p>
         </p:txBody>
@@ -5658,7 +5659,7 @@
                 </a:solidFill>
                 <a:latin typeface="Calibri"/>
               </a:rPr>
-              <a:t>A time-boxed spike by the licensed devs; no procurement, no platform work.</a:t>
+              <a:t>A small time-boxed experiment — and most of it is already done; no procurement, no platform work.</a:t>
             </a:r>
           </a:p>
         </p:txBody>
@@ -5909,7 +5910,7 @@
                           </a:solidFill>
                           <a:latin typeface="Calibri"/>
                         </a:rPr>
-                        <a:t>Per-PI regeneration cadence; generated-on date + commit hash in every pack; regeneration is one command</a:t>
+                        <a:t>Regular regeneration cadence; generated-on date + commit hash in every pack; regeneration is one command</a:t>
                       </a:r>
                     </a:p>
                   </a:txBody>
@@ -6001,7 +6002,7 @@
                           </a:solidFill>
                           <a:latin typeface="Calibri"/>
                         </a:rPr>
-                        <a:t>Size is an explicit evaluation criterion; split or trim files per tool limits during the spike</a:t>
+                        <a:t>Size is an explicit evaluation criterion; split or trim files per tool limits during validation</a:t>
                       </a:r>
                     </a:p>
                   </a:txBody>
@@ -6047,7 +6048,7 @@
                           </a:solidFill>
                           <a:latin typeface="Calibri"/>
                         </a:rPr>
-                        <a:t>Generation is automated; effort is minutes per service per PI, tracked as enabler work</a:t>
+                        <a:t>Generation is automated; effort is minutes per service per cycle, planned as routine squad work</a:t>
                       </a:r>
                     </a:p>
                   </a:txBody>
@@ -6234,7 +6235,7 @@
                 </a:solidFill>
                 <a:latin typeface="Calibri"/>
               </a:rPr>
-              <a:t>ROLLOUT PLAN</a:t>
+              <a:t>OUR TEAM</a:t>
             </a:r>
           </a:p>
           <a:p>
@@ -6246,7 +6247,7 @@
                 </a:solidFill>
                 <a:latin typeface="Calibri"/>
               </a:rPr>
-              <a:t>Rollout, the SAFe way</a:t>
+              <a:t>What this gives each role in a squad</a:t>
             </a:r>
           </a:p>
         </p:txBody>
@@ -6259,8 +6260,101 @@
         </p:nvSpPr>
         <p:spPr>
           <a:xfrm>
-            <a:off x="548640" y="1783080"/>
-            <a:ext cx="2606040" cy="2377440"/>
+            <a:off x="548640" y="1691640"/>
+            <a:ext cx="3611880" cy="3291840"/>
+          </a:xfrm>
+          <a:prstGeom prst="roundRect">
+            <a:avLst>
+              <a:gd name="adj" fmla="val 6000"/>
+            </a:avLst>
+          </a:prstGeom>
+          <a:solidFill>
+            <a:srgbClr val="F4F7FA"/>
+          </a:solidFill>
+          <a:ln w="15875">
+            <a:solidFill>
+              <a:srgbClr val="0E63B0"/>
+            </a:solidFill>
+          </a:ln>
+          <a:effectLst/>
+        </p:spPr>
+        <p:style>
+          <a:lnRef idx="1">
+            <a:schemeClr val="accent1"/>
+          </a:lnRef>
+          <a:fillRef idx="3">
+            <a:schemeClr val="accent1"/>
+          </a:fillRef>
+          <a:effectRef idx="2">
+            <a:schemeClr val="accent1"/>
+          </a:effectRef>
+          <a:fontRef idx="minor">
+            <a:schemeClr val="lt1"/>
+          </a:fontRef>
+        </p:style>
+        <p:txBody>
+          <a:bodyPr rtlCol="0" anchor="t" lIns="164592" rIns="164592" tIns="109728" bIns="109728" wrap="square"/>
+          <a:lstStyle/>
+          <a:p>
+            <a:pPr algn="l"/>
+            <a:r>
+              <a:rPr sz="1600" b="1">
+                <a:solidFill>
+                  <a:srgbClr val="0E63B0"/>
+                </a:solidFill>
+                <a:latin typeface="Calibri"/>
+              </a:rPr>
+              <a:t>Developers</a:t>
+            </a:r>
+          </a:p>
+          <a:p>
+            <a:pPr algn="l"/>
+            <a:r>
+              <a:rPr sz="1200" b="0">
+                <a:solidFill>
+                  <a:srgbClr val="1F2933"/>
+                </a:solidFill>
+                <a:latin typeface="Calibri"/>
+              </a:rPr>
+              <a:t>• Duo/Copilot answers in terms of OUR services — real classes, endpoints, conventions</a:t>
+            </a:r>
+          </a:p>
+          <a:p>
+            <a:pPr algn="l"/>
+            <a:r>
+              <a:rPr sz="1200" b="0">
+                <a:solidFill>
+                  <a:srgbClr val="1F2933"/>
+                </a:solidFill>
+                <a:latin typeface="Calibri"/>
+              </a:rPr>
+              <a:t>• Every change starts from a reviewed plan with step-by-step, paste-ready code</a:t>
+            </a:r>
+          </a:p>
+          <a:p>
+            <a:pPr algn="l"/>
+            <a:r>
+              <a:rPr sz="1200" b="0">
+                <a:solidFill>
+                  <a:srgbClr val="1F2933"/>
+                </a:solidFill>
+                <a:latin typeface="Calibri"/>
+              </a:rPr>
+              <a:t>• New joiners and cross-squad moves get productive on an unfamiliar service fast</a:t>
+            </a:r>
+          </a:p>
+        </p:txBody>
+      </p:sp>
+      <p:sp>
+        <p:nvSpPr>
+          <p:cNvPr id="5" name="Rounded Rectangle 4"/>
+          <p:cNvSpPr/>
+          <p:nvPr/>
+        </p:nvSpPr>
+        <p:spPr>
+          <a:xfrm>
+            <a:off x="4343400" y="1691640"/>
+            <a:ext cx="3611880" cy="3291840"/>
           </a:xfrm>
           <a:prstGeom prst="roundRect">
             <a:avLst>
@@ -6297,13 +6391,13 @@
           <a:p>
             <a:pPr algn="l"/>
             <a:r>
-              <a:rPr sz="1400" b="1">
+              <a:rPr sz="1600" b="1">
                 <a:solidFill>
                   <a:srgbClr val="1E7A45"/>
                 </a:solidFill>
                 <a:latin typeface="Calibri"/>
               </a:rPr>
-              <a:t>Spike — IN PROGRESS</a:t>
+              <a:t>Testers</a:t>
             </a:r>
           </a:p>
           <a:p>
@@ -6315,52 +6409,32 @@
                 </a:solidFill>
                 <a:latin typeface="Calibri"/>
               </a:rPr>
-              <a:t>5 prompt strategies written; 5 packs generated on a sample service; objective checks passed; Duo runs next</a:t>
-            </a:r>
-          </a:p>
-        </p:txBody>
-      </p:sp>
-      <p:sp>
-        <p:nvSpPr>
-          <p:cNvPr id="5" name="Right Arrow 4"/>
-          <p:cNvSpPr/>
-          <p:nvPr/>
-        </p:nvSpPr>
-        <p:spPr>
-          <a:xfrm>
-            <a:off x="3154680" y="2834640"/>
-            <a:ext cx="320040" cy="256032"/>
-          </a:xfrm>
-          <a:prstGeom prst="rightArrow">
-            <a:avLst/>
-          </a:prstGeom>
-          <a:solidFill>
-            <a:srgbClr val="0E63B0"/>
-          </a:solidFill>
-          <a:ln>
-            <a:noFill/>
-          </a:ln>
-          <a:effectLst/>
-        </p:spPr>
-        <p:style>
-          <a:lnRef idx="1">
-            <a:schemeClr val="accent1"/>
-          </a:lnRef>
-          <a:fillRef idx="3">
-            <a:schemeClr val="accent1"/>
-          </a:fillRef>
-          <a:effectRef idx="2">
-            <a:schemeClr val="accent1"/>
-          </a:effectRef>
-          <a:fontRef idx="minor">
-            <a:schemeClr val="lt1"/>
-          </a:fontRef>
-        </p:style>
-        <p:txBody>
-          <a:bodyPr rtlCol="0" anchor="ctr"/>
-          <a:lstStyle/>
-          <a:p>
-            <a:pPr algn="ctr"/>
+              <a:t>• Every AI plan includes a test plan section, in the repo's own test conventions</a:t>
+            </a:r>
+          </a:p>
+          <a:p>
+            <a:pPr algn="l"/>
+            <a:r>
+              <a:rPr sz="1200" b="0">
+                <a:solidFill>
+                  <a:srgbClr val="1F2933"/>
+                </a:solidFill>
+                <a:latin typeface="Calibri"/>
+              </a:rPr>
+              <a:t>• TESTING.md tells the AI (and the tester) the layers, fixtures and run commands</a:t>
+            </a:r>
+          </a:p>
+          <a:p>
+            <a:pPr algn="l"/>
+            <a:r>
+              <a:rPr sz="1200" b="0">
+                <a:solidFill>
+                  <a:srgbClr val="1F2933"/>
+                </a:solidFill>
+                <a:latin typeface="Calibri"/>
+              </a:rPr>
+              <a:t>• GOTCHAS.md turns tribal knowledge of fragile areas into explicit test targets</a:t>
+            </a:r>
           </a:p>
         </p:txBody>
       </p:sp>
@@ -6372,121 +6446,8 @@
         </p:nvSpPr>
         <p:spPr>
           <a:xfrm>
-            <a:off x="3474720" y="1783080"/>
-            <a:ext cx="2606040" cy="2377440"/>
-          </a:xfrm>
-          <a:prstGeom prst="roundRect">
-            <a:avLst>
-              <a:gd name="adj" fmla="val 6000"/>
-            </a:avLst>
-          </a:prstGeom>
-          <a:solidFill>
-            <a:srgbClr val="F4F7FA"/>
-          </a:solidFill>
-          <a:ln w="15875">
-            <a:solidFill>
-              <a:srgbClr val="0E63B0"/>
-            </a:solidFill>
-          </a:ln>
-          <a:effectLst/>
-        </p:spPr>
-        <p:style>
-          <a:lnRef idx="1">
-            <a:schemeClr val="accent1"/>
-          </a:lnRef>
-          <a:fillRef idx="3">
-            <a:schemeClr val="accent1"/>
-          </a:fillRef>
-          <a:effectRef idx="2">
-            <a:schemeClr val="accent1"/>
-          </a:effectRef>
-          <a:fontRef idx="minor">
-            <a:schemeClr val="lt1"/>
-          </a:fontRef>
-        </p:style>
-        <p:txBody>
-          <a:bodyPr rtlCol="0" anchor="t" lIns="164592" rIns="164592" tIns="109728" bIns="109728" wrap="square"/>
-          <a:lstStyle/>
-          <a:p>
-            <a:pPr algn="l"/>
-            <a:r>
-              <a:rPr sz="1400" b="1">
-                <a:solidFill>
-                  <a:srgbClr val="0E63B0"/>
-                </a:solidFill>
-                <a:latin typeface="Calibri"/>
-              </a:rPr>
-              <a:t>Pilot — one PI</a:t>
-            </a:r>
-          </a:p>
-          <a:p>
-            <a:pPr algn="l"/>
-            <a:r>
-              <a:rPr sz="1200" b="0">
-                <a:solidFill>
-                  <a:srgbClr val="1F2933"/>
-                </a:solidFill>
-                <a:latin typeface="Calibri"/>
-              </a:rPr>
-              <a:t>2–3 services; real feature work by non-licensed devs using packs + plan template; collect metrics</a:t>
-            </a:r>
-          </a:p>
-        </p:txBody>
-      </p:sp>
-      <p:sp>
-        <p:nvSpPr>
-          <p:cNvPr id="7" name="Right Arrow 6"/>
-          <p:cNvSpPr/>
-          <p:nvPr/>
-        </p:nvSpPr>
-        <p:spPr>
-          <a:xfrm>
-            <a:off x="6080760" y="2834640"/>
-            <a:ext cx="320040" cy="256032"/>
-          </a:xfrm>
-          <a:prstGeom prst="rightArrow">
-            <a:avLst/>
-          </a:prstGeom>
-          <a:solidFill>
-            <a:srgbClr val="0E63B0"/>
-          </a:solidFill>
-          <a:ln>
-            <a:noFill/>
-          </a:ln>
-          <a:effectLst/>
-        </p:spPr>
-        <p:style>
-          <a:lnRef idx="1">
-            <a:schemeClr val="accent1"/>
-          </a:lnRef>
-          <a:fillRef idx="3">
-            <a:schemeClr val="accent1"/>
-          </a:fillRef>
-          <a:effectRef idx="2">
-            <a:schemeClr val="accent1"/>
-          </a:effectRef>
-          <a:fontRef idx="minor">
-            <a:schemeClr val="lt1"/>
-          </a:fontRef>
-        </p:style>
-        <p:txBody>
-          <a:bodyPr rtlCol="0" anchor="ctr"/>
-          <a:lstStyle/>
-          <a:p>
-            <a:pPr algn="ctr"/>
-          </a:p>
-        </p:txBody>
-      </p:sp>
-      <p:sp>
-        <p:nvSpPr>
-          <p:cNvPr id="8" name="Rounded Rectangle 7"/>
-          <p:cNvSpPr/>
-          <p:nvPr/>
-        </p:nvSpPr>
-        <p:spPr>
-          <a:xfrm>
-            <a:off x="6400800" y="1783080"/>
-            <a:ext cx="2606040" cy="2377440"/>
+            <a:off x="8138160" y="1691640"/>
+            <a:ext cx="3611880" cy="3291840"/>
           </a:xfrm>
           <a:prstGeom prst="roundRect">
             <a:avLst>
@@ -6523,13 +6484,13 @@
           <a:p>
             <a:pPr algn="l"/>
             <a:r>
-              <a:rPr sz="1400" b="1">
+              <a:rPr sz="1600" b="1">
                 <a:solidFill>
                   <a:srgbClr val="B45E12"/>
                 </a:solidFill>
                 <a:latin typeface="Calibri"/>
               </a:rPr>
-              <a:t>Measure &amp; decide</a:t>
+              <a:t>DevOps</a:t>
             </a:r>
           </a:p>
           <a:p>
@@ -6541,27 +6502,53 @@
                 </a:solidFill>
                 <a:latin typeface="Calibri"/>
               </a:rPr>
-              <a:t>Review metrics + dev feedback at PI boundary; go / adjust / stop</a:t>
-            </a:r>
-          </a:p>
-        </p:txBody>
-      </p:sp>
-      <p:sp>
-        <p:nvSpPr>
-          <p:cNvPr id="9" name="Right Arrow 8"/>
+              <a:t>• CONFIG-PROFILES.md and DEPLOYMENT.md make config and deployment facts attachable</a:t>
+            </a:r>
+          </a:p>
+          <a:p>
+            <a:pPr algn="l"/>
+            <a:r>
+              <a:rPr sz="1200" b="0">
+                <a:solidFill>
+                  <a:srgbClr val="1F2933"/>
+                </a:solidFill>
+                <a:latin typeface="Calibri"/>
+              </a:rPr>
+              <a:t>• Every plan has an explicit config &amp; deployment impact section — no surprises late</a:t>
+            </a:r>
+          </a:p>
+          <a:p>
+            <a:pPr algn="l"/>
+            <a:r>
+              <a:rPr sz="1200" b="0">
+                <a:solidFill>
+                  <a:srgbClr val="1F2933"/>
+                </a:solidFill>
+                <a:latin typeface="Calibri"/>
+              </a:rPr>
+              <a:t>• Rollback notes are part of every plan by default</a:t>
+            </a:r>
+          </a:p>
+        </p:txBody>
+      </p:sp>
+      <p:sp>
+        <p:nvSpPr>
+          <p:cNvPr id="7" name="Rounded Rectangle 6"/>
           <p:cNvSpPr/>
           <p:nvPr/>
         </p:nvSpPr>
         <p:spPr>
           <a:xfrm>
-            <a:off x="9006840" y="2834640"/>
-            <a:ext cx="320040" cy="256032"/>
-          </a:xfrm>
-          <a:prstGeom prst="rightArrow">
-            <a:avLst/>
+            <a:off x="548640" y="5212080"/>
+            <a:ext cx="11201400" cy="1051560"/>
+          </a:xfrm>
+          <a:prstGeom prst="roundRect">
+            <a:avLst>
+              <a:gd name="adj" fmla="val 6000"/>
+            </a:avLst>
           </a:prstGeom>
           <a:solidFill>
-            <a:srgbClr val="0E63B0"/>
+            <a:srgbClr val="E3EEF8"/>
           </a:solidFill>
           <a:ln>
             <a:noFill/>
@@ -6583,188 +6570,34 @@
           </a:fontRef>
         </p:style>
         <p:txBody>
-          <a:bodyPr rtlCol="0" anchor="ctr"/>
-          <a:lstStyle/>
-          <a:p>
-            <a:pPr algn="ctr"/>
-          </a:p>
-        </p:txBody>
-      </p:sp>
-      <p:sp>
-        <p:nvSpPr>
-          <p:cNvPr id="10" name="Rounded Rectangle 9"/>
-          <p:cNvSpPr/>
-          <p:nvPr/>
-        </p:nvSpPr>
-        <p:spPr>
-          <a:xfrm>
-            <a:off x="9326880" y="1783080"/>
-            <a:ext cx="2606040" cy="2377440"/>
-          </a:xfrm>
-          <a:prstGeom prst="roundRect">
-            <a:avLst>
-              <a:gd name="adj" fmla="val 6000"/>
-            </a:avLst>
-          </a:prstGeom>
-          <a:solidFill>
-            <a:srgbClr val="F4F7FA"/>
-          </a:solidFill>
-          <a:ln w="15875">
-            <a:solidFill>
-              <a:srgbClr val="1E7A45"/>
-            </a:solidFill>
-          </a:ln>
-          <a:effectLst/>
-        </p:spPr>
-        <p:style>
-          <a:lnRef idx="1">
-            <a:schemeClr val="accent1"/>
-          </a:lnRef>
-          <a:fillRef idx="3">
-            <a:schemeClr val="accent1"/>
-          </a:fillRef>
-          <a:effectRef idx="2">
-            <a:schemeClr val="accent1"/>
-          </a:effectRef>
-          <a:fontRef idx="minor">
-            <a:schemeClr val="lt1"/>
-          </a:fontRef>
-        </p:style>
-        <p:txBody>
-          <a:bodyPr rtlCol="0" anchor="t" lIns="164592" rIns="164592" tIns="109728" bIns="109728" wrap="square"/>
+          <a:bodyPr rtlCol="0" anchor="ctr" lIns="164592" rIns="164592" tIns="109728" bIns="109728" wrap="square"/>
           <a:lstStyle/>
           <a:p>
             <a:pPr algn="l"/>
             <a:r>
               <a:rPr sz="1400" b="1">
                 <a:solidFill>
-                  <a:srgbClr val="1E7A45"/>
-                </a:solidFill>
-                <a:latin typeface="Calibri"/>
-              </a:rPr>
-              <a:t>Scale</a:t>
-            </a:r>
-          </a:p>
-          <a:p>
-            <a:pPr algn="l"/>
-            <a:r>
-              <a:rPr sz="1200" b="0">
+                  <a:srgbClr val="0A467E"/>
+                </a:solidFill>
+                <a:latin typeface="Calibri"/>
+              </a:rPr>
+              <a:t>No process change: </a:t>
+            </a:r>
+            <a:r>
+              <a:rPr sz="1400" b="0">
                 <a:solidFill>
                   <a:srgbClr val="1F2933"/>
                 </a:solidFill>
                 <a:latin typeface="Calibri"/>
               </a:rPr>
-              <a:t>Roll out to all services as enabler stories; per-PI regeneration becomes routine</a:t>
-            </a:r>
-          </a:p>
-        </p:txBody>
-      </p:sp>
-      <p:sp>
-        <p:nvSpPr>
-          <p:cNvPr id="11" name="Rounded Rectangle 10"/>
-          <p:cNvSpPr/>
-          <p:nvPr/>
-        </p:nvSpPr>
-        <p:spPr>
-          <a:xfrm>
-            <a:off x="548640" y="4526280"/>
-            <a:ext cx="11201400" cy="1737360"/>
-          </a:xfrm>
-          <a:prstGeom prst="roundRect">
-            <a:avLst>
-              <a:gd name="adj" fmla="val 6000"/>
-            </a:avLst>
-          </a:prstGeom>
-          <a:solidFill>
-            <a:srgbClr val="F4F7FA"/>
-          </a:solidFill>
-          <a:ln>
-            <a:noFill/>
-          </a:ln>
-          <a:effectLst/>
-        </p:spPr>
-        <p:style>
-          <a:lnRef idx="1">
-            <a:schemeClr val="accent1"/>
-          </a:lnRef>
-          <a:fillRef idx="3">
-            <a:schemeClr val="accent1"/>
-          </a:fillRef>
-          <a:effectRef idx="2">
-            <a:schemeClr val="accent1"/>
-          </a:effectRef>
-          <a:fontRef idx="minor">
-            <a:schemeClr val="lt1"/>
-          </a:fontRef>
-        </p:style>
-        <p:txBody>
-          <a:bodyPr rtlCol="0" anchor="t" lIns="164592" rIns="164592" tIns="109728" bIns="109728" wrap="square"/>
-          <a:lstStyle/>
-          <a:p>
-            <a:pPr algn="l"/>
-            <a:r>
-              <a:rPr sz="1500" b="1">
-                <a:solidFill>
-                  <a:srgbClr val="0A467E"/>
-                </a:solidFill>
-                <a:latin typeface="Calibri"/>
-              </a:rPr>
-              <a:t>Success metrics for the pilot</a:t>
-            </a:r>
-          </a:p>
-          <a:p>
-            <a:pPr algn="l"/>
-            <a:r>
-              <a:rPr sz="1300" b="0">
-                <a:solidFill>
-                  <a:srgbClr val="1F2933"/>
-                </a:solidFill>
-                <a:latin typeface="Calibri"/>
-              </a:rPr>
-              <a:t>• Pack load success rate in Duo and Copilot sessions (target: 100% of pilot packs)</a:t>
-            </a:r>
-          </a:p>
-          <a:p>
-            <a:pPr algn="l"/>
-            <a:r>
-              <a:rPr sz="1300" b="0">
-                <a:solidFill>
-                  <a:srgbClr val="1F2933"/>
-                </a:solidFill>
-                <a:latin typeface="Calibri"/>
-              </a:rPr>
-              <a:t>• Developer survey: usefulness of answers with vs without packs</a:t>
-            </a:r>
-          </a:p>
-          <a:p>
-            <a:pPr algn="l"/>
-            <a:r>
-              <a:rPr sz="1300" b="0">
-                <a:solidFill>
-                  <a:srgbClr val="1F2933"/>
-                </a:solidFill>
-                <a:latin typeface="Calibri"/>
-              </a:rPr>
-              <a:t>• Share of changes where the filled-in plan was usable with minor edits</a:t>
-            </a:r>
-          </a:p>
-          <a:p>
-            <a:pPr algn="l"/>
-            <a:r>
-              <a:rPr sz="1300" b="0">
-                <a:solidFill>
-                  <a:srgbClr val="1F2933"/>
-                </a:solidFill>
-                <a:latin typeface="Calibri"/>
-              </a:rPr>
-              <a:t>• Time-to-first-usable-answer on service-specific questions, before vs after</a:t>
-            </a:r>
-          </a:p>
-        </p:txBody>
-      </p:sp>
-      <p:sp>
-        <p:nvSpPr>
-          <p:cNvPr id="12" name="TextBox 11"/>
+              <a:t>squads keep their boards, their MR reviews and their definition of done. The packs and the plan template slot into how we already work — they just make the AI in the loop actually useful.</a:t>
+            </a:r>
+          </a:p>
+        </p:txBody>
+      </p:sp>
+      <p:sp>
+        <p:nvSpPr>
+          <p:cNvPr id="8" name="TextBox 7"/>
           <p:cNvSpPr txBox="1"/>
           <p:nvPr/>
         </p:nvSpPr>
@@ -6888,7 +6721,7 @@
                 </a:solidFill>
                 <a:latin typeface="Calibri"/>
               </a:rPr>
-              <a:t>THE ASK</a:t>
+              <a:t>OUR TEAM</a:t>
             </a:r>
           </a:p>
           <a:p>
@@ -6900,7 +6733,7 @@
                 </a:solidFill>
                 <a:latin typeface="Calibri"/>
               </a:rPr>
-              <a:t>What I'm asking for today</a:t>
+              <a:t>How it works across our squads</a:t>
             </a:r>
           </a:p>
         </p:txBody>
@@ -6913,8 +6746,8 @@
         </p:nvSpPr>
         <p:spPr>
           <a:xfrm>
-            <a:off x="548640" y="1783080"/>
-            <a:ext cx="5486400" cy="1463040"/>
+            <a:off x="548640" y="1691640"/>
+            <a:ext cx="1965960" cy="1965960"/>
           </a:xfrm>
           <a:prstGeom prst="roundRect">
             <a:avLst>
@@ -6951,25 +6784,25 @@
           <a:p>
             <a:pPr algn="l"/>
             <a:r>
-              <a:rPr sz="1600" b="1">
+              <a:rPr sz="1300" b="1">
                 <a:solidFill>
                   <a:srgbClr val="0E63B0"/>
                 </a:solidFill>
                 <a:latin typeface="Calibri"/>
               </a:rPr>
-              <a:t>Finish the spike</a:t>
-            </a:r>
-          </a:p>
-          <a:p>
-            <a:pPr algn="l"/>
-            <a:r>
-              <a:rPr sz="1300" b="0">
+              <a:t>Delivery squad 1</a:t>
+            </a:r>
+          </a:p>
+          <a:p>
+            <a:pPr algn="l"/>
+            <a:r>
+              <a:rPr sz="1050" b="0">
                 <a:solidFill>
                   <a:srgbClr val="1F2933"/>
                 </a:solidFill>
                 <a:latin typeface="Calibri"/>
               </a:rPr>
-              <a:t>Time to run the Duo validation sessions on the 5 generated packs and pick the winning prompt</a:t>
+              <a:t>Uses packs + plan template for feature work on its services; tester &amp; devops work from the same plan</a:t>
             </a:r>
           </a:p>
         </p:txBody>
@@ -6982,8 +6815,8 @@
         </p:nvSpPr>
         <p:spPr>
           <a:xfrm>
-            <a:off x="6263640" y="1783080"/>
-            <a:ext cx="5486400" cy="1463040"/>
+            <a:off x="2670048" y="1691640"/>
+            <a:ext cx="1965960" cy="1965960"/>
           </a:xfrm>
           <a:prstGeom prst="roundRect">
             <a:avLst>
@@ -7020,25 +6853,25 @@
           <a:p>
             <a:pPr algn="l"/>
             <a:r>
-              <a:rPr sz="1600" b="1">
+              <a:rPr sz="1300" b="1">
                 <a:solidFill>
                   <a:srgbClr val="0E63B0"/>
                 </a:solidFill>
                 <a:latin typeface="Calibri"/>
               </a:rPr>
-              <a:t>Time-box for licensed devs</a:t>
-            </a:r>
-          </a:p>
-          <a:p>
-            <a:pPr algn="l"/>
-            <a:r>
-              <a:rPr sz="1300" b="0">
+              <a:t>Delivery squad 2</a:t>
+            </a:r>
+          </a:p>
+          <a:p>
+            <a:pPr algn="l"/>
+            <a:r>
+              <a:rPr sz="1050" b="0">
                 <a:solidFill>
                   <a:srgbClr val="1F2933"/>
                 </a:solidFill>
                 <a:latin typeface="Calibri"/>
               </a:rPr>
-              <a:t>A few hours of Claude Code time to re-run the winner fresh and generate the first real pack</a:t>
+              <a:t>Uses packs + plan template for feature work on its services; tester &amp; devops work from the same plan</a:t>
             </a:r>
           </a:p>
         </p:txBody>
@@ -7051,8 +6884,8 @@
         </p:nvSpPr>
         <p:spPr>
           <a:xfrm>
-            <a:off x="548640" y="3474720"/>
-            <a:ext cx="5486400" cy="1463040"/>
+            <a:off x="4791456" y="1691640"/>
+            <a:ext cx="1965960" cy="1965960"/>
           </a:xfrm>
           <a:prstGeom prst="roundRect">
             <a:avLst>
@@ -7089,25 +6922,25 @@
           <a:p>
             <a:pPr algn="l"/>
             <a:r>
-              <a:rPr sz="1600" b="1">
+              <a:rPr sz="1300" b="1">
                 <a:solidFill>
                   <a:srgbClr val="0E63B0"/>
                 </a:solidFill>
                 <a:latin typeface="Calibri"/>
               </a:rPr>
-              <a:t>Nominate a pilot service</a:t>
-            </a:r>
-          </a:p>
-          <a:p>
-            <a:pPr algn="l"/>
-            <a:r>
-              <a:rPr sz="1300" b="0">
+              <a:t>Delivery squad 3</a:t>
+            </a:r>
+          </a:p>
+          <a:p>
+            <a:pPr algn="l"/>
+            <a:r>
+              <a:rPr sz="1050" b="0">
                 <a:solidFill>
                   <a:srgbClr val="1F2933"/>
                 </a:solidFill>
                 <a:latin typeface="Calibri"/>
               </a:rPr>
-              <a:t>One representative Spring Boot service (and later 2–3 for the PI pilot)</a:t>
+              <a:t>Uses packs + plan template for feature work on its services; tester &amp; devops work from the same plan</a:t>
             </a:r>
           </a:p>
         </p:txBody>
@@ -7120,8 +6953,8 @@
         </p:nvSpPr>
         <p:spPr>
           <a:xfrm>
-            <a:off x="6263640" y="3474720"/>
-            <a:ext cx="5486400" cy="1463040"/>
+            <a:off x="6912864" y="1691640"/>
+            <a:ext cx="1965960" cy="1965960"/>
           </a:xfrm>
           <a:prstGeom prst="roundRect">
             <a:avLst>
@@ -7158,25 +6991,25 @@
           <a:p>
             <a:pPr algn="l"/>
             <a:r>
-              <a:rPr sz="1600" b="1">
+              <a:rPr sz="1300" b="1">
                 <a:solidFill>
                   <a:srgbClr val="0E63B0"/>
                 </a:solidFill>
                 <a:latin typeface="Calibri"/>
               </a:rPr>
-              <a:t>Team commitment</a:t>
-            </a:r>
-          </a:p>
-          <a:p>
-            <a:pPr algn="l"/>
-            <a:r>
-              <a:rPr sz="1300" b="0">
+              <a:t>Delivery squad 4</a:t>
+            </a:r>
+          </a:p>
+          <a:p>
+            <a:pPr algn="l"/>
+            <a:r>
+              <a:rPr sz="1050" b="0">
                 <a:solidFill>
                   <a:srgbClr val="1F2933"/>
                 </a:solidFill>
                 <a:latin typeface="Calibri"/>
               </a:rPr>
-              <a:t>Pilot developers agree to use the packs on real tasks and give honest feedback</a:t>
+              <a:t>Uses packs + plan template for feature work on its services; tester &amp; devops work from the same plan</a:t>
             </a:r>
           </a:p>
         </p:txBody>
@@ -7189,8 +7022,8 @@
         </p:nvSpPr>
         <p:spPr>
           <a:xfrm>
-            <a:off x="548640" y="5440680"/>
-            <a:ext cx="11201400" cy="914400"/>
+            <a:off x="9189720" y="1691640"/>
+            <a:ext cx="2560320" cy="1965960"/>
           </a:xfrm>
           <a:prstGeom prst="roundRect">
             <a:avLst>
@@ -7198,7 +7031,76 @@
             </a:avLst>
           </a:prstGeom>
           <a:solidFill>
-            <a:srgbClr val="E3EEF8"/>
+            <a:srgbClr val="F4F7FA"/>
+          </a:solidFill>
+          <a:ln w="15875">
+            <a:solidFill>
+              <a:srgbClr val="1E7A45"/>
+            </a:solidFill>
+          </a:ln>
+          <a:effectLst/>
+        </p:spPr>
+        <p:style>
+          <a:lnRef idx="1">
+            <a:schemeClr val="accent1"/>
+          </a:lnRef>
+          <a:fillRef idx="3">
+            <a:schemeClr val="accent1"/>
+          </a:fillRef>
+          <a:effectRef idx="2">
+            <a:schemeClr val="accent1"/>
+          </a:effectRef>
+          <a:fontRef idx="minor">
+            <a:schemeClr val="lt1"/>
+          </a:fontRef>
+        </p:style>
+        <p:txBody>
+          <a:bodyPr rtlCol="0" anchor="t" lIns="164592" rIns="164592" tIns="109728" bIns="109728" wrap="square"/>
+          <a:lstStyle/>
+          <a:p>
+            <a:pPr algn="l"/>
+            <a:r>
+              <a:rPr sz="1300" b="1">
+                <a:solidFill>
+                  <a:srgbClr val="1E7A45"/>
+                </a:solidFill>
+                <a:latin typeface="Calibri"/>
+              </a:rPr>
+              <a:t>Release squad</a:t>
+            </a:r>
+          </a:p>
+          <a:p>
+            <a:pPr algn="l"/>
+            <a:r>
+              <a:rPr sz="1050" b="0">
+                <a:solidFill>
+                  <a:srgbClr val="1F2933"/>
+                </a:solidFill>
+                <a:latin typeface="Calibri"/>
+              </a:rPr>
+              <a:t>Reads the config &amp; deployment impact + rollback sections of every plan; DEPLOYMENT.md per service = one consistent release reference</a:t>
+            </a:r>
+          </a:p>
+        </p:txBody>
+      </p:sp>
+      <p:sp>
+        <p:nvSpPr>
+          <p:cNvPr id="9" name="Rounded Rectangle 8"/>
+          <p:cNvSpPr/>
+          <p:nvPr/>
+        </p:nvSpPr>
+        <p:spPr>
+          <a:xfrm>
+            <a:off x="548640" y="3886200"/>
+            <a:ext cx="6858000" cy="2377440"/>
+          </a:xfrm>
+          <a:prstGeom prst="roundRect">
+            <a:avLst>
+              <a:gd name="adj" fmla="val 6000"/>
+            </a:avLst>
+          </a:prstGeom>
+          <a:solidFill>
+            <a:srgbClr val="F4F7FA"/>
           </a:solidFill>
           <a:ln>
             <a:noFill/>
@@ -7220,7 +7122,7 @@
           </a:fontRef>
         </p:style>
         <p:txBody>
-          <a:bodyPr rtlCol="0" anchor="ctr" lIns="164592" rIns="164592" tIns="109728" bIns="109728" wrap="square"/>
+          <a:bodyPr rtlCol="0" anchor="t" lIns="164592" rIns="164592" tIns="109728" bIns="109728" wrap="square"/>
           <a:lstStyle/>
           <a:p>
             <a:pPr algn="l"/>
@@ -7231,14 +7133,165 @@
                 </a:solidFill>
                 <a:latin typeface="Calibri"/>
               </a:rPr>
-              <a:t>If the pilot doesn't prove itself in one PI, we stop — the only sunk cost is the spike, and we keep the generated documentation either way.</a:t>
-            </a:r>
-          </a:p>
-        </p:txBody>
-      </p:sp>
-      <p:sp>
-        <p:nvSpPr>
-          <p:cNvPr id="9" name="TextBox 8"/>
+              <a:t>Getting there — three small steps</a:t>
+            </a:r>
+          </a:p>
+          <a:p>
+            <a:pPr algn="l"/>
+            <a:r>
+              <a:rPr sz="1300" b="0">
+                <a:solidFill>
+                  <a:srgbClr val="1F2933"/>
+                </a:solidFill>
+                <a:latin typeface="Calibri"/>
+              </a:rPr>
+              <a:t>1. Finish the Duo validation of the 5 generated packs (protocol ready)</a:t>
+            </a:r>
+          </a:p>
+          <a:p>
+            <a:pPr algn="l"/>
+            <a:r>
+              <a:rPr sz="1300" b="0">
+                <a:solidFill>
+                  <a:srgbClr val="1F2933"/>
+                </a:solidFill>
+                <a:latin typeface="Calibri"/>
+              </a:rPr>
+              <a:t>2. Pilot with ONE delivery squad on 1–2 of its services, a few sprints</a:t>
+            </a:r>
+          </a:p>
+          <a:p>
+            <a:pPr algn="l"/>
+            <a:r>
+              <a:rPr sz="1300" b="0">
+                <a:solidFill>
+                  <a:srgbClr val="1F2933"/>
+                </a:solidFill>
+                <a:latin typeface="Calibri"/>
+              </a:rPr>
+              <a:t>3. If the metrics hold, generate packs for the remaining squads' services;</a:t>
+            </a:r>
+          </a:p>
+          <a:p>
+            <a:pPr algn="l"/>
+            <a:r>
+              <a:rPr sz="1300" b="0">
+                <a:solidFill>
+                  <a:srgbClr val="1F2933"/>
+                </a:solidFill>
+                <a:latin typeface="Calibri"/>
+              </a:rPr>
+              <a:t>    regeneration becomes a routine, minutes-per-service task</a:t>
+            </a:r>
+          </a:p>
+        </p:txBody>
+      </p:sp>
+      <p:sp>
+        <p:nvSpPr>
+          <p:cNvPr id="10" name="Rounded Rectangle 9"/>
+          <p:cNvSpPr/>
+          <p:nvPr/>
+        </p:nvSpPr>
+        <p:spPr>
+          <a:xfrm>
+            <a:off x="7635240" y="3886200"/>
+            <a:ext cx="4114800" cy="2377440"/>
+          </a:xfrm>
+          <a:prstGeom prst="roundRect">
+            <a:avLst>
+              <a:gd name="adj" fmla="val 6000"/>
+            </a:avLst>
+          </a:prstGeom>
+          <a:solidFill>
+            <a:srgbClr val="F4F7FA"/>
+          </a:solidFill>
+          <a:ln>
+            <a:noFill/>
+          </a:ln>
+          <a:effectLst/>
+        </p:spPr>
+        <p:style>
+          <a:lnRef idx="1">
+            <a:schemeClr val="accent1"/>
+          </a:lnRef>
+          <a:fillRef idx="3">
+            <a:schemeClr val="accent1"/>
+          </a:fillRef>
+          <a:effectRef idx="2">
+            <a:schemeClr val="accent1"/>
+          </a:effectRef>
+          <a:fontRef idx="minor">
+            <a:schemeClr val="lt1"/>
+          </a:fontRef>
+        </p:style>
+        <p:txBody>
+          <a:bodyPr rtlCol="0" anchor="t" lIns="164592" rIns="164592" tIns="109728" bIns="109728" wrap="square"/>
+          <a:lstStyle/>
+          <a:p>
+            <a:pPr algn="l"/>
+            <a:r>
+              <a:rPr sz="1500" b="1">
+                <a:solidFill>
+                  <a:srgbClr val="0A467E"/>
+                </a:solidFill>
+                <a:latin typeface="Calibri"/>
+              </a:rPr>
+              <a:t>Pilot success metrics</a:t>
+            </a:r>
+          </a:p>
+          <a:p>
+            <a:pPr algn="l"/>
+            <a:r>
+              <a:rPr sz="1200" b="0">
+                <a:solidFill>
+                  <a:srgbClr val="1F2933"/>
+                </a:solidFill>
+                <a:latin typeface="Calibri"/>
+              </a:rPr>
+              <a:t>• Packs load cleanly in Duo/Copilot</a:t>
+            </a:r>
+          </a:p>
+          <a:p>
+            <a:pPr algn="l"/>
+            <a:r>
+              <a:rPr sz="1200" b="0">
+                <a:solidFill>
+                  <a:srgbClr val="1F2933"/>
+                </a:solidFill>
+                <a:latin typeface="Calibri"/>
+              </a:rPr>
+              <a:t>• Squad survey: answers with vs without packs</a:t>
+            </a:r>
+          </a:p>
+          <a:p>
+            <a:pPr algn="l"/>
+            <a:r>
+              <a:rPr sz="1200" b="0">
+                <a:solidFill>
+                  <a:srgbClr val="1F2933"/>
+                </a:solidFill>
+                <a:latin typeface="Calibri"/>
+              </a:rPr>
+              <a:t>• Share of AI plans usable with minor edits</a:t>
+            </a:r>
+          </a:p>
+          <a:p>
+            <a:pPr algn="l"/>
+            <a:r>
+              <a:rPr sz="1200" b="0">
+                <a:solidFill>
+                  <a:srgbClr val="1F2933"/>
+                </a:solidFill>
+                <a:latin typeface="Calibri"/>
+              </a:rPr>
+              <a:t>• Time-to-first-usable-answer, before vs after</a:t>
+            </a:r>
+          </a:p>
+        </p:txBody>
+      </p:sp>
+      <p:sp>
+        <p:nvSpPr>
+          <p:cNvPr id="11" name="TextBox 10"/>
           <p:cNvSpPr txBox="1"/>
           <p:nvPr/>
         </p:nvSpPr>
@@ -7297,6 +7350,480 @@
         </p:nvSpPr>
         <p:spPr>
           <a:xfrm>
+            <a:off x="548640" y="502920"/>
+            <a:ext cx="502920" cy="82296"/>
+          </a:xfrm>
+          <a:prstGeom prst="rect">
+            <a:avLst/>
+          </a:prstGeom>
+          <a:solidFill>
+            <a:srgbClr val="0E63B0"/>
+          </a:solidFill>
+          <a:ln>
+            <a:noFill/>
+          </a:ln>
+        </p:spPr>
+        <p:style>
+          <a:lnRef idx="1">
+            <a:schemeClr val="accent1"/>
+          </a:lnRef>
+          <a:fillRef idx="3">
+            <a:schemeClr val="accent1"/>
+          </a:fillRef>
+          <a:effectRef idx="2">
+            <a:schemeClr val="accent1"/>
+          </a:effectRef>
+          <a:fontRef idx="minor">
+            <a:schemeClr val="lt1"/>
+          </a:fontRef>
+        </p:style>
+        <p:txBody>
+          <a:bodyPr rtlCol="0" anchor="ctr"/>
+          <a:lstStyle/>
+          <a:p>
+            <a:pPr algn="ctr"/>
+          </a:p>
+        </p:txBody>
+      </p:sp>
+      <p:sp>
+        <p:nvSpPr>
+          <p:cNvPr id="3" name="TextBox 2"/>
+          <p:cNvSpPr txBox="1"/>
+          <p:nvPr/>
+        </p:nvSpPr>
+        <p:spPr>
+          <a:xfrm>
+            <a:off x="548640" y="621792"/>
+            <a:ext cx="11064240" cy="914400"/>
+          </a:xfrm>
+          <a:prstGeom prst="rect">
+            <a:avLst/>
+          </a:prstGeom>
+          <a:noFill/>
+        </p:spPr>
+        <p:txBody>
+          <a:bodyPr wrap="square">
+            <a:spAutoFit/>
+          </a:bodyPr>
+          <a:lstStyle/>
+          <a:p>
+            <a:pPr algn="l"/>
+            <a:r>
+              <a:rPr sz="1200" b="1">
+                <a:solidFill>
+                  <a:srgbClr val="0E63B0"/>
+                </a:solidFill>
+                <a:latin typeface="Calibri"/>
+              </a:rPr>
+              <a:t>THE ASK</a:t>
+            </a:r>
+          </a:p>
+          <a:p>
+            <a:pPr algn="l"/>
+            <a:r>
+              <a:rPr sz="3000" b="1">
+                <a:solidFill>
+                  <a:srgbClr val="1F2933"/>
+                </a:solidFill>
+                <a:latin typeface="Calibri"/>
+              </a:rPr>
+              <a:t>What I'm asking for today</a:t>
+            </a:r>
+          </a:p>
+        </p:txBody>
+      </p:sp>
+      <p:sp>
+        <p:nvSpPr>
+          <p:cNvPr id="4" name="Rounded Rectangle 3"/>
+          <p:cNvSpPr/>
+          <p:nvPr/>
+        </p:nvSpPr>
+        <p:spPr>
+          <a:xfrm>
+            <a:off x="548640" y="1783080"/>
+            <a:ext cx="5486400" cy="1463040"/>
+          </a:xfrm>
+          <a:prstGeom prst="roundRect">
+            <a:avLst>
+              <a:gd name="adj" fmla="val 6000"/>
+            </a:avLst>
+          </a:prstGeom>
+          <a:solidFill>
+            <a:srgbClr val="F4F7FA"/>
+          </a:solidFill>
+          <a:ln w="15875">
+            <a:solidFill>
+              <a:srgbClr val="0E63B0"/>
+            </a:solidFill>
+          </a:ln>
+          <a:effectLst/>
+        </p:spPr>
+        <p:style>
+          <a:lnRef idx="1">
+            <a:schemeClr val="accent1"/>
+          </a:lnRef>
+          <a:fillRef idx="3">
+            <a:schemeClr val="accent1"/>
+          </a:fillRef>
+          <a:effectRef idx="2">
+            <a:schemeClr val="accent1"/>
+          </a:effectRef>
+          <a:fontRef idx="minor">
+            <a:schemeClr val="lt1"/>
+          </a:fontRef>
+        </p:style>
+        <p:txBody>
+          <a:bodyPr rtlCol="0" anchor="t" lIns="164592" rIns="164592" tIns="109728" bIns="109728" wrap="square"/>
+          <a:lstStyle/>
+          <a:p>
+            <a:pPr algn="l"/>
+            <a:r>
+              <a:rPr sz="1600" b="1">
+                <a:solidFill>
+                  <a:srgbClr val="0E63B0"/>
+                </a:solidFill>
+                <a:latin typeface="Calibri"/>
+              </a:rPr>
+              <a:t>Finish the validation</a:t>
+            </a:r>
+          </a:p>
+          <a:p>
+            <a:pPr algn="l"/>
+            <a:r>
+              <a:rPr sz="1300" b="0">
+                <a:solidFill>
+                  <a:srgbClr val="1F2933"/>
+                </a:solidFill>
+                <a:latin typeface="Calibri"/>
+              </a:rPr>
+              <a:t>Time to run the Duo sessions on the 5 generated packs and pick the winning prompt</a:t>
+            </a:r>
+          </a:p>
+        </p:txBody>
+      </p:sp>
+      <p:sp>
+        <p:nvSpPr>
+          <p:cNvPr id="5" name="Rounded Rectangle 4"/>
+          <p:cNvSpPr/>
+          <p:nvPr/>
+        </p:nvSpPr>
+        <p:spPr>
+          <a:xfrm>
+            <a:off x="6263640" y="1783080"/>
+            <a:ext cx="5486400" cy="1463040"/>
+          </a:xfrm>
+          <a:prstGeom prst="roundRect">
+            <a:avLst>
+              <a:gd name="adj" fmla="val 6000"/>
+            </a:avLst>
+          </a:prstGeom>
+          <a:solidFill>
+            <a:srgbClr val="F4F7FA"/>
+          </a:solidFill>
+          <a:ln w="15875">
+            <a:solidFill>
+              <a:srgbClr val="0E63B0"/>
+            </a:solidFill>
+          </a:ln>
+          <a:effectLst/>
+        </p:spPr>
+        <p:style>
+          <a:lnRef idx="1">
+            <a:schemeClr val="accent1"/>
+          </a:lnRef>
+          <a:fillRef idx="3">
+            <a:schemeClr val="accent1"/>
+          </a:fillRef>
+          <a:effectRef idx="2">
+            <a:schemeClr val="accent1"/>
+          </a:effectRef>
+          <a:fontRef idx="minor">
+            <a:schemeClr val="lt1"/>
+          </a:fontRef>
+        </p:style>
+        <p:txBody>
+          <a:bodyPr rtlCol="0" anchor="t" lIns="164592" rIns="164592" tIns="109728" bIns="109728" wrap="square"/>
+          <a:lstStyle/>
+          <a:p>
+            <a:pPr algn="l"/>
+            <a:r>
+              <a:rPr sz="1600" b="1">
+                <a:solidFill>
+                  <a:srgbClr val="0E63B0"/>
+                </a:solidFill>
+                <a:latin typeface="Calibri"/>
+              </a:rPr>
+              <a:t>Time-box for licensed devs</a:t>
+            </a:r>
+          </a:p>
+          <a:p>
+            <a:pPr algn="l"/>
+            <a:r>
+              <a:rPr sz="1300" b="0">
+                <a:solidFill>
+                  <a:srgbClr val="1F2933"/>
+                </a:solidFill>
+                <a:latin typeface="Calibri"/>
+              </a:rPr>
+              <a:t>A few hours of Claude Code time to re-run the winner fresh and generate the first real pack</a:t>
+            </a:r>
+          </a:p>
+        </p:txBody>
+      </p:sp>
+      <p:sp>
+        <p:nvSpPr>
+          <p:cNvPr id="6" name="Rounded Rectangle 5"/>
+          <p:cNvSpPr/>
+          <p:nvPr/>
+        </p:nvSpPr>
+        <p:spPr>
+          <a:xfrm>
+            <a:off x="548640" y="3474720"/>
+            <a:ext cx="5486400" cy="1463040"/>
+          </a:xfrm>
+          <a:prstGeom prst="roundRect">
+            <a:avLst>
+              <a:gd name="adj" fmla="val 6000"/>
+            </a:avLst>
+          </a:prstGeom>
+          <a:solidFill>
+            <a:srgbClr val="F4F7FA"/>
+          </a:solidFill>
+          <a:ln w="15875">
+            <a:solidFill>
+              <a:srgbClr val="0E63B0"/>
+            </a:solidFill>
+          </a:ln>
+          <a:effectLst/>
+        </p:spPr>
+        <p:style>
+          <a:lnRef idx="1">
+            <a:schemeClr val="accent1"/>
+          </a:lnRef>
+          <a:fillRef idx="3">
+            <a:schemeClr val="accent1"/>
+          </a:fillRef>
+          <a:effectRef idx="2">
+            <a:schemeClr val="accent1"/>
+          </a:effectRef>
+          <a:fontRef idx="minor">
+            <a:schemeClr val="lt1"/>
+          </a:fontRef>
+        </p:style>
+        <p:txBody>
+          <a:bodyPr rtlCol="0" anchor="t" lIns="164592" rIns="164592" tIns="109728" bIns="109728" wrap="square"/>
+          <a:lstStyle/>
+          <a:p>
+            <a:pPr algn="l"/>
+            <a:r>
+              <a:rPr sz="1600" b="1">
+                <a:solidFill>
+                  <a:srgbClr val="0E63B0"/>
+                </a:solidFill>
+                <a:latin typeface="Calibri"/>
+              </a:rPr>
+              <a:t>Nominate a pilot squad + service</a:t>
+            </a:r>
+          </a:p>
+          <a:p>
+            <a:pPr algn="l"/>
+            <a:r>
+              <a:rPr sz="1300" b="0">
+                <a:solidFill>
+                  <a:srgbClr val="1F2933"/>
+                </a:solidFill>
+                <a:latin typeface="Calibri"/>
+              </a:rPr>
+              <a:t>One delivery squad and 1–2 of its Spring Boot services to pilot with</a:t>
+            </a:r>
+          </a:p>
+        </p:txBody>
+      </p:sp>
+      <p:sp>
+        <p:nvSpPr>
+          <p:cNvPr id="7" name="Rounded Rectangle 6"/>
+          <p:cNvSpPr/>
+          <p:nvPr/>
+        </p:nvSpPr>
+        <p:spPr>
+          <a:xfrm>
+            <a:off x="6263640" y="3474720"/>
+            <a:ext cx="5486400" cy="1463040"/>
+          </a:xfrm>
+          <a:prstGeom prst="roundRect">
+            <a:avLst>
+              <a:gd name="adj" fmla="val 6000"/>
+            </a:avLst>
+          </a:prstGeom>
+          <a:solidFill>
+            <a:srgbClr val="F4F7FA"/>
+          </a:solidFill>
+          <a:ln w="15875">
+            <a:solidFill>
+              <a:srgbClr val="0E63B0"/>
+            </a:solidFill>
+          </a:ln>
+          <a:effectLst/>
+        </p:spPr>
+        <p:style>
+          <a:lnRef idx="1">
+            <a:schemeClr val="accent1"/>
+          </a:lnRef>
+          <a:fillRef idx="3">
+            <a:schemeClr val="accent1"/>
+          </a:fillRef>
+          <a:effectRef idx="2">
+            <a:schemeClr val="accent1"/>
+          </a:effectRef>
+          <a:fontRef idx="minor">
+            <a:schemeClr val="lt1"/>
+          </a:fontRef>
+        </p:style>
+        <p:txBody>
+          <a:bodyPr rtlCol="0" anchor="t" lIns="164592" rIns="164592" tIns="109728" bIns="109728" wrap="square"/>
+          <a:lstStyle/>
+          <a:p>
+            <a:pPr algn="l"/>
+            <a:r>
+              <a:rPr sz="1600" b="1">
+                <a:solidFill>
+                  <a:srgbClr val="0E63B0"/>
+                </a:solidFill>
+                <a:latin typeface="Calibri"/>
+              </a:rPr>
+              <a:t>Squad commitment</a:t>
+            </a:r>
+          </a:p>
+          <a:p>
+            <a:pPr algn="l"/>
+            <a:r>
+              <a:rPr sz="1300" b="0">
+                <a:solidFill>
+                  <a:srgbClr val="1F2933"/>
+                </a:solidFill>
+                <a:latin typeface="Calibri"/>
+              </a:rPr>
+              <a:t>The pilot squad agrees to use the packs on real tasks and give honest feedback</a:t>
+            </a:r>
+          </a:p>
+        </p:txBody>
+      </p:sp>
+      <p:sp>
+        <p:nvSpPr>
+          <p:cNvPr id="8" name="Rounded Rectangle 7"/>
+          <p:cNvSpPr/>
+          <p:nvPr/>
+        </p:nvSpPr>
+        <p:spPr>
+          <a:xfrm>
+            <a:off x="548640" y="5440680"/>
+            <a:ext cx="11201400" cy="914400"/>
+          </a:xfrm>
+          <a:prstGeom prst="roundRect">
+            <a:avLst>
+              <a:gd name="adj" fmla="val 6000"/>
+            </a:avLst>
+          </a:prstGeom>
+          <a:solidFill>
+            <a:srgbClr val="E3EEF8"/>
+          </a:solidFill>
+          <a:ln>
+            <a:noFill/>
+          </a:ln>
+          <a:effectLst/>
+        </p:spPr>
+        <p:style>
+          <a:lnRef idx="1">
+            <a:schemeClr val="accent1"/>
+          </a:lnRef>
+          <a:fillRef idx="3">
+            <a:schemeClr val="accent1"/>
+          </a:fillRef>
+          <a:effectRef idx="2">
+            <a:schemeClr val="accent1"/>
+          </a:effectRef>
+          <a:fontRef idx="minor">
+            <a:schemeClr val="lt1"/>
+          </a:fontRef>
+        </p:style>
+        <p:txBody>
+          <a:bodyPr rtlCol="0" anchor="ctr" lIns="164592" rIns="164592" tIns="109728" bIns="109728" wrap="square"/>
+          <a:lstStyle/>
+          <a:p>
+            <a:pPr algn="l"/>
+            <a:r>
+              <a:rPr sz="1500" b="1">
+                <a:solidFill>
+                  <a:srgbClr val="0A467E"/>
+                </a:solidFill>
+                <a:latin typeface="Calibri"/>
+              </a:rPr>
+              <a:t>If the pilot doesn't prove itself within a few sprints, we stop — the only sunk cost is the validation time, and we keep the generated documentation either way.</a:t>
+            </a:r>
+          </a:p>
+        </p:txBody>
+      </p:sp>
+      <p:sp>
+        <p:nvSpPr>
+          <p:cNvPr id="9" name="TextBox 8"/>
+          <p:cNvSpPr txBox="1"/>
+          <p:nvPr/>
+        </p:nvSpPr>
+        <p:spPr>
+          <a:xfrm>
+            <a:off x="10881360" y="6446520"/>
+            <a:ext cx="1005840" cy="320040"/>
+          </a:xfrm>
+          <a:prstGeom prst="rect">
+            <a:avLst/>
+          </a:prstGeom>
+          <a:noFill/>
+        </p:spPr>
+        <p:txBody>
+          <a:bodyPr wrap="square">
+            <a:spAutoFit/>
+          </a:bodyPr>
+          <a:lstStyle/>
+          <a:p>
+            <a:pPr algn="r"/>
+            <a:r>
+              <a:rPr sz="1100" b="0">
+                <a:solidFill>
+                  <a:srgbClr val="5A6B7A"/>
+                </a:solidFill>
+                <a:latin typeface="Calibri"/>
+              </a:rPr>
+              <a:t>18</a:t>
+            </a:r>
+          </a:p>
+        </p:txBody>
+      </p:sp>
+    </p:spTree>
+  </p:cSld>
+  <p:clrMapOvr>
+    <a:masterClrMapping/>
+  </p:clrMapOvr>
+</p:sld>
+</file>
+
+<file path=ppt/slides/slide19.xml><?xml version="1.0" encoding="utf-8"?>
+<p:sld xmlns:a="http://schemas.openxmlformats.org/drawingml/2006/main" xmlns:p="http://schemas.openxmlformats.org/presentationml/2006/main" xmlns:r="http://schemas.openxmlformats.org/officeDocument/2006/relationships">
+  <p:cSld>
+    <p:spTree>
+      <p:nvGrpSpPr>
+        <p:cNvPr id="1" name=""/>
+        <p:cNvGrpSpPr/>
+        <p:nvPr/>
+      </p:nvGrpSpPr>
+      <p:grpSpPr/>
+      <p:sp>
+        <p:nvSpPr>
+          <p:cNvPr id="2" name="Rectangle 1"/>
+          <p:cNvSpPr/>
+          <p:nvPr/>
+        </p:nvSpPr>
+        <p:spPr>
+          <a:xfrm>
             <a:off x="0" y="0"/>
             <a:ext cx="12191695" cy="6858000"/>
           </a:xfrm>
@@ -7470,7 +7997,7 @@
                 </a:solidFill>
                 <a:latin typeface="Calibri"/>
               </a:rPr>
-              <a:t>•  One spike + one PI pilot tells us if it works — measured, time-boxed, SAFe-friendly.</a:t>
+              <a:t>•  A short pilot with one delivery squad tells us if it works — measured, time-boxed, and it slots into how our squads already operate.</a:t>
             </a:r>
           </a:p>
         </p:txBody>

</xml_diff>